<commit_message>
updated website and docs
</commit_message>
<xml_diff>
--- a/doc/other/asynchrony_for_the_masses.pptx
+++ b/doc/other/asynchrony_for_the_masses.pptx
@@ -217,7 +217,7 @@
           <a:p>
             <a:fld id="{BFF45CA6-BADF-41D0-A504-3A4ACA7D9F3B}" type="datetimeFigureOut">
               <a:rPr lang="en-US" smtClean="0"/>
-              <a:t>11/6/2012</a:t>
+              <a:t>3/12/2014</a:t>
             </a:fld>
             <a:endParaRPr lang="en-US"/>
           </a:p>
@@ -481,7 +481,7 @@
           <a:p>
             <a:fld id="{46B3899D-533A-4EC5-AA14-1D14BFCE068B}" type="datetimeFigureOut">
               <a:rPr lang="en-US" smtClean="0"/>
-              <a:t>11/6/2012</a:t>
+              <a:t>3/12/2014</a:t>
             </a:fld>
             <a:endParaRPr lang="en-US"/>
           </a:p>
@@ -651,7 +651,7 @@
           <a:p>
             <a:fld id="{46B3899D-533A-4EC5-AA14-1D14BFCE068B}" type="datetimeFigureOut">
               <a:rPr lang="en-US" smtClean="0"/>
-              <a:t>11/6/2012</a:t>
+              <a:t>3/12/2014</a:t>
             </a:fld>
             <a:endParaRPr lang="en-US"/>
           </a:p>
@@ -831,7 +831,7 @@
           <a:p>
             <a:fld id="{46B3899D-533A-4EC5-AA14-1D14BFCE068B}" type="datetimeFigureOut">
               <a:rPr lang="en-US" smtClean="0"/>
-              <a:t>11/6/2012</a:t>
+              <a:t>3/12/2014</a:t>
             </a:fld>
             <a:endParaRPr lang="en-US"/>
           </a:p>
@@ -1001,7 +1001,7 @@
           <a:p>
             <a:fld id="{46B3899D-533A-4EC5-AA14-1D14BFCE068B}" type="datetimeFigureOut">
               <a:rPr lang="en-US" smtClean="0"/>
-              <a:t>11/6/2012</a:t>
+              <a:t>3/12/2014</a:t>
             </a:fld>
             <a:endParaRPr lang="en-US"/>
           </a:p>
@@ -1247,7 +1247,7 @@
           <a:p>
             <a:fld id="{46B3899D-533A-4EC5-AA14-1D14BFCE068B}" type="datetimeFigureOut">
               <a:rPr lang="en-US" smtClean="0"/>
-              <a:t>11/6/2012</a:t>
+              <a:t>3/12/2014</a:t>
             </a:fld>
             <a:endParaRPr lang="en-US"/>
           </a:p>
@@ -1535,7 +1535,7 @@
           <a:p>
             <a:fld id="{46B3899D-533A-4EC5-AA14-1D14BFCE068B}" type="datetimeFigureOut">
               <a:rPr lang="en-US" smtClean="0"/>
-              <a:t>11/6/2012</a:t>
+              <a:t>3/12/2014</a:t>
             </a:fld>
             <a:endParaRPr lang="en-US"/>
           </a:p>
@@ -1957,7 +1957,7 @@
           <a:p>
             <a:fld id="{46B3899D-533A-4EC5-AA14-1D14BFCE068B}" type="datetimeFigureOut">
               <a:rPr lang="en-US" smtClean="0"/>
-              <a:t>11/6/2012</a:t>
+              <a:t>3/12/2014</a:t>
             </a:fld>
             <a:endParaRPr lang="en-US"/>
           </a:p>
@@ -2075,7 +2075,7 @@
           <a:p>
             <a:fld id="{46B3899D-533A-4EC5-AA14-1D14BFCE068B}" type="datetimeFigureOut">
               <a:rPr lang="en-US" smtClean="0"/>
-              <a:t>11/6/2012</a:t>
+              <a:t>3/12/2014</a:t>
             </a:fld>
             <a:endParaRPr lang="en-US"/>
           </a:p>
@@ -2170,7 +2170,7 @@
           <a:p>
             <a:fld id="{46B3899D-533A-4EC5-AA14-1D14BFCE068B}" type="datetimeFigureOut">
               <a:rPr lang="en-US" smtClean="0"/>
-              <a:t>11/6/2012</a:t>
+              <a:t>3/12/2014</a:t>
             </a:fld>
             <a:endParaRPr lang="en-US"/>
           </a:p>
@@ -2447,7 +2447,7 @@
           <a:p>
             <a:fld id="{46B3899D-533A-4EC5-AA14-1D14BFCE068B}" type="datetimeFigureOut">
               <a:rPr lang="en-US" smtClean="0"/>
-              <a:t>11/6/2012</a:t>
+              <a:t>3/12/2014</a:t>
             </a:fld>
             <a:endParaRPr lang="en-US"/>
           </a:p>
@@ -2700,7 +2700,7 @@
           <a:p>
             <a:fld id="{46B3899D-533A-4EC5-AA14-1D14BFCE068B}" type="datetimeFigureOut">
               <a:rPr lang="en-US" smtClean="0"/>
-              <a:t>11/6/2012</a:t>
+              <a:t>3/12/2014</a:t>
             </a:fld>
             <a:endParaRPr lang="en-US"/>
           </a:p>
@@ -2913,7 +2913,7 @@
           <a:p>
             <a:fld id="{46B3899D-533A-4EC5-AA14-1D14BFCE068B}" type="datetimeFigureOut">
               <a:rPr lang="en-US" smtClean="0"/>
-              <a:t>11/6/2012</a:t>
+              <a:t>3/12/2014</a:t>
             </a:fld>
             <a:endParaRPr lang="en-US"/>
           </a:p>
@@ -4015,25 +4015,32 @@
               <a:t>(</a:t>
             </a:r>
             <a:r>
+              <a:rPr lang="en-US" sz="1500" dirty="0" smtClean="0">
+                <a:latin typeface="Courier New" pitchFamily="49" charset="0"/>
+                <a:cs typeface="Courier New" pitchFamily="49" charset="0"/>
+              </a:rPr>
+              <a:t>Pt::System</a:t>
+            </a:r>
+            <a:r>
+              <a:rPr lang="en-US" sz="1500" dirty="0" smtClean="0">
+                <a:latin typeface="Courier New" pitchFamily="49" charset="0"/>
+                <a:cs typeface="Courier New" pitchFamily="49" charset="0"/>
+              </a:rPr>
+              <a:t>::</a:t>
+            </a:r>
+            <a:r>
               <a:rPr lang="en-US" sz="1500" dirty="0" err="1" smtClean="0">
                 <a:latin typeface="Courier New" pitchFamily="49" charset="0"/>
                 <a:cs typeface="Courier New" pitchFamily="49" charset="0"/>
               </a:rPr>
-              <a:t>Pt</a:t>
-            </a:r>
-            <a:r>
-              <a:rPr lang="en-US" sz="1500" dirty="0" smtClean="0">
-                <a:latin typeface="Courier New" pitchFamily="49" charset="0"/>
-                <a:cs typeface="Courier New" pitchFamily="49" charset="0"/>
-              </a:rPr>
-              <a:t>::System::</a:t>
+              <a:t>IO</a:t>
             </a:r>
             <a:r>
               <a:rPr lang="en-US" sz="1500" dirty="0" err="1" smtClean="0">
                 <a:latin typeface="Courier New" pitchFamily="49" charset="0"/>
                 <a:cs typeface="Courier New" pitchFamily="49" charset="0"/>
               </a:rPr>
-              <a:t>StreamBuffer</a:t>
+              <a:t>Buffer</a:t>
             </a:r>
             <a:r>
               <a:rPr lang="en-US" sz="1500" dirty="0" smtClean="0">
@@ -4622,8 +4629,19 @@
                 <a:latin typeface="Courier New" pitchFamily="49" charset="0"/>
                 <a:cs typeface="Courier New" pitchFamily="49" charset="0"/>
               </a:rPr>
-              <a:t>    Pt::System::Pipe pipe(Pt::System::Pipe::Async);</a:t>
-            </a:r>
+              <a:t>    Pt::System::Pipe </a:t>
+            </a:r>
+            <a:r>
+              <a:rPr lang="nb-NO" sz="1500" dirty="0" smtClean="0">
+                <a:latin typeface="Courier New" pitchFamily="49" charset="0"/>
+                <a:cs typeface="Courier New" pitchFamily="49" charset="0"/>
+              </a:rPr>
+              <a:t>pipe;</a:t>
+            </a:r>
+            <a:endParaRPr lang="nb-NO" sz="1500" dirty="0" smtClean="0">
+              <a:latin typeface="Courier New" pitchFamily="49" charset="0"/>
+              <a:cs typeface="Courier New" pitchFamily="49" charset="0"/>
+            </a:endParaRPr>
           </a:p>
           <a:p>
             <a:pPr marL="0" indent="0">
@@ -4636,72 +4654,134 @@
               </a:rPr>
               <a:t>	</a:t>
             </a:r>
+            <a:endParaRPr lang="en-US" sz="1500" dirty="0" smtClean="0">
+              <a:latin typeface="Courier New" pitchFamily="49" charset="0"/>
+              <a:cs typeface="Courier New" pitchFamily="49" charset="0"/>
+            </a:endParaRPr>
           </a:p>
           <a:p>
             <a:pPr marL="0" indent="0">
               <a:buNone/>
             </a:pPr>
             <a:r>
+              <a:rPr lang="de-DE" sz="1500" dirty="0" smtClean="0">
+                <a:latin typeface="Courier New" pitchFamily="49" charset="0"/>
+                <a:cs typeface="Courier New" pitchFamily="49" charset="0"/>
+              </a:rPr>
+              <a:t>    </a:t>
+            </a:r>
+            <a:r>
+              <a:rPr lang="de-DE" sz="1500" dirty="0" err="1" smtClean="0">
+                <a:latin typeface="Courier New" pitchFamily="49" charset="0"/>
+                <a:cs typeface="Courier New" pitchFamily="49" charset="0"/>
+              </a:rPr>
+              <a:t>pipe.out</a:t>
+            </a:r>
+            <a:r>
+              <a:rPr lang="de-DE" sz="1500" dirty="0" smtClean="0">
+                <a:latin typeface="Courier New" pitchFamily="49" charset="0"/>
+                <a:cs typeface="Courier New" pitchFamily="49" charset="0"/>
+              </a:rPr>
+              <a:t>().</a:t>
+            </a:r>
+            <a:r>
+              <a:rPr lang="de-DE" sz="1500" dirty="0" err="1" smtClean="0">
+                <a:latin typeface="Courier New" pitchFamily="49" charset="0"/>
+                <a:cs typeface="Courier New" pitchFamily="49" charset="0"/>
+              </a:rPr>
+              <a:t>setActive</a:t>
+            </a:r>
+            <a:r>
+              <a:rPr lang="de-DE" sz="1500" dirty="0" smtClean="0">
+                <a:latin typeface="Courier New" pitchFamily="49" charset="0"/>
+                <a:cs typeface="Courier New" pitchFamily="49" charset="0"/>
+              </a:rPr>
+              <a:t>(</a:t>
+            </a:r>
+            <a:r>
+              <a:rPr lang="de-DE" sz="1500" dirty="0" err="1" smtClean="0">
+                <a:latin typeface="Courier New" pitchFamily="49" charset="0"/>
+                <a:cs typeface="Courier New" pitchFamily="49" charset="0"/>
+              </a:rPr>
+              <a:t>loop</a:t>
+            </a:r>
+            <a:r>
+              <a:rPr lang="de-DE" sz="1500" dirty="0" smtClean="0">
+                <a:latin typeface="Courier New" pitchFamily="49" charset="0"/>
+                <a:cs typeface="Courier New" pitchFamily="49" charset="0"/>
+              </a:rPr>
+              <a:t>);</a:t>
+            </a:r>
+            <a:endParaRPr lang="en-US" sz="1500" dirty="0" smtClean="0">
+              <a:latin typeface="Courier New" pitchFamily="49" charset="0"/>
+              <a:cs typeface="Courier New" pitchFamily="49" charset="0"/>
+            </a:endParaRPr>
+          </a:p>
+          <a:p>
+            <a:pPr marL="0" indent="0">
+              <a:buNone/>
+            </a:pPr>
+            <a:r>
               <a:rPr lang="en-US" sz="1500" dirty="0" smtClean="0">
                 <a:latin typeface="Courier New" pitchFamily="49" charset="0"/>
                 <a:cs typeface="Courier New" pitchFamily="49" charset="0"/>
               </a:rPr>
-              <a:t>    </a:t>
+              <a:t>    Pt::System</a:t>
+            </a:r>
+            <a:r>
+              <a:rPr lang="en-US" sz="1500" dirty="0" smtClean="0">
+                <a:latin typeface="Courier New" pitchFamily="49" charset="0"/>
+                <a:cs typeface="Courier New" pitchFamily="49" charset="0"/>
+              </a:rPr>
+              <a:t>::</a:t>
             </a:r>
             <a:r>
               <a:rPr lang="en-US" sz="1500" dirty="0" err="1" smtClean="0">
                 <a:latin typeface="Courier New" pitchFamily="49" charset="0"/>
                 <a:cs typeface="Courier New" pitchFamily="49" charset="0"/>
               </a:rPr>
-              <a:t>Pt</a:t>
+              <a:t>IO</a:t>
+            </a:r>
+            <a:r>
+              <a:rPr lang="en-US" sz="1500" dirty="0" err="1" smtClean="0">
+                <a:latin typeface="Courier New" pitchFamily="49" charset="0"/>
+                <a:cs typeface="Courier New" pitchFamily="49" charset="0"/>
+              </a:rPr>
+              <a:t>Buffer</a:t>
             </a:r>
             <a:r>
               <a:rPr lang="en-US" sz="1500" dirty="0" smtClean="0">
                 <a:latin typeface="Courier New" pitchFamily="49" charset="0"/>
                 <a:cs typeface="Courier New" pitchFamily="49" charset="0"/>
               </a:rPr>
-              <a:t>::System::</a:t>
+              <a:t> </a:t>
             </a:r>
             <a:r>
               <a:rPr lang="en-US" sz="1500" dirty="0" err="1" smtClean="0">
                 <a:latin typeface="Courier New" pitchFamily="49" charset="0"/>
                 <a:cs typeface="Courier New" pitchFamily="49" charset="0"/>
               </a:rPr>
-              <a:t>StreamBuffer</a:t>
+              <a:t>sb</a:t>
             </a:r>
             <a:r>
               <a:rPr lang="en-US" sz="1500" dirty="0" smtClean="0">
                 <a:latin typeface="Courier New" pitchFamily="49" charset="0"/>
                 <a:cs typeface="Courier New" pitchFamily="49" charset="0"/>
               </a:rPr>
-              <a:t> </a:t>
+              <a:t>(</a:t>
             </a:r>
             <a:r>
               <a:rPr lang="en-US" sz="1500" dirty="0" err="1" smtClean="0">
                 <a:latin typeface="Courier New" pitchFamily="49" charset="0"/>
                 <a:cs typeface="Courier New" pitchFamily="49" charset="0"/>
               </a:rPr>
-              <a:t>sb</a:t>
+              <a:t>pipe.out</a:t>
             </a:r>
             <a:r>
               <a:rPr lang="en-US" sz="1500" dirty="0" smtClean="0">
                 <a:latin typeface="Courier New" pitchFamily="49" charset="0"/>
                 <a:cs typeface="Courier New" pitchFamily="49" charset="0"/>
               </a:rPr>
-              <a:t>(</a:t>
-            </a:r>
-            <a:r>
-              <a:rPr lang="en-US" sz="1500" dirty="0" err="1" smtClean="0">
-                <a:latin typeface="Courier New" pitchFamily="49" charset="0"/>
-                <a:cs typeface="Courier New" pitchFamily="49" charset="0"/>
-              </a:rPr>
-              <a:t>pipe.out</a:t>
-            </a:r>
-            <a:r>
-              <a:rPr lang="en-US" sz="1500" dirty="0" smtClean="0">
-                <a:latin typeface="Courier New" pitchFamily="49" charset="0"/>
-                <a:cs typeface="Courier New" pitchFamily="49" charset="0"/>
-              </a:rPr>
               <a:t>());</a:t>
             </a:r>
           </a:p>
@@ -4735,7 +4815,14 @@
                 <a:latin typeface="Courier New" pitchFamily="49" charset="0"/>
                 <a:cs typeface="Courier New" pitchFamily="49" charset="0"/>
               </a:rPr>
-              <a:t> += Pt::</a:t>
+              <a:t>() </a:t>
+            </a:r>
+            <a:r>
+              <a:rPr lang="de-DE" sz="1500" dirty="0" smtClean="0">
+                <a:latin typeface="Courier New" pitchFamily="49" charset="0"/>
+                <a:cs typeface="Courier New" pitchFamily="49" charset="0"/>
+              </a:rPr>
+              <a:t>+= Pt::</a:t>
             </a:r>
             <a:r>
               <a:rPr lang="de-DE" sz="1500" dirty="0" err="1" smtClean="0">
@@ -4808,46 +4895,6 @@
               <a:latin typeface="Courier New" pitchFamily="49" charset="0"/>
               <a:cs typeface="Courier New" pitchFamily="49" charset="0"/>
             </a:endParaRPr>
-          </a:p>
-          <a:p>
-            <a:pPr marL="0" indent="0">
-              <a:buNone/>
-            </a:pPr>
-            <a:r>
-              <a:rPr lang="de-DE" sz="1500" dirty="0" smtClean="0">
-                <a:latin typeface="Courier New" pitchFamily="49" charset="0"/>
-                <a:cs typeface="Courier New" pitchFamily="49" charset="0"/>
-              </a:rPr>
-              <a:t>    </a:t>
-            </a:r>
-            <a:r>
-              <a:rPr lang="de-DE" sz="1500" dirty="0" err="1" smtClean="0">
-                <a:latin typeface="Courier New" pitchFamily="49" charset="0"/>
-                <a:cs typeface="Courier New" pitchFamily="49" charset="0"/>
-              </a:rPr>
-              <a:t>loop.add</a:t>
-            </a:r>
-            <a:r>
-              <a:rPr lang="de-DE" sz="1500" dirty="0" smtClean="0">
-                <a:latin typeface="Courier New" pitchFamily="49" charset="0"/>
-                <a:cs typeface="Courier New" pitchFamily="49" charset="0"/>
-              </a:rPr>
-              <a:t>(</a:t>
-            </a:r>
-            <a:r>
-              <a:rPr lang="de-DE" sz="1500" dirty="0" err="1" smtClean="0">
-                <a:latin typeface="Courier New" pitchFamily="49" charset="0"/>
-                <a:cs typeface="Courier New" pitchFamily="49" charset="0"/>
-              </a:rPr>
-              <a:t>pipe.out</a:t>
-            </a:r>
-            <a:r>
-              <a:rPr lang="de-DE" sz="1500" dirty="0" smtClean="0">
-                <a:latin typeface="Courier New" pitchFamily="49" charset="0"/>
-                <a:cs typeface="Courier New" pitchFamily="49" charset="0"/>
-              </a:rPr>
-              <a:t>());</a:t>
-            </a:r>
           </a:p>
           <a:p>
             <a:pPr marL="0" indent="0">
@@ -5260,7 +5307,13 @@
               <a:rPr lang="de-DE" sz="1300" dirty="0" err="1" smtClean="0">
                 <a:cs typeface="Courier New" pitchFamily="49" charset="0"/>
               </a:rPr>
-              <a:t>StreamBuffer</a:t>
+              <a:t>IO</a:t>
+            </a:r>
+            <a:r>
+              <a:rPr lang="de-DE" sz="1300" dirty="0" err="1" smtClean="0">
+                <a:cs typeface="Courier New" pitchFamily="49" charset="0"/>
+              </a:rPr>
+              <a:t>Buffer</a:t>
             </a:r>
             <a:r>
               <a:rPr lang="de-DE" sz="1300" dirty="0" smtClean="0">
@@ -6023,7 +6076,7 @@
               <a:rPr lang="de-DE" sz="1300" dirty="0" err="1" smtClean="0">
                 <a:cs typeface="Courier New" pitchFamily="49" charset="0"/>
               </a:rPr>
-              <a:t>sstem</a:t>
+              <a:t>system</a:t>
             </a:r>
             <a:r>
               <a:rPr lang="de-DE" sz="1300" dirty="0" smtClean="0">
@@ -6234,25 +6287,32 @@
               <a:t>(</a:t>
             </a:r>
             <a:r>
+              <a:rPr lang="en-US" sz="1400" dirty="0" smtClean="0">
+                <a:latin typeface="Courier New" pitchFamily="49" charset="0"/>
+                <a:cs typeface="Courier New" pitchFamily="49" charset="0"/>
+              </a:rPr>
+              <a:t>Pt::System</a:t>
+            </a:r>
+            <a:r>
+              <a:rPr lang="en-US" sz="1400" dirty="0" smtClean="0">
+                <a:latin typeface="Courier New" pitchFamily="49" charset="0"/>
+                <a:cs typeface="Courier New" pitchFamily="49" charset="0"/>
+              </a:rPr>
+              <a:t>::</a:t>
+            </a:r>
+            <a:r>
               <a:rPr lang="en-US" sz="1400" dirty="0" err="1" smtClean="0">
                 <a:latin typeface="Courier New" pitchFamily="49" charset="0"/>
                 <a:cs typeface="Courier New" pitchFamily="49" charset="0"/>
               </a:rPr>
-              <a:t>Pt</a:t>
-            </a:r>
-            <a:r>
-              <a:rPr lang="en-US" sz="1400" dirty="0" smtClean="0">
-                <a:latin typeface="Courier New" pitchFamily="49" charset="0"/>
-                <a:cs typeface="Courier New" pitchFamily="49" charset="0"/>
-              </a:rPr>
-              <a:t>::System::</a:t>
+              <a:t>IO</a:t>
             </a:r>
             <a:r>
               <a:rPr lang="en-US" sz="1400" dirty="0" err="1" smtClean="0">
                 <a:latin typeface="Courier New" pitchFamily="49" charset="0"/>
                 <a:cs typeface="Courier New" pitchFamily="49" charset="0"/>
               </a:rPr>
-              <a:t>StreamBuffer</a:t>
+              <a:t>Buffer</a:t>
             </a:r>
             <a:r>
               <a:rPr lang="en-US" sz="1400" dirty="0" smtClean="0">
@@ -7043,7 +7103,13 @@
               <a:rPr lang="de-DE" sz="1300" dirty="0" err="1" smtClean="0">
                 <a:cs typeface="Courier New" pitchFamily="49" charset="0"/>
               </a:rPr>
-              <a:t>StreamBuffer</a:t>
+              <a:t>IO</a:t>
+            </a:r>
+            <a:r>
+              <a:rPr lang="de-DE" sz="1300" dirty="0" err="1" smtClean="0">
+                <a:cs typeface="Courier New" pitchFamily="49" charset="0"/>
+              </a:rPr>
+              <a:t>Buffer</a:t>
             </a:r>
             <a:r>
               <a:rPr lang="de-DE" sz="1300" dirty="0" smtClean="0">
@@ -7067,7 +7133,13 @@
               <a:rPr lang="de-DE" sz="1300" dirty="0" err="1" smtClean="0">
                 <a:cs typeface="Courier New" pitchFamily="49" charset="0"/>
               </a:rPr>
-              <a:t>StreamBuffer</a:t>
+              <a:t>IO</a:t>
+            </a:r>
+            <a:r>
+              <a:rPr lang="de-DE" sz="1300" dirty="0" err="1" smtClean="0">
+                <a:cs typeface="Courier New" pitchFamily="49" charset="0"/>
+              </a:rPr>
+              <a:t>Buffer</a:t>
             </a:r>
             <a:r>
               <a:rPr lang="de-DE" sz="1300" dirty="0" smtClean="0">
@@ -7738,7 +7810,7 @@
             </a:r>
             <a:r>
               <a:rPr lang="de-DE" dirty="0" err="1" smtClean="0"/>
-              <a:t>Streambuffer</a:t>
+              <a:t>IOBuffer</a:t>
             </a:r>
             <a:endParaRPr lang="en-US" dirty="0"/>
           </a:p>
@@ -10351,6 +10423,85 @@
               <a:buNone/>
             </a:pPr>
             <a:r>
+              <a:rPr lang="de-DE" sz="1300" dirty="0">
+                <a:latin typeface="Courier New" pitchFamily="49" charset="0"/>
+                <a:cs typeface="Courier New" pitchFamily="49" charset="0"/>
+              </a:rPr>
+              <a:t> </a:t>
+            </a:r>
+            <a:r>
+              <a:rPr lang="de-DE" sz="1300" dirty="0" smtClean="0">
+                <a:latin typeface="Courier New" pitchFamily="49" charset="0"/>
+                <a:cs typeface="Courier New" pitchFamily="49" charset="0"/>
+              </a:rPr>
+              <a:t>   </a:t>
+            </a:r>
+            <a:r>
+              <a:rPr lang="de-DE" sz="1300" dirty="0" err="1">
+                <a:latin typeface="Courier New" pitchFamily="49" charset="0"/>
+                <a:cs typeface="Courier New" pitchFamily="49" charset="0"/>
+              </a:rPr>
+              <a:t>app.loop</a:t>
+            </a:r>
+            <a:r>
+              <a:rPr lang="de-DE" sz="1300" dirty="0">
+                <a:latin typeface="Courier New" pitchFamily="49" charset="0"/>
+                <a:cs typeface="Courier New" pitchFamily="49" charset="0"/>
+              </a:rPr>
+              <a:t>().</a:t>
+            </a:r>
+            <a:r>
+              <a:rPr lang="de-DE" sz="1300" dirty="0" err="1">
+                <a:latin typeface="Courier New" pitchFamily="49" charset="0"/>
+                <a:cs typeface="Courier New" pitchFamily="49" charset="0"/>
+              </a:rPr>
+              <a:t>eventReceived</a:t>
+            </a:r>
+            <a:r>
+              <a:rPr lang="de-DE" sz="1300" dirty="0">
+                <a:latin typeface="Courier New" pitchFamily="49" charset="0"/>
+                <a:cs typeface="Courier New" pitchFamily="49" charset="0"/>
+              </a:rPr>
+              <a:t>() += Pt::</a:t>
+            </a:r>
+            <a:r>
+              <a:rPr lang="de-DE" sz="1300" dirty="0" err="1">
+                <a:latin typeface="Courier New" pitchFamily="49" charset="0"/>
+                <a:cs typeface="Courier New" pitchFamily="49" charset="0"/>
+              </a:rPr>
+              <a:t>slot</a:t>
+            </a:r>
+            <a:r>
+              <a:rPr lang="de-DE" sz="1300" dirty="0">
+                <a:latin typeface="Courier New" pitchFamily="49" charset="0"/>
+                <a:cs typeface="Courier New" pitchFamily="49" charset="0"/>
+              </a:rPr>
+              <a:t>(&amp;</a:t>
+            </a:r>
+            <a:r>
+              <a:rPr lang="de-DE" sz="1300" dirty="0" err="1">
+                <a:latin typeface="Courier New" pitchFamily="49" charset="0"/>
+                <a:cs typeface="Courier New" pitchFamily="49" charset="0"/>
+              </a:rPr>
+              <a:t>onExitEvent</a:t>
+            </a:r>
+            <a:r>
+              <a:rPr lang="de-DE" sz="1300" dirty="0" smtClean="0">
+                <a:latin typeface="Courier New" pitchFamily="49" charset="0"/>
+                <a:cs typeface="Courier New" pitchFamily="49" charset="0"/>
+              </a:rPr>
+              <a:t>);</a:t>
+            </a:r>
+            <a:endParaRPr lang="de-DE" sz="1300" dirty="0" smtClean="0">
+              <a:latin typeface="Courier New" pitchFamily="49" charset="0"/>
+              <a:cs typeface="Courier New" pitchFamily="49" charset="0"/>
+            </a:endParaRPr>
+          </a:p>
+          <a:p>
+            <a:pPr marL="0" indent="0">
+              <a:buNone/>
+            </a:pPr>
+            <a:r>
               <a:rPr lang="de-DE" sz="1300" dirty="0" smtClean="0">
                 <a:latin typeface="Courier New" pitchFamily="49" charset="0"/>
                 <a:cs typeface="Courier New" pitchFamily="49" charset="0"/>
@@ -10474,74 +10625,6 @@
               <a:latin typeface="Courier New" pitchFamily="49" charset="0"/>
               <a:cs typeface="Courier New" pitchFamily="49" charset="0"/>
             </a:endParaRPr>
-          </a:p>
-          <a:p>
-            <a:pPr marL="0" indent="0">
-              <a:buNone/>
-            </a:pPr>
-            <a:r>
-              <a:rPr lang="de-DE" sz="1300" dirty="0" smtClean="0">
-                <a:latin typeface="Courier New" pitchFamily="49" charset="0"/>
-                <a:cs typeface="Courier New" pitchFamily="49" charset="0"/>
-              </a:rPr>
-              <a:t>    </a:t>
-            </a:r>
-            <a:r>
-              <a:rPr lang="de-DE" sz="1300" dirty="0" err="1" smtClean="0">
-                <a:latin typeface="Courier New" pitchFamily="49" charset="0"/>
-                <a:cs typeface="Courier New" pitchFamily="49" charset="0"/>
-              </a:rPr>
-              <a:t>app.loop</a:t>
-            </a:r>
-            <a:r>
-              <a:rPr lang="de-DE" sz="1300" dirty="0" smtClean="0">
-                <a:latin typeface="Courier New" pitchFamily="49" charset="0"/>
-                <a:cs typeface="Courier New" pitchFamily="49" charset="0"/>
-              </a:rPr>
-              <a:t>().</a:t>
-            </a:r>
-            <a:r>
-              <a:rPr lang="de-DE" sz="1300" dirty="0" err="1" smtClean="0">
-                <a:latin typeface="Courier New" pitchFamily="49" charset="0"/>
-                <a:cs typeface="Courier New" pitchFamily="49" charset="0"/>
-              </a:rPr>
-              <a:t>event</a:t>
-            </a:r>
-            <a:r>
-              <a:rPr lang="de-DE" sz="1300" dirty="0" smtClean="0">
-                <a:latin typeface="Courier New" pitchFamily="49" charset="0"/>
-                <a:cs typeface="Courier New" pitchFamily="49" charset="0"/>
-              </a:rPr>
-              <a:t> += Pt::</a:t>
-            </a:r>
-            <a:r>
-              <a:rPr lang="de-DE" sz="1300" dirty="0" err="1" smtClean="0">
-                <a:latin typeface="Courier New" pitchFamily="49" charset="0"/>
-                <a:cs typeface="Courier New" pitchFamily="49" charset="0"/>
-              </a:rPr>
-              <a:t>slot</a:t>
-            </a:r>
-            <a:r>
-              <a:rPr lang="de-DE" sz="1300" dirty="0" smtClean="0">
-                <a:latin typeface="Courier New" pitchFamily="49" charset="0"/>
-                <a:cs typeface="Courier New" pitchFamily="49" charset="0"/>
-              </a:rPr>
-              <a:t>(&amp;</a:t>
-            </a:r>
-            <a:r>
-              <a:rPr lang="de-DE" sz="1300" dirty="0" err="1" smtClean="0">
-                <a:latin typeface="Courier New" pitchFamily="49" charset="0"/>
-                <a:cs typeface="Courier New" pitchFamily="49" charset="0"/>
-              </a:rPr>
-              <a:t>onExitEvent</a:t>
-            </a:r>
-            <a:r>
-              <a:rPr lang="de-DE" sz="1300" dirty="0" smtClean="0">
-                <a:latin typeface="Courier New" pitchFamily="49" charset="0"/>
-                <a:cs typeface="Courier New" pitchFamily="49" charset="0"/>
-              </a:rPr>
-              <a:t>);</a:t>
-            </a:r>
           </a:p>
           <a:p>
             <a:pPr marL="0" indent="0">
@@ -10822,7 +10905,19 @@
               <a:rPr lang="de-DE" sz="1300" dirty="0" smtClean="0">
                 <a:cs typeface="Courier New" pitchFamily="49" charset="0"/>
               </a:rPr>
-              <a:t> Events </a:t>
+              <a:t> </a:t>
+            </a:r>
+            <a:r>
+              <a:rPr lang="de-DE" sz="1300" dirty="0" err="1" smtClean="0">
+                <a:cs typeface="Courier New" pitchFamily="49" charset="0"/>
+              </a:rPr>
+              <a:t>events</a:t>
+            </a:r>
+            <a:r>
+              <a:rPr lang="de-DE" sz="1300" dirty="0" smtClean="0">
+                <a:cs typeface="Courier New" pitchFamily="49" charset="0"/>
+              </a:rPr>
+              <a:t> </a:t>
             </a:r>
             <a:r>
               <a:rPr lang="de-DE" sz="1300" dirty="0" err="1" smtClean="0">
@@ -11330,14 +11425,21 @@
                 <a:latin typeface="Courier New" pitchFamily="49" charset="0"/>
                 <a:cs typeface="Courier New" pitchFamily="49" charset="0"/>
               </a:rPr>
-              <a:t>event</a:t>
-            </a:r>
-            <a:r>
-              <a:rPr lang="de-DE" sz="1300" dirty="0" smtClean="0">
-                <a:latin typeface="Courier New" pitchFamily="49" charset="0"/>
-                <a:cs typeface="Courier New" pitchFamily="49" charset="0"/>
-              </a:rPr>
-              <a:t> += Pt::</a:t>
+              <a:t>eventReceived</a:t>
+            </a:r>
+            <a:r>
+              <a:rPr lang="de-DE" sz="1300" dirty="0" smtClean="0">
+                <a:latin typeface="Courier New" pitchFamily="49" charset="0"/>
+                <a:cs typeface="Courier New" pitchFamily="49" charset="0"/>
+              </a:rPr>
+              <a:t>() </a:t>
+            </a:r>
+            <a:r>
+              <a:rPr lang="de-DE" sz="1300" dirty="0" smtClean="0">
+                <a:latin typeface="Courier New" pitchFamily="49" charset="0"/>
+                <a:cs typeface="Courier New" pitchFamily="49" charset="0"/>
+              </a:rPr>
+              <a:t>+= Pt::</a:t>
             </a:r>
             <a:r>
               <a:rPr lang="de-DE" sz="1300" dirty="0" err="1" smtClean="0">
@@ -17856,11 +17958,7 @@
             </a:r>
             <a:r>
               <a:rPr lang="de-DE" sz="2800" dirty="0" smtClean="0"/>
-              <a:t> </a:t>
-            </a:r>
-            <a:r>
-              <a:rPr lang="de-DE" sz="2800" dirty="0" smtClean="0"/>
-              <a:t>XML-RPC </a:t>
+              <a:t> XML-RPC </a:t>
             </a:r>
             <a:r>
               <a:rPr lang="de-DE" sz="2800" dirty="0"/>
@@ -18758,12 +18856,112 @@
             <a:pPr marL="0" indent="0">
               <a:buNone/>
             </a:pPr>
+            <a:endParaRPr lang="de-DE" sz="1600" dirty="0">
+              <a:latin typeface="Courier New" pitchFamily="49" charset="0"/>
+              <a:cs typeface="Courier New" pitchFamily="49" charset="0"/>
+            </a:endParaRPr>
+          </a:p>
+          <a:p>
+            <a:pPr marL="0" indent="0">
+              <a:buNone/>
+            </a:pPr>
+            <a:r>
+              <a:rPr lang="de-DE" sz="1600" dirty="0" smtClean="0">
+                <a:latin typeface="Courier New" pitchFamily="49" charset="0"/>
+                <a:cs typeface="Courier New" pitchFamily="49" charset="0"/>
+              </a:rPr>
+              <a:t>    Pt::Net::</a:t>
+            </a:r>
+            <a:r>
+              <a:rPr lang="de-DE" sz="1600" dirty="0" err="1">
+                <a:latin typeface="Courier New" pitchFamily="49" charset="0"/>
+                <a:cs typeface="Courier New" pitchFamily="49" charset="0"/>
+              </a:rPr>
+              <a:t>E</a:t>
+            </a:r>
+            <a:r>
+              <a:rPr lang="de-DE" sz="1600" dirty="0" err="1" smtClean="0">
+                <a:latin typeface="Courier New" pitchFamily="49" charset="0"/>
+                <a:cs typeface="Courier New" pitchFamily="49" charset="0"/>
+              </a:rPr>
+              <a:t>ndpoint</a:t>
+            </a:r>
+            <a:r>
+              <a:rPr lang="de-DE" sz="1600" dirty="0" smtClean="0">
+                <a:latin typeface="Courier New" pitchFamily="49" charset="0"/>
+                <a:cs typeface="Courier New" pitchFamily="49" charset="0"/>
+              </a:rPr>
+              <a:t> </a:t>
+            </a:r>
+            <a:r>
+              <a:rPr lang="de-DE" sz="1600" dirty="0" err="1" smtClean="0">
+                <a:latin typeface="Courier New" pitchFamily="49" charset="0"/>
+                <a:cs typeface="Courier New" pitchFamily="49" charset="0"/>
+              </a:rPr>
+              <a:t>ep</a:t>
+            </a:r>
+            <a:r>
+              <a:rPr lang="de-DE" sz="1600" dirty="0" smtClean="0">
+                <a:latin typeface="Courier New" pitchFamily="49" charset="0"/>
+                <a:cs typeface="Courier New" pitchFamily="49" charset="0"/>
+              </a:rPr>
+              <a:t>(</a:t>
+            </a:r>
+            <a:r>
+              <a:rPr lang="de-DE" sz="1600" dirty="0">
+                <a:solidFill>
+                  <a:schemeClr val="accent2">
+                    <a:lumMod val="75000"/>
+                  </a:schemeClr>
+                </a:solidFill>
+                <a:latin typeface="Courier New" pitchFamily="49" charset="0"/>
+                <a:cs typeface="Courier New" pitchFamily="49" charset="0"/>
+              </a:rPr>
+              <a:t>"127.0.0.1"</a:t>
+            </a:r>
+            <a:r>
+              <a:rPr lang="de-DE" sz="1600" dirty="0">
+                <a:latin typeface="Courier New" pitchFamily="49" charset="0"/>
+                <a:cs typeface="Courier New" pitchFamily="49" charset="0"/>
+              </a:rPr>
+              <a:t>, 4000</a:t>
+            </a:r>
+            <a:r>
+              <a:rPr lang="de-DE" sz="1600" dirty="0" smtClean="0">
+                <a:latin typeface="Courier New" pitchFamily="49" charset="0"/>
+                <a:cs typeface="Courier New" pitchFamily="49" charset="0"/>
+              </a:rPr>
+              <a:t>);</a:t>
+            </a:r>
+            <a:endParaRPr lang="de-DE" sz="1600" dirty="0" smtClean="0">
+              <a:latin typeface="Courier New" pitchFamily="49" charset="0"/>
+              <a:cs typeface="Courier New" pitchFamily="49" charset="0"/>
+            </a:endParaRPr>
+          </a:p>
+          <a:p>
+            <a:pPr marL="0" indent="0">
+              <a:buNone/>
+            </a:pPr>
             <a:r>
               <a:rPr lang="nb-NO" sz="1600" dirty="0" smtClean="0">
                 <a:latin typeface="Courier New" pitchFamily="49" charset="0"/>
                 <a:cs typeface="Courier New" pitchFamily="49" charset="0"/>
               </a:rPr>
               <a:t>    Pt::XmlRpc::HttpClient client(loop, </a:t>
+            </a:r>
+            <a:r>
+              <a:rPr lang="de-DE" sz="1600" dirty="0" err="1" smtClean="0">
+                <a:latin typeface="Courier New" pitchFamily="49" charset="0"/>
+                <a:cs typeface="Courier New" pitchFamily="49" charset="0"/>
+              </a:rPr>
+              <a:t>ep</a:t>
+            </a:r>
+            <a:r>
+              <a:rPr lang="de-DE" sz="1600" dirty="0" smtClean="0">
+                <a:latin typeface="Courier New" pitchFamily="49" charset="0"/>
+                <a:cs typeface="Courier New" pitchFamily="49" charset="0"/>
+              </a:rPr>
+              <a:t>, </a:t>
             </a:r>
             <a:r>
               <a:rPr lang="de-DE" sz="1600" dirty="0" smtClean="0">
@@ -18775,10 +18973,10 @@
                 <a:latin typeface="Courier New" pitchFamily="49" charset="0"/>
                 <a:cs typeface="Courier New" pitchFamily="49" charset="0"/>
               </a:rPr>
-              <a:t>"127.0.0.1</a:t>
-            </a:r>
-            <a:r>
-              <a:rPr lang="de-DE" sz="1600" dirty="0">
+              <a:t>"/</a:t>
+            </a:r>
+            <a:r>
+              <a:rPr lang="de-DE" sz="1600" dirty="0" err="1" smtClean="0">
                 <a:solidFill>
                   <a:schemeClr val="accent2">
                     <a:lumMod val="75000"/>
@@ -18787,14 +18985,7 @@
                 <a:latin typeface="Courier New" pitchFamily="49" charset="0"/>
                 <a:cs typeface="Courier New" pitchFamily="49" charset="0"/>
               </a:rPr>
-              <a:t>"</a:t>
-            </a:r>
-            <a:r>
-              <a:rPr lang="de-DE" sz="1600" dirty="0">
-                <a:latin typeface="Courier New" pitchFamily="49" charset="0"/>
-                <a:cs typeface="Courier New" pitchFamily="49" charset="0"/>
-              </a:rPr>
-              <a:t>, 4000, </a:t>
+              <a:t>calc</a:t>
             </a:r>
             <a:r>
               <a:rPr lang="de-DE" sz="1600" dirty="0" smtClean="0">
@@ -18806,7 +18997,80 @@
                 <a:latin typeface="Courier New" pitchFamily="49" charset="0"/>
                 <a:cs typeface="Courier New" pitchFamily="49" charset="0"/>
               </a:rPr>
-              <a:t>"/</a:t>
+              <a:t>"</a:t>
+            </a:r>
+            <a:r>
+              <a:rPr lang="de-DE" sz="1600" dirty="0" smtClean="0">
+                <a:latin typeface="Courier New" pitchFamily="49" charset="0"/>
+                <a:cs typeface="Courier New" pitchFamily="49" charset="0"/>
+              </a:rPr>
+              <a:t>)</a:t>
+            </a:r>
+            <a:r>
+              <a:rPr lang="nb-NO" sz="1600" dirty="0" smtClean="0">
+                <a:latin typeface="Courier New" pitchFamily="49" charset="0"/>
+                <a:cs typeface="Courier New" pitchFamily="49" charset="0"/>
+              </a:rPr>
+              <a:t>;</a:t>
+            </a:r>
+          </a:p>
+          <a:p>
+            <a:pPr marL="0" indent="0">
+              <a:buNone/>
+            </a:pPr>
+            <a:r>
+              <a:rPr lang="de-DE" sz="1600" dirty="0" smtClean="0">
+                <a:latin typeface="Courier New" pitchFamily="49" charset="0"/>
+                <a:cs typeface="Courier New" pitchFamily="49" charset="0"/>
+              </a:rPr>
+              <a:t>    </a:t>
+            </a:r>
+          </a:p>
+          <a:p>
+            <a:pPr marL="0" indent="0">
+              <a:buNone/>
+            </a:pPr>
+            <a:r>
+              <a:rPr lang="de-DE" sz="1600" dirty="0">
+                <a:latin typeface="Courier New" pitchFamily="49" charset="0"/>
+                <a:cs typeface="Courier New" pitchFamily="49" charset="0"/>
+              </a:rPr>
+              <a:t> </a:t>
+            </a:r>
+            <a:r>
+              <a:rPr lang="de-DE" sz="1600" dirty="0" smtClean="0">
+                <a:latin typeface="Courier New" pitchFamily="49" charset="0"/>
+                <a:cs typeface="Courier New" pitchFamily="49" charset="0"/>
+              </a:rPr>
+              <a:t>   Pt::</a:t>
+            </a:r>
+            <a:r>
+              <a:rPr lang="de-DE" sz="1600" dirty="0" err="1" smtClean="0">
+                <a:latin typeface="Courier New" pitchFamily="49" charset="0"/>
+                <a:cs typeface="Courier New" pitchFamily="49" charset="0"/>
+              </a:rPr>
+              <a:t>XmlRpc</a:t>
+            </a:r>
+            <a:r>
+              <a:rPr lang="de-DE" sz="1600" dirty="0" smtClean="0">
+                <a:latin typeface="Courier New" pitchFamily="49" charset="0"/>
+                <a:cs typeface="Courier New" pitchFamily="49" charset="0"/>
+              </a:rPr>
+              <a:t>::</a:t>
+            </a:r>
+            <a:r>
+              <a:rPr lang="de-DE" sz="1600" dirty="0" err="1" smtClean="0">
+                <a:latin typeface="Courier New" pitchFamily="49" charset="0"/>
+                <a:cs typeface="Courier New" pitchFamily="49" charset="0"/>
+              </a:rPr>
+              <a:t>RemoteProcedure</a:t>
+            </a:r>
+            <a:r>
+              <a:rPr lang="de-DE" sz="1600" dirty="0" smtClean="0">
+                <a:latin typeface="Courier New" pitchFamily="49" charset="0"/>
+                <a:cs typeface="Courier New" pitchFamily="49" charset="0"/>
+              </a:rPr>
+              <a:t>&lt;</a:t>
             </a:r>
             <a:r>
               <a:rPr lang="de-DE" sz="1600" dirty="0" err="1" smtClean="0">
@@ -18818,7 +19082,80 @@
                 <a:latin typeface="Courier New" pitchFamily="49" charset="0"/>
                 <a:cs typeface="Courier New" pitchFamily="49" charset="0"/>
               </a:rPr>
-              <a:t>calc</a:t>
+              <a:t>int</a:t>
+            </a:r>
+            <a:r>
+              <a:rPr lang="de-DE" sz="1600" dirty="0" smtClean="0">
+                <a:latin typeface="Courier New" pitchFamily="49" charset="0"/>
+                <a:cs typeface="Courier New" pitchFamily="49" charset="0"/>
+              </a:rPr>
+              <a:t>, </a:t>
+            </a:r>
+            <a:r>
+              <a:rPr lang="de-DE" sz="1600" dirty="0" err="1" smtClean="0">
+                <a:solidFill>
+                  <a:schemeClr val="accent2">
+                    <a:lumMod val="75000"/>
+                  </a:schemeClr>
+                </a:solidFill>
+                <a:latin typeface="Courier New" pitchFamily="49" charset="0"/>
+                <a:cs typeface="Courier New" pitchFamily="49" charset="0"/>
+              </a:rPr>
+              <a:t>int</a:t>
+            </a:r>
+            <a:r>
+              <a:rPr lang="de-DE" sz="1600" dirty="0" smtClean="0">
+                <a:latin typeface="Courier New" pitchFamily="49" charset="0"/>
+                <a:cs typeface="Courier New" pitchFamily="49" charset="0"/>
+              </a:rPr>
+              <a:t>, </a:t>
+            </a:r>
+            <a:r>
+              <a:rPr lang="de-DE" sz="1600" dirty="0" err="1" smtClean="0">
+                <a:solidFill>
+                  <a:schemeClr val="accent2">
+                    <a:lumMod val="75000"/>
+                  </a:schemeClr>
+                </a:solidFill>
+                <a:latin typeface="Courier New" pitchFamily="49" charset="0"/>
+                <a:cs typeface="Courier New" pitchFamily="49" charset="0"/>
+              </a:rPr>
+              <a:t>int</a:t>
+            </a:r>
+            <a:r>
+              <a:rPr lang="de-DE" sz="1600" dirty="0" smtClean="0">
+                <a:latin typeface="Courier New" pitchFamily="49" charset="0"/>
+                <a:cs typeface="Courier New" pitchFamily="49" charset="0"/>
+              </a:rPr>
+              <a:t>&gt; </a:t>
+            </a:r>
+            <a:r>
+              <a:rPr lang="de-DE" sz="1600" dirty="0" err="1" smtClean="0">
+                <a:latin typeface="Courier New" pitchFamily="49" charset="0"/>
+                <a:cs typeface="Courier New" pitchFamily="49" charset="0"/>
+              </a:rPr>
+              <a:t>multiply</a:t>
+            </a:r>
+            <a:r>
+              <a:rPr lang="de-DE" sz="1600" dirty="0" smtClean="0">
+                <a:latin typeface="Courier New" pitchFamily="49" charset="0"/>
+                <a:cs typeface="Courier New" pitchFamily="49" charset="0"/>
+              </a:rPr>
+              <a:t>(</a:t>
+            </a:r>
+            <a:r>
+              <a:rPr lang="de-DE" sz="1600" dirty="0" err="1" smtClean="0">
+                <a:latin typeface="Courier New" pitchFamily="49" charset="0"/>
+                <a:cs typeface="Courier New" pitchFamily="49" charset="0"/>
+              </a:rPr>
+              <a:t>client</a:t>
+            </a:r>
+            <a:r>
+              <a:rPr lang="de-DE" sz="1600" dirty="0" smtClean="0">
+                <a:latin typeface="Courier New" pitchFamily="49" charset="0"/>
+                <a:cs typeface="Courier New" pitchFamily="49" charset="0"/>
+              </a:rPr>
+              <a:t>, </a:t>
             </a:r>
             <a:r>
               <a:rPr lang="de-DE" sz="1600" dirty="0" smtClean="0">
@@ -18830,80 +19167,7 @@
                 <a:latin typeface="Courier New" pitchFamily="49" charset="0"/>
                 <a:cs typeface="Courier New" pitchFamily="49" charset="0"/>
               </a:rPr>
-              <a:t>"</a:t>
-            </a:r>
-            <a:r>
-              <a:rPr lang="de-DE" sz="1600" dirty="0" smtClean="0">
-                <a:latin typeface="Courier New" pitchFamily="49" charset="0"/>
-                <a:cs typeface="Courier New" pitchFamily="49" charset="0"/>
-              </a:rPr>
-              <a:t>)</a:t>
-            </a:r>
-            <a:r>
-              <a:rPr lang="nb-NO" sz="1600" dirty="0" smtClean="0">
-                <a:latin typeface="Courier New" pitchFamily="49" charset="0"/>
-                <a:cs typeface="Courier New" pitchFamily="49" charset="0"/>
-              </a:rPr>
-              <a:t>;</a:t>
-            </a:r>
-          </a:p>
-          <a:p>
-            <a:pPr marL="0" indent="0">
-              <a:buNone/>
-            </a:pPr>
-            <a:r>
-              <a:rPr lang="de-DE" sz="1600" dirty="0" smtClean="0">
-                <a:latin typeface="Courier New" pitchFamily="49" charset="0"/>
-                <a:cs typeface="Courier New" pitchFamily="49" charset="0"/>
-              </a:rPr>
-              <a:t>    </a:t>
-            </a:r>
-          </a:p>
-          <a:p>
-            <a:pPr marL="0" indent="0">
-              <a:buNone/>
-            </a:pPr>
-            <a:r>
-              <a:rPr lang="de-DE" sz="1600" dirty="0">
-                <a:latin typeface="Courier New" pitchFamily="49" charset="0"/>
-                <a:cs typeface="Courier New" pitchFamily="49" charset="0"/>
-              </a:rPr>
-              <a:t> </a:t>
-            </a:r>
-            <a:r>
-              <a:rPr lang="de-DE" sz="1600" dirty="0" smtClean="0">
-                <a:latin typeface="Courier New" pitchFamily="49" charset="0"/>
-                <a:cs typeface="Courier New" pitchFamily="49" charset="0"/>
-              </a:rPr>
-              <a:t>   Pt::</a:t>
-            </a:r>
-            <a:r>
-              <a:rPr lang="de-DE" sz="1600" dirty="0" err="1" smtClean="0">
-                <a:latin typeface="Courier New" pitchFamily="49" charset="0"/>
-                <a:cs typeface="Courier New" pitchFamily="49" charset="0"/>
-              </a:rPr>
-              <a:t>XmlRpc</a:t>
-            </a:r>
-            <a:r>
-              <a:rPr lang="de-DE" sz="1600" dirty="0" smtClean="0">
-                <a:latin typeface="Courier New" pitchFamily="49" charset="0"/>
-                <a:cs typeface="Courier New" pitchFamily="49" charset="0"/>
-              </a:rPr>
-              <a:t>::</a:t>
-            </a:r>
-            <a:r>
-              <a:rPr lang="de-DE" sz="1600" dirty="0" err="1" smtClean="0">
-                <a:latin typeface="Courier New" pitchFamily="49" charset="0"/>
-                <a:cs typeface="Courier New" pitchFamily="49" charset="0"/>
-              </a:rPr>
-              <a:t>RemoteProcedure</a:t>
-            </a:r>
-            <a:r>
-              <a:rPr lang="de-DE" sz="1600" dirty="0" smtClean="0">
-                <a:latin typeface="Courier New" pitchFamily="49" charset="0"/>
-                <a:cs typeface="Courier New" pitchFamily="49" charset="0"/>
-              </a:rPr>
-              <a:t>&lt;</a:t>
+              <a:t>„</a:t>
             </a:r>
             <a:r>
               <a:rPr lang="de-DE" sz="1600" dirty="0" err="1" smtClean="0">
@@ -18915,80 +19179,7 @@
                 <a:latin typeface="Courier New" pitchFamily="49" charset="0"/>
                 <a:cs typeface="Courier New" pitchFamily="49" charset="0"/>
               </a:rPr>
-              <a:t>int</a:t>
-            </a:r>
-            <a:r>
-              <a:rPr lang="de-DE" sz="1600" dirty="0" smtClean="0">
-                <a:latin typeface="Courier New" pitchFamily="49" charset="0"/>
-                <a:cs typeface="Courier New" pitchFamily="49" charset="0"/>
-              </a:rPr>
-              <a:t>, </a:t>
-            </a:r>
-            <a:r>
-              <a:rPr lang="de-DE" sz="1600" dirty="0" err="1" smtClean="0">
-                <a:solidFill>
-                  <a:schemeClr val="accent2">
-                    <a:lumMod val="75000"/>
-                  </a:schemeClr>
-                </a:solidFill>
-                <a:latin typeface="Courier New" pitchFamily="49" charset="0"/>
-                <a:cs typeface="Courier New" pitchFamily="49" charset="0"/>
-              </a:rPr>
-              <a:t>int</a:t>
-            </a:r>
-            <a:r>
-              <a:rPr lang="de-DE" sz="1600" dirty="0" smtClean="0">
-                <a:latin typeface="Courier New" pitchFamily="49" charset="0"/>
-                <a:cs typeface="Courier New" pitchFamily="49" charset="0"/>
-              </a:rPr>
-              <a:t>, </a:t>
-            </a:r>
-            <a:r>
-              <a:rPr lang="de-DE" sz="1600" dirty="0" err="1" smtClean="0">
-                <a:solidFill>
-                  <a:schemeClr val="accent2">
-                    <a:lumMod val="75000"/>
-                  </a:schemeClr>
-                </a:solidFill>
-                <a:latin typeface="Courier New" pitchFamily="49" charset="0"/>
-                <a:cs typeface="Courier New" pitchFamily="49" charset="0"/>
-              </a:rPr>
-              <a:t>int</a:t>
-            </a:r>
-            <a:r>
-              <a:rPr lang="de-DE" sz="1600" dirty="0" smtClean="0">
-                <a:latin typeface="Courier New" pitchFamily="49" charset="0"/>
-                <a:cs typeface="Courier New" pitchFamily="49" charset="0"/>
-              </a:rPr>
-              <a:t>&gt; </a:t>
-            </a:r>
-            <a:r>
-              <a:rPr lang="de-DE" sz="1600" dirty="0" err="1" smtClean="0">
-                <a:latin typeface="Courier New" pitchFamily="49" charset="0"/>
-                <a:cs typeface="Courier New" pitchFamily="49" charset="0"/>
-              </a:rPr>
               <a:t>multiply</a:t>
-            </a:r>
-            <a:r>
-              <a:rPr lang="de-DE" sz="1600" dirty="0" smtClean="0">
-                <a:latin typeface="Courier New" pitchFamily="49" charset="0"/>
-                <a:cs typeface="Courier New" pitchFamily="49" charset="0"/>
-              </a:rPr>
-              <a:t>(</a:t>
-            </a:r>
-            <a:r>
-              <a:rPr lang="de-DE" sz="1600" dirty="0" err="1" smtClean="0">
-                <a:latin typeface="Courier New" pitchFamily="49" charset="0"/>
-                <a:cs typeface="Courier New" pitchFamily="49" charset="0"/>
-              </a:rPr>
-              <a:t>client</a:t>
-            </a:r>
-            <a:r>
-              <a:rPr lang="de-DE" sz="1600" dirty="0" smtClean="0">
-                <a:latin typeface="Courier New" pitchFamily="49" charset="0"/>
-                <a:cs typeface="Courier New" pitchFamily="49" charset="0"/>
-              </a:rPr>
-              <a:t>, </a:t>
             </a:r>
             <a:r>
               <a:rPr lang="de-DE" sz="1600" dirty="0" smtClean="0">
@@ -19000,71 +19191,54 @@
                 <a:latin typeface="Courier New" pitchFamily="49" charset="0"/>
                 <a:cs typeface="Courier New" pitchFamily="49" charset="0"/>
               </a:rPr>
-              <a:t>„</a:t>
+              <a:t>“</a:t>
+            </a:r>
+            <a:r>
+              <a:rPr lang="de-DE" sz="1600" dirty="0" smtClean="0">
+                <a:latin typeface="Courier New" pitchFamily="49" charset="0"/>
+                <a:cs typeface="Courier New" pitchFamily="49" charset="0"/>
+              </a:rPr>
+              <a:t>);</a:t>
+            </a:r>
+          </a:p>
+          <a:p>
+            <a:pPr marL="0" indent="0">
+              <a:buNone/>
+            </a:pPr>
+            <a:r>
+              <a:rPr lang="de-DE" sz="1600" dirty="0">
+                <a:latin typeface="Courier New" pitchFamily="49" charset="0"/>
+                <a:cs typeface="Courier New" pitchFamily="49" charset="0"/>
+              </a:rPr>
+              <a:t> </a:t>
+            </a:r>
+            <a:r>
+              <a:rPr lang="de-DE" sz="1600" dirty="0" smtClean="0">
+                <a:latin typeface="Courier New" pitchFamily="49" charset="0"/>
+                <a:cs typeface="Courier New" pitchFamily="49" charset="0"/>
+              </a:rPr>
+              <a:t>   </a:t>
             </a:r>
             <a:r>
               <a:rPr lang="de-DE" sz="1600" dirty="0" err="1" smtClean="0">
-                <a:solidFill>
-                  <a:schemeClr val="accent2">
-                    <a:lumMod val="75000"/>
-                  </a:schemeClr>
-                </a:solidFill>
-                <a:latin typeface="Courier New" pitchFamily="49" charset="0"/>
-                <a:cs typeface="Courier New" pitchFamily="49" charset="0"/>
-              </a:rPr>
-              <a:t>multiply</a:t>
+                <a:latin typeface="Courier New" pitchFamily="49" charset="0"/>
+                <a:cs typeface="Courier New" pitchFamily="49" charset="0"/>
+              </a:rPr>
+              <a:t>multiply.finished</a:t>
             </a:r>
             <a:r>
               <a:rPr lang="de-DE" sz="1600" dirty="0" smtClean="0">
-                <a:solidFill>
-                  <a:schemeClr val="accent2">
-                    <a:lumMod val="75000"/>
-                  </a:schemeClr>
-                </a:solidFill>
-                <a:latin typeface="Courier New" pitchFamily="49" charset="0"/>
-                <a:cs typeface="Courier New" pitchFamily="49" charset="0"/>
-              </a:rPr>
-              <a:t>“</a:t>
-            </a:r>
-            <a:r>
-              <a:rPr lang="de-DE" sz="1600" dirty="0" smtClean="0">
-                <a:latin typeface="Courier New" pitchFamily="49" charset="0"/>
-                <a:cs typeface="Courier New" pitchFamily="49" charset="0"/>
-              </a:rPr>
-              <a:t>);</a:t>
-            </a:r>
-          </a:p>
-          <a:p>
-            <a:pPr marL="0" indent="0">
-              <a:buNone/>
-            </a:pPr>
+                <a:latin typeface="Courier New" pitchFamily="49" charset="0"/>
+                <a:cs typeface="Courier New" pitchFamily="49" charset="0"/>
+              </a:rPr>
+              <a:t>() </a:t>
+            </a:r>
             <a:r>
               <a:rPr lang="de-DE" sz="1600" dirty="0">
                 <a:latin typeface="Courier New" pitchFamily="49" charset="0"/>
                 <a:cs typeface="Courier New" pitchFamily="49" charset="0"/>
               </a:rPr>
-              <a:t> </a:t>
-            </a:r>
-            <a:r>
-              <a:rPr lang="de-DE" sz="1600" dirty="0" smtClean="0">
-                <a:latin typeface="Courier New" pitchFamily="49" charset="0"/>
-                <a:cs typeface="Courier New" pitchFamily="49" charset="0"/>
-              </a:rPr>
-              <a:t>   </a:t>
-            </a:r>
-            <a:r>
-              <a:rPr lang="de-DE" sz="1600" dirty="0" err="1">
-                <a:latin typeface="Courier New" pitchFamily="49" charset="0"/>
-                <a:cs typeface="Courier New" pitchFamily="49" charset="0"/>
-              </a:rPr>
-              <a:t>multiply.finished</a:t>
-            </a:r>
-            <a:r>
-              <a:rPr lang="de-DE" sz="1600" dirty="0">
-                <a:latin typeface="Courier New" pitchFamily="49" charset="0"/>
-                <a:cs typeface="Courier New" pitchFamily="49" charset="0"/>
-              </a:rPr>
-              <a:t> += Pt::</a:t>
+              <a:t>+= Pt::</a:t>
             </a:r>
             <a:r>
               <a:rPr lang="de-DE" sz="1600" dirty="0" err="1">
@@ -19264,15 +19438,7 @@
             </a:r>
             <a:r>
               <a:rPr lang="de-DE" sz="2800" dirty="0" smtClean="0"/>
-              <a:t> </a:t>
-            </a:r>
-            <a:r>
-              <a:rPr lang="de-DE" sz="2800" dirty="0" smtClean="0"/>
-              <a:t>XML-RPC </a:t>
-            </a:r>
-            <a:r>
-              <a:rPr lang="de-DE" sz="2800" dirty="0" smtClean="0"/>
-              <a:t>Services</a:t>
+              <a:t> XML-RPC Services</a:t>
             </a:r>
             <a:endParaRPr lang="en-US" sz="2800" dirty="0"/>
           </a:p>
@@ -19291,7 +19457,7 @@
         <p:spPr>
           <a:xfrm>
             <a:off x="323528" y="908720"/>
-            <a:ext cx="8568952" cy="5760640"/>
+            <a:ext cx="8568952" cy="5832648"/>
           </a:xfrm>
         </p:spPr>
         <p:txBody>
@@ -20007,12 +20173,63 @@
             <a:pPr marL="0" indent="0">
               <a:buNone/>
             </a:pPr>
+            <a:endParaRPr lang="de-DE" sz="1600" dirty="0">
+              <a:latin typeface="Courier New" pitchFamily="49" charset="0"/>
+              <a:cs typeface="Courier New" pitchFamily="49" charset="0"/>
+            </a:endParaRPr>
+          </a:p>
+          <a:p>
+            <a:pPr marL="0" indent="0">
+              <a:buNone/>
+            </a:pPr>
             <a:r>
               <a:rPr lang="de-DE" sz="1600" dirty="0" smtClean="0">
                 <a:latin typeface="Courier New" pitchFamily="49" charset="0"/>
                 <a:cs typeface="Courier New" pitchFamily="49" charset="0"/>
               </a:rPr>
-              <a:t>	</a:t>
+              <a:t>    Pt::</a:t>
+            </a:r>
+            <a:r>
+              <a:rPr lang="de-DE" sz="1600" dirty="0" err="1" smtClean="0">
+                <a:latin typeface="Courier New" pitchFamily="49" charset="0"/>
+                <a:cs typeface="Courier New" pitchFamily="49" charset="0"/>
+              </a:rPr>
+              <a:t>XmlRpc</a:t>
+            </a:r>
+            <a:r>
+              <a:rPr lang="de-DE" sz="1600" dirty="0" smtClean="0">
+                <a:latin typeface="Courier New" pitchFamily="49" charset="0"/>
+                <a:cs typeface="Courier New" pitchFamily="49" charset="0"/>
+              </a:rPr>
+              <a:t>::</a:t>
+            </a:r>
+            <a:r>
+              <a:rPr lang="de-DE" sz="1600" dirty="0" err="1" smtClean="0">
+                <a:latin typeface="Courier New" pitchFamily="49" charset="0"/>
+                <a:cs typeface="Courier New" pitchFamily="49" charset="0"/>
+              </a:rPr>
+              <a:t>ServiceDefinition</a:t>
+            </a:r>
+            <a:r>
+              <a:rPr lang="de-DE" sz="1600" dirty="0" smtClean="0">
+                <a:latin typeface="Courier New" pitchFamily="49" charset="0"/>
+                <a:cs typeface="Courier New" pitchFamily="49" charset="0"/>
+              </a:rPr>
+              <a:t> </a:t>
+            </a:r>
+            <a:r>
+              <a:rPr lang="de-DE" sz="1600" dirty="0" err="1" smtClean="0">
+                <a:latin typeface="Courier New" pitchFamily="49" charset="0"/>
+                <a:cs typeface="Courier New" pitchFamily="49" charset="0"/>
+              </a:rPr>
+              <a:t>def</a:t>
+            </a:r>
+            <a:r>
+              <a:rPr lang="de-DE" sz="1600" dirty="0" smtClean="0">
+                <a:latin typeface="Courier New" pitchFamily="49" charset="0"/>
+                <a:cs typeface="Courier New" pitchFamily="49" charset="0"/>
+              </a:rPr>
+              <a:t>;</a:t>
             </a:r>
           </a:p>
           <a:p>
@@ -20020,58 +20237,25 @@
               <a:buNone/>
             </a:pPr>
             <a:r>
+              <a:rPr lang="de-DE" sz="1600" dirty="0">
+                <a:latin typeface="Courier New" pitchFamily="49" charset="0"/>
+                <a:cs typeface="Courier New" pitchFamily="49" charset="0"/>
+              </a:rPr>
+              <a:t> </a:t>
+            </a:r>
+            <a:r>
               <a:rPr lang="de-DE" sz="1600" dirty="0" smtClean="0">
                 <a:latin typeface="Courier New" pitchFamily="49" charset="0"/>
                 <a:cs typeface="Courier New" pitchFamily="49" charset="0"/>
               </a:rPr>
-              <a:t>    Pt::</a:t>
+              <a:t>   </a:t>
             </a:r>
             <a:r>
               <a:rPr lang="de-DE" sz="1600" dirty="0" err="1" smtClean="0">
                 <a:latin typeface="Courier New" pitchFamily="49" charset="0"/>
                 <a:cs typeface="Courier New" pitchFamily="49" charset="0"/>
               </a:rPr>
-              <a:t>XmlRpc</a:t>
-            </a:r>
-            <a:r>
-              <a:rPr lang="de-DE" sz="1600" dirty="0" smtClean="0">
-                <a:latin typeface="Courier New" pitchFamily="49" charset="0"/>
-                <a:cs typeface="Courier New" pitchFamily="49" charset="0"/>
-              </a:rPr>
-              <a:t>::Service </a:t>
-            </a:r>
-            <a:r>
-              <a:rPr lang="de-DE" sz="1600" dirty="0" err="1" smtClean="0">
-                <a:latin typeface="Courier New" pitchFamily="49" charset="0"/>
-                <a:cs typeface="Courier New" pitchFamily="49" charset="0"/>
-              </a:rPr>
-              <a:t>service</a:t>
-            </a:r>
-            <a:r>
-              <a:rPr lang="de-DE" sz="1600" dirty="0" smtClean="0">
-                <a:latin typeface="Courier New" pitchFamily="49" charset="0"/>
-                <a:cs typeface="Courier New" pitchFamily="49" charset="0"/>
-              </a:rPr>
-              <a:t>;</a:t>
-            </a:r>
-          </a:p>
-          <a:p>
-            <a:pPr marL="0" indent="0">
-              <a:buNone/>
-            </a:pPr>
-            <a:r>
-              <a:rPr lang="de-DE" sz="1600" dirty="0" smtClean="0">
-                <a:latin typeface="Courier New" pitchFamily="49" charset="0"/>
-                <a:cs typeface="Courier New" pitchFamily="49" charset="0"/>
-              </a:rPr>
-              <a:t>    </a:t>
-            </a:r>
-            <a:r>
-              <a:rPr lang="de-DE" sz="1600" dirty="0" err="1" smtClean="0">
-                <a:latin typeface="Courier New" pitchFamily="49" charset="0"/>
-                <a:cs typeface="Courier New" pitchFamily="49" charset="0"/>
-              </a:rPr>
-              <a:t>service.registerFunction</a:t>
+              <a:t>service.registerProcedure</a:t>
             </a:r>
             <a:r>
               <a:rPr lang="de-DE" sz="1600" dirty="0" smtClean="0">
@@ -20093,7 +20277,7 @@
               <a:t>„</a:t>
             </a:r>
             <a:r>
-              <a:rPr lang="de-DE" sz="1600" dirty="0" err="1" smtClean="0">
+              <a:rPr lang="de-DE" sz="1600" dirty="0" err="1">
                 <a:solidFill>
                   <a:schemeClr val="accent2">
                     <a:lumMod val="75000"/>
@@ -20103,6 +20287,65 @@
                 <a:cs typeface="Courier New" pitchFamily="49" charset="0"/>
               </a:rPr>
               <a:t>multiply</a:t>
+            </a:r>
+            <a:r>
+              <a:rPr lang="de-DE" sz="1600" dirty="0">
+                <a:solidFill>
+                  <a:schemeClr val="accent2">
+                    <a:lumMod val="75000"/>
+                  </a:schemeClr>
+                </a:solidFill>
+                <a:latin typeface="Courier New" pitchFamily="49" charset="0"/>
+                <a:cs typeface="Courier New" pitchFamily="49" charset="0"/>
+              </a:rPr>
+              <a:t>“</a:t>
+            </a:r>
+            <a:r>
+              <a:rPr lang="de-DE" sz="1600" dirty="0">
+                <a:latin typeface="Courier New" pitchFamily="49" charset="0"/>
+                <a:cs typeface="Courier New" pitchFamily="49" charset="0"/>
+              </a:rPr>
+              <a:t>, &amp;</a:t>
+            </a:r>
+            <a:r>
+              <a:rPr lang="de-DE" sz="1600" dirty="0" err="1">
+                <a:latin typeface="Courier New" pitchFamily="49" charset="0"/>
+                <a:cs typeface="Courier New" pitchFamily="49" charset="0"/>
+              </a:rPr>
+              <a:t>multiply</a:t>
+            </a:r>
+            <a:r>
+              <a:rPr lang="de-DE" sz="1600" dirty="0">
+                <a:latin typeface="Courier New" pitchFamily="49" charset="0"/>
+                <a:cs typeface="Courier New" pitchFamily="49" charset="0"/>
+              </a:rPr>
+              <a:t>);</a:t>
+            </a:r>
+          </a:p>
+          <a:p>
+            <a:pPr marL="0" indent="0">
+              <a:buNone/>
+            </a:pPr>
+            <a:r>
+              <a:rPr lang="de-DE" sz="1600" dirty="0">
+                <a:latin typeface="Courier New" pitchFamily="49" charset="0"/>
+                <a:cs typeface="Courier New" pitchFamily="49" charset="0"/>
+              </a:rPr>
+              <a:t>    </a:t>
+            </a:r>
+            <a:r>
+              <a:rPr lang="de-DE" sz="1600" dirty="0" err="1" smtClean="0">
+                <a:latin typeface="Courier New" pitchFamily="49" charset="0"/>
+                <a:cs typeface="Courier New" pitchFamily="49" charset="0"/>
+              </a:rPr>
+              <a:t>service.registerProcedure</a:t>
+            </a:r>
+            <a:r>
+              <a:rPr lang="de-DE" sz="1600" dirty="0" smtClean="0">
+                <a:latin typeface="Courier New" pitchFamily="49" charset="0"/>
+                <a:cs typeface="Courier New" pitchFamily="49" charset="0"/>
+              </a:rPr>
+              <a:t>(</a:t>
             </a:r>
             <a:r>
               <a:rPr lang="de-DE" sz="1600" dirty="0" smtClean="0">
@@ -20114,29 +20357,134 @@
                 <a:latin typeface="Courier New" pitchFamily="49" charset="0"/>
                 <a:cs typeface="Courier New" pitchFamily="49" charset="0"/>
               </a:rPr>
+              <a:t>„</a:t>
+            </a:r>
+            <a:r>
+              <a:rPr lang="de-DE" sz="1600" dirty="0" err="1">
+                <a:solidFill>
+                  <a:schemeClr val="accent2">
+                    <a:lumMod val="75000"/>
+                  </a:schemeClr>
+                </a:solidFill>
+                <a:latin typeface="Courier New" pitchFamily="49" charset="0"/>
+                <a:cs typeface="Courier New" pitchFamily="49" charset="0"/>
+              </a:rPr>
+              <a:t>add</a:t>
+            </a:r>
+            <a:r>
+              <a:rPr lang="de-DE" sz="1600" dirty="0">
+                <a:solidFill>
+                  <a:schemeClr val="accent2">
+                    <a:lumMod val="75000"/>
+                  </a:schemeClr>
+                </a:solidFill>
+                <a:latin typeface="Courier New" pitchFamily="49" charset="0"/>
+                <a:cs typeface="Courier New" pitchFamily="49" charset="0"/>
+              </a:rPr>
               <a:t>“</a:t>
             </a:r>
             <a:r>
+              <a:rPr lang="de-DE" sz="1600" dirty="0">
+                <a:latin typeface="Courier New" pitchFamily="49" charset="0"/>
+                <a:cs typeface="Courier New" pitchFamily="49" charset="0"/>
+              </a:rPr>
+              <a:t>, &amp;</a:t>
+            </a:r>
+            <a:r>
+              <a:rPr lang="de-DE" sz="1600" dirty="0" err="1">
+                <a:latin typeface="Courier New" pitchFamily="49" charset="0"/>
+                <a:cs typeface="Courier New" pitchFamily="49" charset="0"/>
+              </a:rPr>
+              <a:t>add</a:t>
+            </a:r>
+            <a:r>
+              <a:rPr lang="de-DE" sz="1600" dirty="0">
+                <a:latin typeface="Courier New" pitchFamily="49" charset="0"/>
+                <a:cs typeface="Courier New" pitchFamily="49" charset="0"/>
+              </a:rPr>
+              <a:t>);</a:t>
+            </a:r>
+          </a:p>
+          <a:p>
+            <a:pPr marL="0" indent="0">
+              <a:buNone/>
+            </a:pPr>
+            <a:endParaRPr lang="de-DE" sz="1600" dirty="0" smtClean="0">
+              <a:latin typeface="Courier New" pitchFamily="49" charset="0"/>
+              <a:cs typeface="Courier New" pitchFamily="49" charset="0"/>
+            </a:endParaRPr>
+          </a:p>
+          <a:p>
+            <a:pPr marL="0" indent="0">
+              <a:buNone/>
+            </a:pPr>
+            <a:r>
               <a:rPr lang="de-DE" sz="1600" dirty="0" smtClean="0">
                 <a:latin typeface="Courier New" pitchFamily="49" charset="0"/>
                 <a:cs typeface="Courier New" pitchFamily="49" charset="0"/>
               </a:rPr>
-              <a:t>, &amp;</a:t>
+              <a:t>    Pt::</a:t>
             </a:r>
             <a:r>
               <a:rPr lang="de-DE" sz="1600" dirty="0" err="1" smtClean="0">
                 <a:latin typeface="Courier New" pitchFamily="49" charset="0"/>
                 <a:cs typeface="Courier New" pitchFamily="49" charset="0"/>
               </a:rPr>
-              <a:t>multiply</a:t>
+              <a:t>XmlRpc</a:t>
             </a:r>
             <a:r>
               <a:rPr lang="de-DE" sz="1600" dirty="0" smtClean="0">
                 <a:latin typeface="Courier New" pitchFamily="49" charset="0"/>
                 <a:cs typeface="Courier New" pitchFamily="49" charset="0"/>
               </a:rPr>
+              <a:t>::</a:t>
+            </a:r>
+            <a:r>
+              <a:rPr lang="de-DE" sz="1600" dirty="0" err="1" smtClean="0">
+                <a:latin typeface="Courier New" pitchFamily="49" charset="0"/>
+                <a:cs typeface="Courier New" pitchFamily="49" charset="0"/>
+              </a:rPr>
+              <a:t>HttpService</a:t>
+            </a:r>
+            <a:r>
+              <a:rPr lang="de-DE" sz="1600" dirty="0" smtClean="0">
+                <a:latin typeface="Courier New" pitchFamily="49" charset="0"/>
+                <a:cs typeface="Courier New" pitchFamily="49" charset="0"/>
+              </a:rPr>
+              <a:t> </a:t>
+            </a:r>
+            <a:r>
+              <a:rPr lang="de-DE" sz="1600" dirty="0" err="1" smtClean="0">
+                <a:latin typeface="Courier New" pitchFamily="49" charset="0"/>
+                <a:cs typeface="Courier New" pitchFamily="49" charset="0"/>
+              </a:rPr>
+              <a:t>service</a:t>
+            </a:r>
+            <a:r>
+              <a:rPr lang="de-DE" sz="1600" dirty="0" smtClean="0">
+                <a:latin typeface="Courier New" pitchFamily="49" charset="0"/>
+                <a:cs typeface="Courier New" pitchFamily="49" charset="0"/>
+              </a:rPr>
+              <a:t>(</a:t>
+            </a:r>
+            <a:r>
+              <a:rPr lang="de-DE" sz="1600" dirty="0" err="1" smtClean="0">
+                <a:latin typeface="Courier New" pitchFamily="49" charset="0"/>
+                <a:cs typeface="Courier New" pitchFamily="49" charset="0"/>
+              </a:rPr>
+              <a:t>def</a:t>
+            </a:r>
+            <a:r>
+              <a:rPr lang="de-DE" sz="1600" dirty="0" smtClean="0">
+                <a:latin typeface="Courier New" pitchFamily="49" charset="0"/>
+                <a:cs typeface="Courier New" pitchFamily="49" charset="0"/>
+              </a:rPr>
               <a:t>);</a:t>
             </a:r>
+            <a:endParaRPr lang="de-DE" sz="1600" dirty="0" smtClean="0">
+              <a:latin typeface="Courier New" pitchFamily="49" charset="0"/>
+              <a:cs typeface="Courier New" pitchFamily="49" charset="0"/>
+            </a:endParaRPr>
           </a:p>
           <a:p>
             <a:pPr marL="0" indent="0">
@@ -20149,19 +20497,31 @@
               </a:rPr>
               <a:t>    </a:t>
             </a:r>
-            <a:r>
-              <a:rPr lang="de-DE" sz="1600" dirty="0" err="1" smtClean="0">
-                <a:latin typeface="Courier New" pitchFamily="49" charset="0"/>
-                <a:cs typeface="Courier New" pitchFamily="49" charset="0"/>
-              </a:rPr>
-              <a:t>service.registerFunction</a:t>
-            </a:r>
-            <a:r>
-              <a:rPr lang="de-DE" sz="1600" dirty="0" smtClean="0">
-                <a:latin typeface="Courier New" pitchFamily="49" charset="0"/>
-                <a:cs typeface="Courier New" pitchFamily="49" charset="0"/>
-              </a:rPr>
-              <a:t>(</a:t>
+          </a:p>
+          <a:p>
+            <a:pPr marL="0" indent="0">
+              <a:buNone/>
+            </a:pPr>
+            <a:r>
+              <a:rPr lang="nb-NO" sz="1600" smtClean="0">
+                <a:latin typeface="Courier New" pitchFamily="49" charset="0"/>
+                <a:cs typeface="Courier New" pitchFamily="49" charset="0"/>
+              </a:rPr>
+              <a:t>    </a:t>
+            </a:r>
+            <a:r>
+              <a:rPr lang="nb-NO" sz="1600" smtClean="0">
+                <a:latin typeface="Courier New" pitchFamily="49" charset="0"/>
+                <a:cs typeface="Courier New" pitchFamily="49" charset="0"/>
+              </a:rPr>
+              <a:t>Pt::Http::Server </a:t>
+            </a:r>
+            <a:r>
+              <a:rPr lang="nb-NO" sz="1600" dirty="0" smtClean="0">
+                <a:latin typeface="Courier New" pitchFamily="49" charset="0"/>
+                <a:cs typeface="Courier New" pitchFamily="49" charset="0"/>
+              </a:rPr>
+              <a:t>server(loop, </a:t>
             </a:r>
             <a:r>
               <a:rPr lang="de-DE" sz="1600" dirty="0" smtClean="0">
@@ -20173,10 +20533,10 @@
                 <a:latin typeface="Courier New" pitchFamily="49" charset="0"/>
                 <a:cs typeface="Courier New" pitchFamily="49" charset="0"/>
               </a:rPr>
-              <a:t>„</a:t>
-            </a:r>
-            <a:r>
-              <a:rPr lang="de-DE" sz="1600" dirty="0" err="1" smtClean="0">
+              <a:t>"127.0.0.1</a:t>
+            </a:r>
+            <a:r>
+              <a:rPr lang="de-DE" sz="1600" dirty="0">
                 <a:solidFill>
                   <a:schemeClr val="accent2">
                     <a:lumMod val="75000"/>
@@ -20185,7 +20545,91 @@
                 <a:latin typeface="Courier New" pitchFamily="49" charset="0"/>
                 <a:cs typeface="Courier New" pitchFamily="49" charset="0"/>
               </a:rPr>
-              <a:t>add</a:t>
+              <a:t>"</a:t>
+            </a:r>
+            <a:r>
+              <a:rPr lang="de-DE" sz="1600" dirty="0">
+                <a:latin typeface="Courier New" pitchFamily="49" charset="0"/>
+                <a:cs typeface="Courier New" pitchFamily="49" charset="0"/>
+              </a:rPr>
+              <a:t>, </a:t>
+            </a:r>
+            <a:r>
+              <a:rPr lang="de-DE" sz="1600" dirty="0" smtClean="0">
+                <a:latin typeface="Courier New" pitchFamily="49" charset="0"/>
+                <a:cs typeface="Courier New" pitchFamily="49" charset="0"/>
+              </a:rPr>
+              <a:t>4000</a:t>
+            </a:r>
+            <a:r>
+              <a:rPr lang="de-DE" sz="1600" dirty="0">
+                <a:latin typeface="Courier New" pitchFamily="49" charset="0"/>
+                <a:cs typeface="Courier New" pitchFamily="49" charset="0"/>
+              </a:rPr>
+              <a:t>)</a:t>
+            </a:r>
+            <a:r>
+              <a:rPr lang="nb-NO" sz="1600" dirty="0" smtClean="0">
+                <a:latin typeface="Courier New" pitchFamily="49" charset="0"/>
+                <a:cs typeface="Courier New" pitchFamily="49" charset="0"/>
+              </a:rPr>
+              <a:t>;</a:t>
+            </a:r>
+          </a:p>
+          <a:p>
+            <a:pPr marL="0" indent="0">
+              <a:buNone/>
+            </a:pPr>
+            <a:endParaRPr lang="nb-NO" sz="1600" dirty="0">
+              <a:latin typeface="Courier New" pitchFamily="49" charset="0"/>
+              <a:cs typeface="Courier New" pitchFamily="49" charset="0"/>
+            </a:endParaRPr>
+          </a:p>
+          <a:p>
+            <a:pPr marL="0" indent="0">
+              <a:buNone/>
+            </a:pPr>
+            <a:r>
+              <a:rPr lang="de-DE" sz="1600" dirty="0">
+                <a:latin typeface="Courier New" pitchFamily="49" charset="0"/>
+                <a:cs typeface="Courier New" pitchFamily="49" charset="0"/>
+              </a:rPr>
+              <a:t> </a:t>
+            </a:r>
+            <a:r>
+              <a:rPr lang="de-DE" sz="1600" dirty="0" smtClean="0">
+                <a:latin typeface="Courier New" pitchFamily="49" charset="0"/>
+                <a:cs typeface="Courier New" pitchFamily="49" charset="0"/>
+              </a:rPr>
+              <a:t>   Pt::Http::</a:t>
+            </a:r>
+            <a:r>
+              <a:rPr lang="de-DE" sz="1600" dirty="0" err="1" smtClean="0">
+                <a:latin typeface="Courier New" pitchFamily="49" charset="0"/>
+                <a:cs typeface="Courier New" pitchFamily="49" charset="0"/>
+              </a:rPr>
+              <a:t>MapUrl</a:t>
+            </a:r>
+            <a:r>
+              <a:rPr lang="de-DE" sz="1600" dirty="0" smtClean="0">
+                <a:latin typeface="Courier New" pitchFamily="49" charset="0"/>
+                <a:cs typeface="Courier New" pitchFamily="49" charset="0"/>
+              </a:rPr>
+              <a:t> </a:t>
+            </a:r>
+            <a:r>
+              <a:rPr lang="de-DE" sz="1600" dirty="0" err="1" smtClean="0">
+                <a:latin typeface="Courier New" pitchFamily="49" charset="0"/>
+                <a:cs typeface="Courier New" pitchFamily="49" charset="0"/>
+              </a:rPr>
+              <a:t>mapUrl</a:t>
+            </a:r>
+            <a:r>
+              <a:rPr lang="de-DE" sz="1600" dirty="0" smtClean="0">
+                <a:latin typeface="Courier New" pitchFamily="49" charset="0"/>
+                <a:cs typeface="Courier New" pitchFamily="49" charset="0"/>
+              </a:rPr>
+              <a:t>(</a:t>
             </a:r>
             <a:r>
               <a:rPr lang="de-DE" sz="1600" dirty="0" smtClean="0">
@@ -20197,52 +20641,10 @@
                 <a:latin typeface="Courier New" pitchFamily="49" charset="0"/>
                 <a:cs typeface="Courier New" pitchFamily="49" charset="0"/>
               </a:rPr>
-              <a:t>“</a:t>
-            </a:r>
-            <a:r>
-              <a:rPr lang="de-DE" sz="1600" dirty="0" smtClean="0">
-                <a:latin typeface="Courier New" pitchFamily="49" charset="0"/>
-                <a:cs typeface="Courier New" pitchFamily="49" charset="0"/>
-              </a:rPr>
-              <a:t>, &amp;</a:t>
-            </a:r>
-            <a:r>
-              <a:rPr lang="de-DE" sz="1600" dirty="0" err="1" smtClean="0">
-                <a:latin typeface="Courier New" pitchFamily="49" charset="0"/>
-                <a:cs typeface="Courier New" pitchFamily="49" charset="0"/>
-              </a:rPr>
-              <a:t>add</a:t>
-            </a:r>
-            <a:r>
-              <a:rPr lang="de-DE" sz="1600" dirty="0" smtClean="0">
-                <a:latin typeface="Courier New" pitchFamily="49" charset="0"/>
-                <a:cs typeface="Courier New" pitchFamily="49" charset="0"/>
-              </a:rPr>
-              <a:t>);</a:t>
-            </a:r>
-          </a:p>
-          <a:p>
-            <a:pPr marL="0" indent="0">
-              <a:buNone/>
-            </a:pPr>
-            <a:endParaRPr lang="de-DE" sz="1600" dirty="0" smtClean="0">
-              <a:latin typeface="Courier New" pitchFamily="49" charset="0"/>
-              <a:cs typeface="Courier New" pitchFamily="49" charset="0"/>
-            </a:endParaRPr>
-          </a:p>
-          <a:p>
-            <a:pPr marL="0" indent="0">
-              <a:buNone/>
-            </a:pPr>
-            <a:r>
-              <a:rPr lang="nb-NO" sz="1600" dirty="0" smtClean="0">
-                <a:latin typeface="Courier New" pitchFamily="49" charset="0"/>
-                <a:cs typeface="Courier New" pitchFamily="49" charset="0"/>
-              </a:rPr>
-              <a:t>    Pt::XmlRpc::HttpServer server(loop, </a:t>
-            </a:r>
-            <a:r>
-              <a:rPr lang="de-DE" sz="1600" dirty="0" smtClean="0">
+              <a:t>„/</a:t>
+            </a:r>
+            <a:r>
+              <a:rPr lang="de-DE" sz="1600" dirty="0" err="1">
                 <a:solidFill>
                   <a:schemeClr val="accent2">
                     <a:lumMod val="75000"/>
@@ -20251,7 +20653,7 @@
                 <a:latin typeface="Courier New" pitchFamily="49" charset="0"/>
                 <a:cs typeface="Courier New" pitchFamily="49" charset="0"/>
               </a:rPr>
-              <a:t>"127.0.0.1</a:t>
+              <a:t>calc</a:t>
             </a:r>
             <a:r>
               <a:rPr lang="de-DE" sz="1600" dirty="0">
@@ -20263,126 +20665,6 @@
                 <a:latin typeface="Courier New" pitchFamily="49" charset="0"/>
                 <a:cs typeface="Courier New" pitchFamily="49" charset="0"/>
               </a:rPr>
-              <a:t>"</a:t>
-            </a:r>
-            <a:r>
-              <a:rPr lang="de-DE" sz="1600" dirty="0">
-                <a:latin typeface="Courier New" pitchFamily="49" charset="0"/>
-                <a:cs typeface="Courier New" pitchFamily="49" charset="0"/>
-              </a:rPr>
-              <a:t>, </a:t>
-            </a:r>
-            <a:r>
-              <a:rPr lang="de-DE" sz="1600" dirty="0" smtClean="0">
-                <a:latin typeface="Courier New" pitchFamily="49" charset="0"/>
-                <a:cs typeface="Courier New" pitchFamily="49" charset="0"/>
-              </a:rPr>
-              <a:t>4000</a:t>
-            </a:r>
-            <a:r>
-              <a:rPr lang="de-DE" sz="1600" dirty="0">
-                <a:latin typeface="Courier New" pitchFamily="49" charset="0"/>
-                <a:cs typeface="Courier New" pitchFamily="49" charset="0"/>
-              </a:rPr>
-              <a:t>)</a:t>
-            </a:r>
-            <a:r>
-              <a:rPr lang="nb-NO" sz="1600" dirty="0" smtClean="0">
-                <a:latin typeface="Courier New" pitchFamily="49" charset="0"/>
-                <a:cs typeface="Courier New" pitchFamily="49" charset="0"/>
-              </a:rPr>
-              <a:t>;</a:t>
-            </a:r>
-          </a:p>
-          <a:p>
-            <a:pPr marL="0" indent="0">
-              <a:buNone/>
-            </a:pPr>
-            <a:endParaRPr lang="nb-NO" sz="1600" dirty="0">
-              <a:latin typeface="Courier New" pitchFamily="49" charset="0"/>
-              <a:cs typeface="Courier New" pitchFamily="49" charset="0"/>
-            </a:endParaRPr>
-          </a:p>
-          <a:p>
-            <a:pPr marL="0" indent="0">
-              <a:buNone/>
-            </a:pPr>
-            <a:r>
-              <a:rPr lang="de-DE" sz="1600" dirty="0">
-                <a:latin typeface="Courier New" pitchFamily="49" charset="0"/>
-                <a:cs typeface="Courier New" pitchFamily="49" charset="0"/>
-              </a:rPr>
-              <a:t> </a:t>
-            </a:r>
-            <a:r>
-              <a:rPr lang="de-DE" sz="1600" dirty="0" smtClean="0">
-                <a:latin typeface="Courier New" pitchFamily="49" charset="0"/>
-                <a:cs typeface="Courier New" pitchFamily="49" charset="0"/>
-              </a:rPr>
-              <a:t>   Pt::Http::</a:t>
-            </a:r>
-            <a:r>
-              <a:rPr lang="de-DE" sz="1600" dirty="0" err="1" smtClean="0">
-                <a:latin typeface="Courier New" pitchFamily="49" charset="0"/>
-                <a:cs typeface="Courier New" pitchFamily="49" charset="0"/>
-              </a:rPr>
-              <a:t>MapUrl</a:t>
-            </a:r>
-            <a:r>
-              <a:rPr lang="de-DE" sz="1600" dirty="0" smtClean="0">
-                <a:latin typeface="Courier New" pitchFamily="49" charset="0"/>
-                <a:cs typeface="Courier New" pitchFamily="49" charset="0"/>
-              </a:rPr>
-              <a:t> </a:t>
-            </a:r>
-            <a:r>
-              <a:rPr lang="de-DE" sz="1600" dirty="0" err="1" smtClean="0">
-                <a:latin typeface="Courier New" pitchFamily="49" charset="0"/>
-                <a:cs typeface="Courier New" pitchFamily="49" charset="0"/>
-              </a:rPr>
-              <a:t>mapUrl</a:t>
-            </a:r>
-            <a:r>
-              <a:rPr lang="de-DE" sz="1600" dirty="0" smtClean="0">
-                <a:latin typeface="Courier New" pitchFamily="49" charset="0"/>
-                <a:cs typeface="Courier New" pitchFamily="49" charset="0"/>
-              </a:rPr>
-              <a:t>(</a:t>
-            </a:r>
-            <a:r>
-              <a:rPr lang="de-DE" sz="1600" dirty="0" smtClean="0">
-                <a:solidFill>
-                  <a:schemeClr val="accent2">
-                    <a:lumMod val="75000"/>
-                  </a:schemeClr>
-                </a:solidFill>
-                <a:latin typeface="Courier New" pitchFamily="49" charset="0"/>
-                <a:cs typeface="Courier New" pitchFamily="49" charset="0"/>
-              </a:rPr>
-              <a:t>„/</a:t>
-            </a:r>
-            <a:r>
-              <a:rPr lang="de-DE" sz="1600" dirty="0" err="1">
-                <a:solidFill>
-                  <a:schemeClr val="accent2">
-                    <a:lumMod val="75000"/>
-                  </a:schemeClr>
-                </a:solidFill>
-                <a:latin typeface="Courier New" pitchFamily="49" charset="0"/>
-                <a:cs typeface="Courier New" pitchFamily="49" charset="0"/>
-              </a:rPr>
-              <a:t>calc</a:t>
-            </a:r>
-            <a:r>
-              <a:rPr lang="de-DE" sz="1600" dirty="0">
-                <a:solidFill>
-                  <a:schemeClr val="accent2">
-                    <a:lumMod val="75000"/>
-                  </a:schemeClr>
-                </a:solidFill>
-                <a:latin typeface="Courier New" pitchFamily="49" charset="0"/>
-                <a:cs typeface="Courier New" pitchFamily="49" charset="0"/>
-              </a:rPr>
               <a:t>“</a:t>
             </a:r>
             <a:r>
@@ -20450,10 +20732,6 @@
               </a:rPr>
               <a:t>);</a:t>
             </a:r>
-            <a:endParaRPr lang="de-DE" sz="1600" dirty="0" smtClean="0">
-              <a:latin typeface="Courier New" pitchFamily="49" charset="0"/>
-              <a:cs typeface="Courier New" pitchFamily="49" charset="0"/>
-            </a:endParaRPr>
           </a:p>
           <a:p>
             <a:pPr marL="0" indent="0">
@@ -20598,15 +20876,7 @@
             </a:r>
             <a:r>
               <a:rPr lang="de-DE" sz="2800" dirty="0" smtClean="0"/>
-              <a:t> </a:t>
-            </a:r>
-            <a:r>
-              <a:rPr lang="de-DE" sz="2800" dirty="0" smtClean="0"/>
-              <a:t>XML-RPC </a:t>
-            </a:r>
-            <a:r>
-              <a:rPr lang="de-DE" sz="2800" dirty="0" smtClean="0"/>
-              <a:t>Clients </a:t>
+              <a:t> XML-RPC Clients </a:t>
             </a:r>
             <a:r>
               <a:rPr lang="de-DE" sz="2800" dirty="0" err="1" smtClean="0"/>
@@ -20614,11 +20884,7 @@
             </a:r>
             <a:r>
               <a:rPr lang="de-DE" sz="2800" dirty="0" smtClean="0"/>
-              <a:t> </a:t>
-            </a:r>
-            <a:r>
-              <a:rPr lang="de-DE" sz="2800" dirty="0" smtClean="0"/>
-              <a:t>Services (1)</a:t>
+              <a:t> Services (1)</a:t>
             </a:r>
             <a:endParaRPr lang="en-US" sz="2800" dirty="0"/>
           </a:p>
@@ -21736,14 +22002,7 @@
                 <a:latin typeface="Courier New" pitchFamily="49" charset="0"/>
                 <a:cs typeface="Courier New" pitchFamily="49" charset="0"/>
               </a:rPr>
-              <a:t>Position</a:t>
-            </a:r>
-            <a:r>
-              <a:rPr lang="de-DE" sz="1400" dirty="0" err="1" smtClean="0">
-                <a:latin typeface="Courier New" pitchFamily="49" charset="0"/>
-                <a:cs typeface="Courier New" pitchFamily="49" charset="0"/>
-              </a:rPr>
-              <a:t>Info</a:t>
+              <a:t>PositionInfo</a:t>
             </a:r>
             <a:r>
               <a:rPr lang="de-DE" sz="1400" dirty="0" smtClean="0">
@@ -21821,15 +22080,6 @@
               </a:rPr>
               <a:t>“);</a:t>
             </a:r>
-            <a:endParaRPr lang="de-DE" sz="1400" dirty="0" smtClean="0">
-              <a:solidFill>
-                <a:schemeClr val="accent2">
-                  <a:lumMod val="75000"/>
-                </a:schemeClr>
-              </a:solidFill>
-              <a:latin typeface="Courier New" pitchFamily="49" charset="0"/>
-              <a:cs typeface="Courier New" pitchFamily="49" charset="0"/>
-            </a:endParaRPr>
           </a:p>
           <a:p>
             <a:pPr marL="0" indent="0">
@@ -21941,13 +22191,7 @@
               <a:rPr lang="de-DE" sz="1400" dirty="0" err="1" smtClean="0">
                 <a:cs typeface="Courier New" pitchFamily="49" charset="0"/>
               </a:rPr>
-              <a:t>Position</a:t>
-            </a:r>
-            <a:r>
-              <a:rPr lang="de-DE" sz="1400" dirty="0" err="1" smtClean="0">
-                <a:cs typeface="Courier New" pitchFamily="49" charset="0"/>
-              </a:rPr>
-              <a:t>Info</a:t>
+              <a:t>PositionInfo</a:t>
             </a:r>
             <a:endParaRPr lang="de-DE" sz="1400" dirty="0" smtClean="0">
               <a:cs typeface="Courier New" pitchFamily="49" charset="0"/>
@@ -22552,19 +22796,7 @@
               <a:rPr lang="de-DE" sz="1300" dirty="0" smtClean="0">
                 <a:cs typeface="Courier New" pitchFamily="49" charset="0"/>
               </a:rPr>
-              <a:t> </a:t>
-            </a:r>
-            <a:r>
-              <a:rPr lang="de-DE" sz="1300" dirty="0" smtClean="0">
-                <a:cs typeface="Courier New" pitchFamily="49" charset="0"/>
-              </a:rPr>
-              <a:t>C</a:t>
-            </a:r>
-            <a:r>
-              <a:rPr lang="de-DE" sz="1300" dirty="0" smtClean="0">
-                <a:cs typeface="Courier New" pitchFamily="49" charset="0"/>
-              </a:rPr>
-              <a:t>++ </a:t>
+              <a:t> C++ </a:t>
             </a:r>
             <a:r>
               <a:rPr lang="de-DE" sz="1300" dirty="0" err="1" smtClean="0">
@@ -22717,14 +22949,7 @@
                 <a:latin typeface="Courier New" pitchFamily="49" charset="0"/>
                 <a:cs typeface="Courier New" pitchFamily="49" charset="0"/>
               </a:rPr>
-              <a:t>Position</a:t>
-            </a:r>
-            <a:r>
-              <a:rPr lang="de-DE" sz="1400" dirty="0" err="1" smtClean="0">
-                <a:latin typeface="Courier New" pitchFamily="49" charset="0"/>
-                <a:cs typeface="Courier New" pitchFamily="49" charset="0"/>
-              </a:rPr>
-              <a:t>Info</a:t>
+              <a:t>PositionInfo</a:t>
             </a:r>
             <a:endParaRPr lang="de-DE" sz="1400" dirty="0">
               <a:latin typeface="Courier New" pitchFamily="49" charset="0"/>
@@ -22835,18 +23060,18 @@
               <a:t>&amp; si, </a:t>
             </a:r>
             <a:r>
-              <a:rPr lang="de-DE" sz="1400" dirty="0" err="1">
+              <a:rPr lang="de-DE" sz="1400" dirty="0" err="1" smtClean="0">
                 <a:latin typeface="Courier New" pitchFamily="49" charset="0"/>
                 <a:cs typeface="Courier New" pitchFamily="49" charset="0"/>
               </a:rPr>
               <a:t>PositionInfo</a:t>
             </a:r>
             <a:r>
-              <a:rPr lang="de-DE" sz="1400" dirty="0">
-                <a:latin typeface="Courier New" pitchFamily="49" charset="0"/>
-                <a:cs typeface="Courier New" pitchFamily="49" charset="0"/>
-              </a:rPr>
-              <a:t> &amp; </a:t>
+              <a:rPr lang="de-DE" sz="1400" dirty="0" smtClean="0">
+                <a:latin typeface="Courier New" pitchFamily="49" charset="0"/>
+                <a:cs typeface="Courier New" pitchFamily="49" charset="0"/>
+              </a:rPr>
+              <a:t>&amp; </a:t>
             </a:r>
             <a:r>
               <a:rPr lang="de-DE" sz="1400" dirty="0">
@@ -22948,18 +23173,18 @@
               <a:t> </a:t>
             </a:r>
             <a:r>
-              <a:rPr lang="de-DE" sz="1400" dirty="0" err="1">
+              <a:rPr lang="de-DE" sz="1400" dirty="0" err="1" smtClean="0">
                 <a:latin typeface="Courier New" pitchFamily="49" charset="0"/>
                 <a:cs typeface="Courier New" pitchFamily="49" charset="0"/>
               </a:rPr>
               <a:t>PositionInfo</a:t>
             </a:r>
             <a:r>
-              <a:rPr lang="de-DE" sz="1400" dirty="0">
-                <a:latin typeface="Courier New" pitchFamily="49" charset="0"/>
-                <a:cs typeface="Courier New" pitchFamily="49" charset="0"/>
-              </a:rPr>
-              <a:t> &amp; </a:t>
+              <a:rPr lang="de-DE" sz="1400" dirty="0" smtClean="0">
+                <a:latin typeface="Courier New" pitchFamily="49" charset="0"/>
+                <a:cs typeface="Courier New" pitchFamily="49" charset="0"/>
+              </a:rPr>
+              <a:t>&amp; </a:t>
             </a:r>
             <a:r>
               <a:rPr lang="de-DE" sz="1400" dirty="0">
@@ -23057,33 +23282,8 @@
                 <a:latin typeface="Courier New" pitchFamily="49" charset="0"/>
                 <a:cs typeface="Courier New" pitchFamily="49" charset="0"/>
               </a:rPr>
-              <a:t>   : </a:t>
-            </a:r>
-            <a:r>
-              <a:rPr lang="de-DE" sz="1400" dirty="0" smtClean="0">
-                <a:latin typeface="Courier New" pitchFamily="49" charset="0"/>
-                <a:cs typeface="Courier New" pitchFamily="49" charset="0"/>
-              </a:rPr>
-              <a:t>_x(0</a:t>
-            </a:r>
-            <a:r>
-              <a:rPr lang="de-DE" sz="1400" dirty="0" smtClean="0">
-                <a:latin typeface="Courier New" pitchFamily="49" charset="0"/>
-                <a:cs typeface="Courier New" pitchFamily="49" charset="0"/>
-              </a:rPr>
-              <a:t>), </a:t>
-            </a:r>
-            <a:r>
-              <a:rPr lang="de-DE" sz="1400" dirty="0" smtClean="0">
-                <a:latin typeface="Courier New" pitchFamily="49" charset="0"/>
-                <a:cs typeface="Courier New" pitchFamily="49" charset="0"/>
-              </a:rPr>
-              <a:t>_y(0)    </a:t>
-            </a:r>
-            <a:endParaRPr lang="de-DE" sz="1400" dirty="0" smtClean="0">
-              <a:latin typeface="Courier New" pitchFamily="49" charset="0"/>
-              <a:cs typeface="Courier New" pitchFamily="49" charset="0"/>
-            </a:endParaRPr>
+              <a:t>   : _x(0), _y(0)    </a:t>
+            </a:r>
           </a:p>
           <a:p>
             <a:pPr marL="0" indent="0">
@@ -23178,14 +23378,7 @@
                 <a:latin typeface="Courier New" pitchFamily="49" charset="0"/>
                 <a:cs typeface="Courier New" pitchFamily="49" charset="0"/>
               </a:rPr>
-              <a:t>    </a:t>
-            </a:r>
-            <a:r>
-              <a:rPr lang="de-DE" sz="1400" dirty="0">
-                <a:latin typeface="Courier New" pitchFamily="49" charset="0"/>
-                <a:cs typeface="Courier New" pitchFamily="49" charset="0"/>
-              </a:rPr>
-              <a:t>Pt::uint32_t </a:t>
+              <a:t>    Pt::uint32_t </a:t>
             </a:r>
             <a:r>
               <a:rPr lang="de-DE" sz="1400" dirty="0" smtClean="0">
@@ -23309,25 +23502,25 @@
               <a:t>&amp; si, </a:t>
             </a:r>
             <a:r>
-              <a:rPr lang="de-DE" sz="1400" dirty="0" err="1">
+              <a:rPr lang="de-DE" sz="1400" dirty="0" err="1" smtClean="0">
                 <a:latin typeface="Courier New" pitchFamily="49" charset="0"/>
                 <a:cs typeface="Courier New" pitchFamily="49" charset="0"/>
               </a:rPr>
               <a:t>PositionInfo</a:t>
             </a:r>
             <a:r>
-              <a:rPr lang="de-DE" sz="1400" dirty="0">
-                <a:latin typeface="Courier New" pitchFamily="49" charset="0"/>
-                <a:cs typeface="Courier New" pitchFamily="49" charset="0"/>
-              </a:rPr>
-              <a:t> </a:t>
-            </a:r>
-            <a:r>
               <a:rPr lang="it-IT" sz="1400" dirty="0" smtClean="0">
                 <a:latin typeface="Courier New" pitchFamily="49" charset="0"/>
                 <a:cs typeface="Courier New" pitchFamily="49" charset="0"/>
               </a:rPr>
-              <a:t>&amp; p)</a:t>
+              <a:t>&amp; </a:t>
+            </a:r>
+            <a:r>
+              <a:rPr lang="it-IT" sz="1400" dirty="0" smtClean="0">
+                <a:latin typeface="Courier New" pitchFamily="49" charset="0"/>
+                <a:cs typeface="Courier New" pitchFamily="49" charset="0"/>
+              </a:rPr>
+              <a:t>p)</a:t>
             </a:r>
             <a:endParaRPr lang="it-IT" sz="1400" dirty="0">
               <a:latin typeface="Courier New" pitchFamily="49" charset="0"/>
@@ -23381,7 +23574,79 @@
                 <a:latin typeface="Courier New" pitchFamily="49" charset="0"/>
                 <a:cs typeface="Courier New" pitchFamily="49" charset="0"/>
               </a:rPr>
-              <a:t>„</a:t>
+              <a:t>„x"</a:t>
+            </a:r>
+            <a:r>
+              <a:rPr lang="de-DE" sz="1400" dirty="0" smtClean="0">
+                <a:latin typeface="Courier New" pitchFamily="49" charset="0"/>
+                <a:cs typeface="Courier New" pitchFamily="49" charset="0"/>
+              </a:rPr>
+              <a:t>) </a:t>
+            </a:r>
+            <a:r>
+              <a:rPr lang="de-DE" sz="1400" dirty="0">
+                <a:latin typeface="Courier New" pitchFamily="49" charset="0"/>
+                <a:cs typeface="Courier New" pitchFamily="49" charset="0"/>
+              </a:rPr>
+              <a:t>&gt;&gt;= </a:t>
+            </a:r>
+            <a:r>
+              <a:rPr lang="de-DE" sz="1400" dirty="0" err="1">
+                <a:latin typeface="Courier New" pitchFamily="49" charset="0"/>
+                <a:cs typeface="Courier New" pitchFamily="49" charset="0"/>
+              </a:rPr>
+              <a:t>p</a:t>
+            </a:r>
+            <a:r>
+              <a:rPr lang="de-DE" sz="1400" dirty="0" err="1" smtClean="0">
+                <a:latin typeface="Courier New" pitchFamily="49" charset="0"/>
+                <a:cs typeface="Courier New" pitchFamily="49" charset="0"/>
+              </a:rPr>
+              <a:t>._</a:t>
+            </a:r>
+            <a:r>
+              <a:rPr lang="de-DE" sz="1400" dirty="0" err="1">
+                <a:latin typeface="Courier New" pitchFamily="49" charset="0"/>
+                <a:cs typeface="Courier New" pitchFamily="49" charset="0"/>
+              </a:rPr>
+              <a:t>x</a:t>
+            </a:r>
+            <a:r>
+              <a:rPr lang="de-DE" sz="1400" dirty="0" smtClean="0">
+                <a:latin typeface="Courier New" pitchFamily="49" charset="0"/>
+                <a:cs typeface="Courier New" pitchFamily="49" charset="0"/>
+              </a:rPr>
+              <a:t>;</a:t>
+            </a:r>
+            <a:endParaRPr lang="de-DE" sz="1400" dirty="0">
+              <a:latin typeface="Courier New" pitchFamily="49" charset="0"/>
+              <a:cs typeface="Courier New" pitchFamily="49" charset="0"/>
+            </a:endParaRPr>
+          </a:p>
+          <a:p>
+            <a:pPr marL="0" indent="0">
+              <a:buNone/>
+            </a:pPr>
+            <a:r>
+              <a:rPr lang="de-DE" sz="1400" dirty="0">
+                <a:latin typeface="Courier New" pitchFamily="49" charset="0"/>
+                <a:cs typeface="Courier New" pitchFamily="49" charset="0"/>
+              </a:rPr>
+              <a:t>  </a:t>
+            </a:r>
+            <a:r>
+              <a:rPr lang="de-DE" sz="1400" dirty="0" err="1">
+                <a:latin typeface="Courier New" pitchFamily="49" charset="0"/>
+                <a:cs typeface="Courier New" pitchFamily="49" charset="0"/>
+              </a:rPr>
+              <a:t>si.getMember</a:t>
+            </a:r>
+            <a:r>
+              <a:rPr lang="de-DE" sz="1400" dirty="0" smtClean="0">
+                <a:latin typeface="Courier New" pitchFamily="49" charset="0"/>
+                <a:cs typeface="Courier New" pitchFamily="49" charset="0"/>
+              </a:rPr>
+              <a:t>(</a:t>
             </a:r>
             <a:r>
               <a:rPr lang="de-DE" sz="1400" dirty="0" smtClean="0">
@@ -23393,7 +23658,226 @@
                 <a:latin typeface="Courier New" pitchFamily="49" charset="0"/>
                 <a:cs typeface="Courier New" pitchFamily="49" charset="0"/>
               </a:rPr>
-              <a:t>x</a:t>
+              <a:t>„y"</a:t>
+            </a:r>
+            <a:r>
+              <a:rPr lang="de-DE" sz="1400" dirty="0" smtClean="0">
+                <a:latin typeface="Courier New" pitchFamily="49" charset="0"/>
+                <a:cs typeface="Courier New" pitchFamily="49" charset="0"/>
+              </a:rPr>
+              <a:t>) </a:t>
+            </a:r>
+            <a:r>
+              <a:rPr lang="de-DE" sz="1400" dirty="0">
+                <a:latin typeface="Courier New" pitchFamily="49" charset="0"/>
+                <a:cs typeface="Courier New" pitchFamily="49" charset="0"/>
+              </a:rPr>
+              <a:t>&gt;&gt;= </a:t>
+            </a:r>
+            <a:r>
+              <a:rPr lang="de-DE" sz="1400" dirty="0" err="1">
+                <a:latin typeface="Courier New" pitchFamily="49" charset="0"/>
+                <a:cs typeface="Courier New" pitchFamily="49" charset="0"/>
+              </a:rPr>
+              <a:t>p</a:t>
+            </a:r>
+            <a:r>
+              <a:rPr lang="de-DE" sz="1400" dirty="0" err="1" smtClean="0">
+                <a:latin typeface="Courier New" pitchFamily="49" charset="0"/>
+                <a:cs typeface="Courier New" pitchFamily="49" charset="0"/>
+              </a:rPr>
+              <a:t>._</a:t>
+            </a:r>
+            <a:r>
+              <a:rPr lang="de-DE" sz="1400" dirty="0" err="1">
+                <a:latin typeface="Courier New" pitchFamily="49" charset="0"/>
+                <a:cs typeface="Courier New" pitchFamily="49" charset="0"/>
+              </a:rPr>
+              <a:t>y</a:t>
+            </a:r>
+            <a:r>
+              <a:rPr lang="de-DE" sz="1400" dirty="0" smtClean="0">
+                <a:latin typeface="Courier New" pitchFamily="49" charset="0"/>
+                <a:cs typeface="Courier New" pitchFamily="49" charset="0"/>
+              </a:rPr>
+              <a:t>;</a:t>
+            </a:r>
+            <a:endParaRPr lang="de-DE" sz="1400" dirty="0">
+              <a:latin typeface="Courier New" pitchFamily="49" charset="0"/>
+              <a:cs typeface="Courier New" pitchFamily="49" charset="0"/>
+            </a:endParaRPr>
+          </a:p>
+          <a:p>
+            <a:pPr marL="0" indent="0">
+              <a:buNone/>
+            </a:pPr>
+            <a:r>
+              <a:rPr lang="de-DE" sz="1400" dirty="0" smtClean="0">
+                <a:latin typeface="Courier New" pitchFamily="49" charset="0"/>
+                <a:cs typeface="Courier New" pitchFamily="49" charset="0"/>
+              </a:rPr>
+              <a:t>}</a:t>
+            </a:r>
+            <a:endParaRPr lang="de-DE" sz="1400" dirty="0">
+              <a:latin typeface="Courier New" pitchFamily="49" charset="0"/>
+              <a:cs typeface="Courier New" pitchFamily="49" charset="0"/>
+            </a:endParaRPr>
+          </a:p>
+          <a:p>
+            <a:pPr marL="0" indent="0">
+              <a:buNone/>
+            </a:pPr>
+            <a:endParaRPr lang="de-DE" sz="1400" dirty="0">
+              <a:latin typeface="Courier New" pitchFamily="49" charset="0"/>
+              <a:cs typeface="Courier New" pitchFamily="49" charset="0"/>
+            </a:endParaRPr>
+          </a:p>
+          <a:p>
+            <a:pPr marL="0" indent="0">
+              <a:buNone/>
+            </a:pPr>
+            <a:r>
+              <a:rPr lang="it-IT" sz="1400" dirty="0" err="1">
+                <a:solidFill>
+                  <a:schemeClr val="accent2">
+                    <a:lumMod val="75000"/>
+                  </a:schemeClr>
+                </a:solidFill>
+                <a:latin typeface="Courier New" pitchFamily="49" charset="0"/>
+                <a:cs typeface="Courier New" pitchFamily="49" charset="0"/>
+              </a:rPr>
+              <a:t>void</a:t>
+            </a:r>
+            <a:r>
+              <a:rPr lang="it-IT" sz="1400" dirty="0">
+                <a:latin typeface="Courier New" pitchFamily="49" charset="0"/>
+                <a:cs typeface="Courier New" pitchFamily="49" charset="0"/>
+              </a:rPr>
+              <a:t> </a:t>
+            </a:r>
+            <a:r>
+              <a:rPr lang="it-IT" sz="1400" b="1" dirty="0">
+                <a:latin typeface="Courier New" pitchFamily="49" charset="0"/>
+                <a:cs typeface="Courier New" pitchFamily="49" charset="0"/>
+              </a:rPr>
+              <a:t>operator</a:t>
+            </a:r>
+            <a:r>
+              <a:rPr lang="it-IT" sz="1400" dirty="0">
+                <a:latin typeface="Courier New" pitchFamily="49" charset="0"/>
+                <a:cs typeface="Courier New" pitchFamily="49" charset="0"/>
+              </a:rPr>
+              <a:t>&lt;&lt;=(</a:t>
+            </a:r>
+            <a:r>
+              <a:rPr lang="it-IT" sz="1400" dirty="0" err="1">
+                <a:latin typeface="Courier New" pitchFamily="49" charset="0"/>
+                <a:cs typeface="Courier New" pitchFamily="49" charset="0"/>
+              </a:rPr>
+              <a:t>Pt</a:t>
+            </a:r>
+            <a:r>
+              <a:rPr lang="it-IT" sz="1400" dirty="0">
+                <a:latin typeface="Courier New" pitchFamily="49" charset="0"/>
+                <a:cs typeface="Courier New" pitchFamily="49" charset="0"/>
+              </a:rPr>
+              <a:t>::</a:t>
+            </a:r>
+            <a:r>
+              <a:rPr lang="it-IT" sz="1400" dirty="0" err="1">
+                <a:latin typeface="Courier New" pitchFamily="49" charset="0"/>
+                <a:cs typeface="Courier New" pitchFamily="49" charset="0"/>
+              </a:rPr>
+              <a:t>SerializationInfo</a:t>
+            </a:r>
+            <a:r>
+              <a:rPr lang="it-IT" sz="1400" dirty="0">
+                <a:latin typeface="Courier New" pitchFamily="49" charset="0"/>
+                <a:cs typeface="Courier New" pitchFamily="49" charset="0"/>
+              </a:rPr>
+              <a:t>&amp; si, </a:t>
+            </a:r>
+            <a:r>
+              <a:rPr lang="it-IT" sz="1400" dirty="0" err="1">
+                <a:solidFill>
+                  <a:schemeClr val="accent2">
+                    <a:lumMod val="75000"/>
+                  </a:schemeClr>
+                </a:solidFill>
+                <a:latin typeface="Courier New" pitchFamily="49" charset="0"/>
+                <a:cs typeface="Courier New" pitchFamily="49" charset="0"/>
+              </a:rPr>
+              <a:t>const</a:t>
+            </a:r>
+            <a:r>
+              <a:rPr lang="it-IT" sz="1400" dirty="0">
+                <a:latin typeface="Courier New" pitchFamily="49" charset="0"/>
+                <a:cs typeface="Courier New" pitchFamily="49" charset="0"/>
+              </a:rPr>
+              <a:t> </a:t>
+            </a:r>
+            <a:r>
+              <a:rPr lang="de-DE" sz="1400" dirty="0" err="1" smtClean="0">
+                <a:latin typeface="Courier New" pitchFamily="49" charset="0"/>
+                <a:cs typeface="Courier New" pitchFamily="49" charset="0"/>
+              </a:rPr>
+              <a:t>PositionInfo</a:t>
+            </a:r>
+            <a:r>
+              <a:rPr lang="it-IT" sz="1400" dirty="0" smtClean="0">
+                <a:latin typeface="Courier New" pitchFamily="49" charset="0"/>
+                <a:cs typeface="Courier New" pitchFamily="49" charset="0"/>
+              </a:rPr>
+              <a:t>&amp; </a:t>
+            </a:r>
+            <a:r>
+              <a:rPr lang="it-IT" sz="1400" dirty="0" smtClean="0">
+                <a:latin typeface="Courier New" pitchFamily="49" charset="0"/>
+                <a:cs typeface="Courier New" pitchFamily="49" charset="0"/>
+              </a:rPr>
+              <a:t>p)</a:t>
+            </a:r>
+            <a:endParaRPr lang="it-IT" sz="1400" dirty="0">
+              <a:latin typeface="Courier New" pitchFamily="49" charset="0"/>
+              <a:cs typeface="Courier New" pitchFamily="49" charset="0"/>
+            </a:endParaRPr>
+          </a:p>
+          <a:p>
+            <a:pPr marL="0" indent="0">
+              <a:buNone/>
+            </a:pPr>
+            <a:r>
+              <a:rPr lang="de-DE" sz="1400" dirty="0">
+                <a:latin typeface="Courier New" pitchFamily="49" charset="0"/>
+                <a:cs typeface="Courier New" pitchFamily="49" charset="0"/>
+              </a:rPr>
+              <a:t>{</a:t>
+            </a:r>
+          </a:p>
+          <a:p>
+            <a:pPr marL="0" indent="0">
+              <a:buNone/>
+            </a:pPr>
+            <a:r>
+              <a:rPr lang="de-DE" sz="1400" dirty="0">
+                <a:latin typeface="Courier New" pitchFamily="49" charset="0"/>
+                <a:cs typeface="Courier New" pitchFamily="49" charset="0"/>
+              </a:rPr>
+              <a:t>  </a:t>
+            </a:r>
+            <a:r>
+              <a:rPr lang="de-DE" sz="1400" dirty="0" err="1">
+                <a:latin typeface="Courier New" pitchFamily="49" charset="0"/>
+                <a:cs typeface="Courier New" pitchFamily="49" charset="0"/>
+              </a:rPr>
+              <a:t>si.setTypeName</a:t>
+            </a:r>
+            <a:r>
+              <a:rPr lang="de-DE" sz="1400" dirty="0" smtClean="0">
+                <a:latin typeface="Courier New" pitchFamily="49" charset="0"/>
+                <a:cs typeface="Courier New" pitchFamily="49" charset="0"/>
+              </a:rPr>
+              <a:t>(</a:t>
             </a:r>
             <a:r>
               <a:rPr lang="de-DE" sz="1400" dirty="0" smtClean="0">
@@ -23405,72 +23889,57 @@
                 <a:latin typeface="Courier New" pitchFamily="49" charset="0"/>
                 <a:cs typeface="Courier New" pitchFamily="49" charset="0"/>
               </a:rPr>
+              <a:t>„</a:t>
+            </a:r>
+            <a:r>
+              <a:rPr lang="de-DE" sz="1400" dirty="0" err="1" smtClean="0">
+                <a:solidFill>
+                  <a:schemeClr val="accent2">
+                    <a:lumMod val="75000"/>
+                  </a:schemeClr>
+                </a:solidFill>
+                <a:latin typeface="Courier New" pitchFamily="49" charset="0"/>
+                <a:cs typeface="Courier New" pitchFamily="49" charset="0"/>
+              </a:rPr>
+              <a:t>PositionInfo</a:t>
+            </a:r>
+            <a:r>
+              <a:rPr lang="de-DE" sz="1400" dirty="0">
+                <a:solidFill>
+                  <a:schemeClr val="accent2">
+                    <a:lumMod val="75000"/>
+                  </a:schemeClr>
+                </a:solidFill>
+                <a:latin typeface="Courier New" pitchFamily="49" charset="0"/>
+                <a:cs typeface="Courier New" pitchFamily="49" charset="0"/>
+              </a:rPr>
               <a:t>"</a:t>
             </a:r>
             <a:r>
-              <a:rPr lang="de-DE" sz="1400" dirty="0" smtClean="0">
-                <a:latin typeface="Courier New" pitchFamily="49" charset="0"/>
-                <a:cs typeface="Courier New" pitchFamily="49" charset="0"/>
-              </a:rPr>
-              <a:t>) </a:t>
-            </a:r>
-            <a:r>
               <a:rPr lang="de-DE" sz="1400" dirty="0">
                 <a:latin typeface="Courier New" pitchFamily="49" charset="0"/>
                 <a:cs typeface="Courier New" pitchFamily="49" charset="0"/>
               </a:rPr>
-              <a:t>&gt;&gt;= </a:t>
+              <a:t>);</a:t>
+            </a:r>
+          </a:p>
+          <a:p>
+            <a:pPr marL="0" indent="0">
+              <a:buNone/>
+            </a:pPr>
+            <a:r>
+              <a:rPr lang="de-DE" sz="1400" dirty="0">
+                <a:latin typeface="Courier New" pitchFamily="49" charset="0"/>
+                <a:cs typeface="Courier New" pitchFamily="49" charset="0"/>
+              </a:rPr>
+              <a:t>  </a:t>
             </a:r>
             <a:r>
               <a:rPr lang="de-DE" sz="1400" dirty="0" err="1">
                 <a:latin typeface="Courier New" pitchFamily="49" charset="0"/>
                 <a:cs typeface="Courier New" pitchFamily="49" charset="0"/>
               </a:rPr>
-              <a:t>p</a:t>
-            </a:r>
-            <a:r>
-              <a:rPr lang="de-DE" sz="1400" dirty="0" err="1" smtClean="0">
-                <a:latin typeface="Courier New" pitchFamily="49" charset="0"/>
-                <a:cs typeface="Courier New" pitchFamily="49" charset="0"/>
-              </a:rPr>
-              <a:t>._</a:t>
-            </a:r>
-            <a:r>
-              <a:rPr lang="de-DE" sz="1400" dirty="0" err="1">
-                <a:latin typeface="Courier New" pitchFamily="49" charset="0"/>
-                <a:cs typeface="Courier New" pitchFamily="49" charset="0"/>
-              </a:rPr>
-              <a:t>x</a:t>
-            </a:r>
-            <a:r>
-              <a:rPr lang="de-DE" sz="1400" dirty="0" smtClean="0">
-                <a:latin typeface="Courier New" pitchFamily="49" charset="0"/>
-                <a:cs typeface="Courier New" pitchFamily="49" charset="0"/>
-              </a:rPr>
-              <a:t>;</a:t>
-            </a:r>
-            <a:endParaRPr lang="de-DE" sz="1400" dirty="0">
-              <a:latin typeface="Courier New" pitchFamily="49" charset="0"/>
-              <a:cs typeface="Courier New" pitchFamily="49" charset="0"/>
-            </a:endParaRPr>
-          </a:p>
-          <a:p>
-            <a:pPr marL="0" indent="0">
-              <a:buNone/>
-            </a:pPr>
-            <a:r>
-              <a:rPr lang="de-DE" sz="1400" dirty="0">
-                <a:latin typeface="Courier New" pitchFamily="49" charset="0"/>
-                <a:cs typeface="Courier New" pitchFamily="49" charset="0"/>
-              </a:rPr>
-              <a:t>  </a:t>
-            </a:r>
-            <a:r>
-              <a:rPr lang="de-DE" sz="1400" dirty="0" err="1">
-                <a:latin typeface="Courier New" pitchFamily="49" charset="0"/>
-                <a:cs typeface="Courier New" pitchFamily="49" charset="0"/>
-              </a:rPr>
-              <a:t>si.getMember</a:t>
+              <a:t>si.addMember</a:t>
             </a:r>
             <a:r>
               <a:rPr lang="de-DE" sz="1400" dirty="0" smtClean="0">
@@ -23489,7 +23958,7 @@
                 <a:latin typeface="Courier New" pitchFamily="49" charset="0"/>
                 <a:cs typeface="Courier New" pitchFamily="49" charset="0"/>
               </a:rPr>
-              <a:t>„y"</a:t>
+              <a:t>„x"</a:t>
             </a:r>
             <a:r>
               <a:rPr lang="de-DE" sz="1400" dirty="0" smtClean="0">
@@ -23503,7 +23972,7 @@
                 <a:latin typeface="Courier New" pitchFamily="49" charset="0"/>
                 <a:cs typeface="Courier New" pitchFamily="49" charset="0"/>
               </a:rPr>
-              <a:t>&gt;&gt;= </a:t>
+              <a:t>&lt;&lt;= </a:t>
             </a:r>
             <a:r>
               <a:rPr lang="de-DE" sz="1400" dirty="0" err="1">
@@ -23524,7 +23993,7 @@
                 <a:latin typeface="Courier New" pitchFamily="49" charset="0"/>
                 <a:cs typeface="Courier New" pitchFamily="49" charset="0"/>
               </a:rPr>
-              <a:t>y</a:t>
+              <a:t>x</a:t>
             </a:r>
             <a:r>
               <a:rPr lang="de-DE" sz="1400" dirty="0" smtClean="0">
@@ -23543,165 +24012,18 @@
               <a:buNone/>
             </a:pPr>
             <a:r>
-              <a:rPr lang="de-DE" sz="1400" dirty="0" smtClean="0">
-                <a:latin typeface="Courier New" pitchFamily="49" charset="0"/>
-                <a:cs typeface="Courier New" pitchFamily="49" charset="0"/>
-              </a:rPr>
-              <a:t>}</a:t>
-            </a:r>
-            <a:endParaRPr lang="de-DE" sz="1400" dirty="0">
-              <a:latin typeface="Courier New" pitchFamily="49" charset="0"/>
-              <a:cs typeface="Courier New" pitchFamily="49" charset="0"/>
-            </a:endParaRPr>
-          </a:p>
-          <a:p>
-            <a:pPr marL="0" indent="0">
-              <a:buNone/>
-            </a:pPr>
-            <a:endParaRPr lang="de-DE" sz="1400" dirty="0">
-              <a:latin typeface="Courier New" pitchFamily="49" charset="0"/>
-              <a:cs typeface="Courier New" pitchFamily="49" charset="0"/>
-            </a:endParaRPr>
-          </a:p>
-          <a:p>
-            <a:pPr marL="0" indent="0">
-              <a:buNone/>
-            </a:pPr>
-            <a:r>
-              <a:rPr lang="it-IT" sz="1400" dirty="0" err="1">
-                <a:solidFill>
-                  <a:schemeClr val="accent2">
-                    <a:lumMod val="75000"/>
-                  </a:schemeClr>
-                </a:solidFill>
-                <a:latin typeface="Courier New" pitchFamily="49" charset="0"/>
-                <a:cs typeface="Courier New" pitchFamily="49" charset="0"/>
-              </a:rPr>
-              <a:t>void</a:t>
-            </a:r>
-            <a:r>
-              <a:rPr lang="it-IT" sz="1400" dirty="0">
-                <a:latin typeface="Courier New" pitchFamily="49" charset="0"/>
-                <a:cs typeface="Courier New" pitchFamily="49" charset="0"/>
-              </a:rPr>
-              <a:t> </a:t>
-            </a:r>
-            <a:r>
-              <a:rPr lang="it-IT" sz="1400" b="1" dirty="0">
-                <a:latin typeface="Courier New" pitchFamily="49" charset="0"/>
-                <a:cs typeface="Courier New" pitchFamily="49" charset="0"/>
-              </a:rPr>
-              <a:t>operator</a:t>
-            </a:r>
-            <a:r>
-              <a:rPr lang="it-IT" sz="1400" dirty="0">
-                <a:latin typeface="Courier New" pitchFamily="49" charset="0"/>
-                <a:cs typeface="Courier New" pitchFamily="49" charset="0"/>
-              </a:rPr>
-              <a:t>&lt;&lt;=(</a:t>
-            </a:r>
-            <a:r>
-              <a:rPr lang="it-IT" sz="1400" dirty="0" err="1">
-                <a:latin typeface="Courier New" pitchFamily="49" charset="0"/>
-                <a:cs typeface="Courier New" pitchFamily="49" charset="0"/>
-              </a:rPr>
-              <a:t>Pt</a:t>
-            </a:r>
-            <a:r>
-              <a:rPr lang="it-IT" sz="1400" dirty="0">
-                <a:latin typeface="Courier New" pitchFamily="49" charset="0"/>
-                <a:cs typeface="Courier New" pitchFamily="49" charset="0"/>
-              </a:rPr>
-              <a:t>::</a:t>
-            </a:r>
-            <a:r>
-              <a:rPr lang="it-IT" sz="1400" dirty="0" err="1">
-                <a:latin typeface="Courier New" pitchFamily="49" charset="0"/>
-                <a:cs typeface="Courier New" pitchFamily="49" charset="0"/>
-              </a:rPr>
-              <a:t>SerializationInfo</a:t>
-            </a:r>
-            <a:r>
-              <a:rPr lang="it-IT" sz="1400" dirty="0">
-                <a:latin typeface="Courier New" pitchFamily="49" charset="0"/>
-                <a:cs typeface="Courier New" pitchFamily="49" charset="0"/>
-              </a:rPr>
-              <a:t>&amp; si, </a:t>
-            </a:r>
-            <a:r>
-              <a:rPr lang="it-IT" sz="1400" dirty="0" err="1">
-                <a:solidFill>
-                  <a:schemeClr val="accent2">
-                    <a:lumMod val="75000"/>
-                  </a:schemeClr>
-                </a:solidFill>
-                <a:latin typeface="Courier New" pitchFamily="49" charset="0"/>
-                <a:cs typeface="Courier New" pitchFamily="49" charset="0"/>
-              </a:rPr>
-              <a:t>const</a:t>
-            </a:r>
-            <a:r>
-              <a:rPr lang="it-IT" sz="1400" dirty="0">
-                <a:latin typeface="Courier New" pitchFamily="49" charset="0"/>
-                <a:cs typeface="Courier New" pitchFamily="49" charset="0"/>
-              </a:rPr>
-              <a:t> </a:t>
+              <a:rPr lang="de-DE" sz="1400" dirty="0">
+                <a:latin typeface="Courier New" pitchFamily="49" charset="0"/>
+                <a:cs typeface="Courier New" pitchFamily="49" charset="0"/>
+              </a:rPr>
+              <a:t>  </a:t>
             </a:r>
             <a:r>
               <a:rPr lang="de-DE" sz="1400" dirty="0" err="1">
                 <a:latin typeface="Courier New" pitchFamily="49" charset="0"/>
                 <a:cs typeface="Courier New" pitchFamily="49" charset="0"/>
               </a:rPr>
-              <a:t>PositionInfo</a:t>
-            </a:r>
-            <a:r>
-              <a:rPr lang="de-DE" sz="1400" dirty="0">
-                <a:latin typeface="Courier New" pitchFamily="49" charset="0"/>
-                <a:cs typeface="Courier New" pitchFamily="49" charset="0"/>
-              </a:rPr>
-              <a:t> </a:t>
-            </a:r>
-            <a:r>
-              <a:rPr lang="it-IT" sz="1400" dirty="0" smtClean="0">
-                <a:latin typeface="Courier New" pitchFamily="49" charset="0"/>
-                <a:cs typeface="Courier New" pitchFamily="49" charset="0"/>
-              </a:rPr>
-              <a:t>&amp; p)</a:t>
-            </a:r>
-            <a:endParaRPr lang="it-IT" sz="1400" dirty="0">
-              <a:latin typeface="Courier New" pitchFamily="49" charset="0"/>
-              <a:cs typeface="Courier New" pitchFamily="49" charset="0"/>
-            </a:endParaRPr>
-          </a:p>
-          <a:p>
-            <a:pPr marL="0" indent="0">
-              <a:buNone/>
-            </a:pPr>
-            <a:r>
-              <a:rPr lang="de-DE" sz="1400" dirty="0">
-                <a:latin typeface="Courier New" pitchFamily="49" charset="0"/>
-                <a:cs typeface="Courier New" pitchFamily="49" charset="0"/>
-              </a:rPr>
-              <a:t>{</a:t>
-            </a:r>
-          </a:p>
-          <a:p>
-            <a:pPr marL="0" indent="0">
-              <a:buNone/>
-            </a:pPr>
-            <a:r>
-              <a:rPr lang="de-DE" sz="1400" dirty="0">
-                <a:latin typeface="Courier New" pitchFamily="49" charset="0"/>
-                <a:cs typeface="Courier New" pitchFamily="49" charset="0"/>
-              </a:rPr>
-              <a:t>  </a:t>
-            </a:r>
-            <a:r>
-              <a:rPr lang="de-DE" sz="1400" dirty="0" err="1">
-                <a:latin typeface="Courier New" pitchFamily="49" charset="0"/>
-                <a:cs typeface="Courier New" pitchFamily="49" charset="0"/>
-              </a:rPr>
-              <a:t>si.setTypeName</a:t>
+              <a:t>si.addMember</a:t>
             </a:r>
             <a:r>
               <a:rPr lang="de-DE" sz="1400" dirty="0" smtClean="0">
@@ -23720,220 +24042,7 @@
                 <a:latin typeface="Courier New" pitchFamily="49" charset="0"/>
                 <a:cs typeface="Courier New" pitchFamily="49" charset="0"/>
               </a:rPr>
-              <a:t>„</a:t>
-            </a:r>
-            <a:r>
-              <a:rPr lang="de-DE" sz="1400" dirty="0" err="1" smtClean="0">
-                <a:solidFill>
-                  <a:schemeClr val="accent2">
-                    <a:lumMod val="75000"/>
-                  </a:schemeClr>
-                </a:solidFill>
-                <a:latin typeface="Courier New" pitchFamily="49" charset="0"/>
-                <a:cs typeface="Courier New" pitchFamily="49" charset="0"/>
-              </a:rPr>
-              <a:t>Position</a:t>
-            </a:r>
-            <a:r>
-              <a:rPr lang="de-DE" sz="1400" dirty="0" err="1" smtClean="0">
-                <a:solidFill>
-                  <a:schemeClr val="accent2">
-                    <a:lumMod val="75000"/>
-                  </a:schemeClr>
-                </a:solidFill>
-                <a:latin typeface="Courier New" pitchFamily="49" charset="0"/>
-                <a:cs typeface="Courier New" pitchFamily="49" charset="0"/>
-              </a:rPr>
-              <a:t>Info</a:t>
-            </a:r>
-            <a:r>
-              <a:rPr lang="de-DE" sz="1400" dirty="0">
-                <a:solidFill>
-                  <a:schemeClr val="accent2">
-                    <a:lumMod val="75000"/>
-                  </a:schemeClr>
-                </a:solidFill>
-                <a:latin typeface="Courier New" pitchFamily="49" charset="0"/>
-                <a:cs typeface="Courier New" pitchFamily="49" charset="0"/>
-              </a:rPr>
-              <a:t>"</a:t>
-            </a:r>
-            <a:r>
-              <a:rPr lang="de-DE" sz="1400" dirty="0">
-                <a:latin typeface="Courier New" pitchFamily="49" charset="0"/>
-                <a:cs typeface="Courier New" pitchFamily="49" charset="0"/>
-              </a:rPr>
-              <a:t>);</a:t>
-            </a:r>
-          </a:p>
-          <a:p>
-            <a:pPr marL="0" indent="0">
-              <a:buNone/>
-            </a:pPr>
-            <a:r>
-              <a:rPr lang="de-DE" sz="1400" dirty="0">
-                <a:latin typeface="Courier New" pitchFamily="49" charset="0"/>
-                <a:cs typeface="Courier New" pitchFamily="49" charset="0"/>
-              </a:rPr>
-              <a:t>  </a:t>
-            </a:r>
-            <a:r>
-              <a:rPr lang="de-DE" sz="1400" dirty="0" err="1">
-                <a:latin typeface="Courier New" pitchFamily="49" charset="0"/>
-                <a:cs typeface="Courier New" pitchFamily="49" charset="0"/>
-              </a:rPr>
-              <a:t>si.addMember</a:t>
-            </a:r>
-            <a:r>
-              <a:rPr lang="de-DE" sz="1400" dirty="0" smtClean="0">
-                <a:latin typeface="Courier New" pitchFamily="49" charset="0"/>
-                <a:cs typeface="Courier New" pitchFamily="49" charset="0"/>
-              </a:rPr>
-              <a:t>(</a:t>
-            </a:r>
-            <a:r>
-              <a:rPr lang="de-DE" sz="1400" dirty="0" smtClean="0">
-                <a:solidFill>
-                  <a:schemeClr val="accent2">
-                    <a:lumMod val="75000"/>
-                  </a:schemeClr>
-                </a:solidFill>
-                <a:latin typeface="Courier New" pitchFamily="49" charset="0"/>
-                <a:cs typeface="Courier New" pitchFamily="49" charset="0"/>
-              </a:rPr>
-              <a:t>„</a:t>
-            </a:r>
-            <a:r>
-              <a:rPr lang="de-DE" sz="1400" dirty="0" smtClean="0">
-                <a:solidFill>
-                  <a:schemeClr val="accent2">
-                    <a:lumMod val="75000"/>
-                  </a:schemeClr>
-                </a:solidFill>
-                <a:latin typeface="Courier New" pitchFamily="49" charset="0"/>
-                <a:cs typeface="Courier New" pitchFamily="49" charset="0"/>
-              </a:rPr>
-              <a:t>x</a:t>
-            </a:r>
-            <a:r>
-              <a:rPr lang="de-DE" sz="1400" dirty="0" smtClean="0">
-                <a:solidFill>
-                  <a:schemeClr val="accent2">
-                    <a:lumMod val="75000"/>
-                  </a:schemeClr>
-                </a:solidFill>
-                <a:latin typeface="Courier New" pitchFamily="49" charset="0"/>
-                <a:cs typeface="Courier New" pitchFamily="49" charset="0"/>
-              </a:rPr>
-              <a:t>"</a:t>
-            </a:r>
-            <a:r>
-              <a:rPr lang="de-DE" sz="1400" dirty="0" smtClean="0">
-                <a:latin typeface="Courier New" pitchFamily="49" charset="0"/>
-                <a:cs typeface="Courier New" pitchFamily="49" charset="0"/>
-              </a:rPr>
-              <a:t>) </a:t>
-            </a:r>
-            <a:r>
-              <a:rPr lang="de-DE" sz="1400" dirty="0">
-                <a:latin typeface="Courier New" pitchFamily="49" charset="0"/>
-                <a:cs typeface="Courier New" pitchFamily="49" charset="0"/>
-              </a:rPr>
-              <a:t>&lt;&lt;= </a:t>
-            </a:r>
-            <a:r>
-              <a:rPr lang="de-DE" sz="1400" dirty="0" err="1">
-                <a:latin typeface="Courier New" pitchFamily="49" charset="0"/>
-                <a:cs typeface="Courier New" pitchFamily="49" charset="0"/>
-              </a:rPr>
-              <a:t>p</a:t>
-            </a:r>
-            <a:r>
-              <a:rPr lang="de-DE" sz="1400" dirty="0" err="1" smtClean="0">
-                <a:latin typeface="Courier New" pitchFamily="49" charset="0"/>
-                <a:cs typeface="Courier New" pitchFamily="49" charset="0"/>
-              </a:rPr>
-              <a:t>._</a:t>
-            </a:r>
-            <a:r>
-              <a:rPr lang="de-DE" sz="1400" dirty="0" err="1">
-                <a:latin typeface="Courier New" pitchFamily="49" charset="0"/>
-                <a:cs typeface="Courier New" pitchFamily="49" charset="0"/>
-              </a:rPr>
-              <a:t>x</a:t>
-            </a:r>
-            <a:r>
-              <a:rPr lang="de-DE" sz="1400" dirty="0" smtClean="0">
-                <a:latin typeface="Courier New" pitchFamily="49" charset="0"/>
-                <a:cs typeface="Courier New" pitchFamily="49" charset="0"/>
-              </a:rPr>
-              <a:t>;</a:t>
-            </a:r>
-            <a:endParaRPr lang="de-DE" sz="1400" dirty="0">
-              <a:latin typeface="Courier New" pitchFamily="49" charset="0"/>
-              <a:cs typeface="Courier New" pitchFamily="49" charset="0"/>
-            </a:endParaRPr>
-          </a:p>
-          <a:p>
-            <a:pPr marL="0" indent="0">
-              <a:buNone/>
-            </a:pPr>
-            <a:r>
-              <a:rPr lang="de-DE" sz="1400" dirty="0">
-                <a:latin typeface="Courier New" pitchFamily="49" charset="0"/>
-                <a:cs typeface="Courier New" pitchFamily="49" charset="0"/>
-              </a:rPr>
-              <a:t>  </a:t>
-            </a:r>
-            <a:r>
-              <a:rPr lang="de-DE" sz="1400" dirty="0" err="1">
-                <a:latin typeface="Courier New" pitchFamily="49" charset="0"/>
-                <a:cs typeface="Courier New" pitchFamily="49" charset="0"/>
-              </a:rPr>
-              <a:t>si.addMember</a:t>
-            </a:r>
-            <a:r>
-              <a:rPr lang="de-DE" sz="1400" dirty="0" smtClean="0">
-                <a:latin typeface="Courier New" pitchFamily="49" charset="0"/>
-                <a:cs typeface="Courier New" pitchFamily="49" charset="0"/>
-              </a:rPr>
-              <a:t>(</a:t>
-            </a:r>
-            <a:r>
-              <a:rPr lang="de-DE" sz="1400" dirty="0" smtClean="0">
-                <a:solidFill>
-                  <a:schemeClr val="accent2">
-                    <a:lumMod val="75000"/>
-                  </a:schemeClr>
-                </a:solidFill>
-                <a:latin typeface="Courier New" pitchFamily="49" charset="0"/>
-                <a:cs typeface="Courier New" pitchFamily="49" charset="0"/>
-              </a:rPr>
-              <a:t>„</a:t>
-            </a:r>
-            <a:r>
-              <a:rPr lang="de-DE" sz="1400" dirty="0" smtClean="0">
-                <a:solidFill>
-                  <a:schemeClr val="accent2">
-                    <a:lumMod val="75000"/>
-                  </a:schemeClr>
-                </a:solidFill>
-                <a:latin typeface="Courier New" pitchFamily="49" charset="0"/>
-                <a:cs typeface="Courier New" pitchFamily="49" charset="0"/>
-              </a:rPr>
-              <a:t>y</a:t>
-            </a:r>
-            <a:r>
-              <a:rPr lang="de-DE" sz="1400" dirty="0" smtClean="0">
-                <a:solidFill>
-                  <a:schemeClr val="accent2">
-                    <a:lumMod val="75000"/>
-                  </a:schemeClr>
-                </a:solidFill>
-                <a:latin typeface="Courier New" pitchFamily="49" charset="0"/>
-                <a:cs typeface="Courier New" pitchFamily="49" charset="0"/>
-              </a:rPr>
-              <a:t>"</a:t>
+              <a:t>„y"</a:t>
             </a:r>
             <a:r>
               <a:rPr lang="de-DE" sz="1400" dirty="0" smtClean="0">
@@ -26191,10 +26300,61 @@
               <a:buNone/>
             </a:pPr>
             <a:r>
+              <a:rPr lang="de-DE" sz="1400" dirty="0">
+                <a:latin typeface="Courier New" pitchFamily="49" charset="0"/>
+                <a:cs typeface="Courier New" pitchFamily="49" charset="0"/>
+              </a:rPr>
+              <a:t> </a:t>
+            </a:r>
+            <a:r>
               <a:rPr lang="de-DE" sz="1400" dirty="0" smtClean="0">
                 <a:latin typeface="Courier New" pitchFamily="49" charset="0"/>
                 <a:cs typeface="Courier New" pitchFamily="49" charset="0"/>
               </a:rPr>
+              <a:t>   </a:t>
+            </a:r>
+            <a:r>
+              <a:rPr lang="de-DE" sz="1400" dirty="0" err="1" smtClean="0">
+                <a:latin typeface="Courier New" pitchFamily="49" charset="0"/>
+                <a:cs typeface="Courier New" pitchFamily="49" charset="0"/>
+              </a:rPr>
+              <a:t>timer.setActive</a:t>
+            </a:r>
+            <a:r>
+              <a:rPr lang="de-DE" sz="1400" dirty="0" smtClean="0">
+                <a:latin typeface="Courier New" pitchFamily="49" charset="0"/>
+                <a:cs typeface="Courier New" pitchFamily="49" charset="0"/>
+              </a:rPr>
+              <a:t>(</a:t>
+            </a:r>
+            <a:r>
+              <a:rPr lang="de-DE" sz="1400" dirty="0" err="1" smtClean="0">
+                <a:latin typeface="Courier New" pitchFamily="49" charset="0"/>
+                <a:cs typeface="Courier New" pitchFamily="49" charset="0"/>
+              </a:rPr>
+              <a:t>loop</a:t>
+            </a:r>
+            <a:r>
+              <a:rPr lang="de-DE" sz="1400" dirty="0" smtClean="0">
+                <a:latin typeface="Courier New" pitchFamily="49" charset="0"/>
+                <a:cs typeface="Courier New" pitchFamily="49" charset="0"/>
+              </a:rPr>
+              <a:t>);</a:t>
+            </a:r>
+            <a:endParaRPr lang="de-DE" sz="1400" dirty="0" smtClean="0">
+              <a:latin typeface="Courier New" pitchFamily="49" charset="0"/>
+              <a:cs typeface="Courier New" pitchFamily="49" charset="0"/>
+            </a:endParaRPr>
+          </a:p>
+          <a:p>
+            <a:pPr marL="0" indent="0">
+              <a:buNone/>
+            </a:pPr>
+            <a:r>
+              <a:rPr lang="de-DE" sz="1400" dirty="0" smtClean="0">
+                <a:latin typeface="Courier New" pitchFamily="49" charset="0"/>
+                <a:cs typeface="Courier New" pitchFamily="49" charset="0"/>
+              </a:rPr>
               <a:t>    </a:t>
             </a:r>
             <a:r>
@@ -26202,6 +26362,156 @@
                 <a:latin typeface="Courier New" pitchFamily="49" charset="0"/>
                 <a:cs typeface="Courier New" pitchFamily="49" charset="0"/>
               </a:rPr>
+              <a:t>timer.timeout</a:t>
+            </a:r>
+            <a:r>
+              <a:rPr lang="de-DE" sz="1400" dirty="0" smtClean="0">
+                <a:latin typeface="Courier New" pitchFamily="49" charset="0"/>
+                <a:cs typeface="Courier New" pitchFamily="49" charset="0"/>
+              </a:rPr>
+              <a:t>() += Pt::</a:t>
+            </a:r>
+            <a:r>
+              <a:rPr lang="de-DE" sz="1400" dirty="0" err="1" smtClean="0">
+                <a:latin typeface="Courier New" pitchFamily="49" charset="0"/>
+                <a:cs typeface="Courier New" pitchFamily="49" charset="0"/>
+              </a:rPr>
+              <a:t>slot</a:t>
+            </a:r>
+            <a:r>
+              <a:rPr lang="de-DE" sz="1400" dirty="0" smtClean="0">
+                <a:latin typeface="Courier New" pitchFamily="49" charset="0"/>
+                <a:cs typeface="Courier New" pitchFamily="49" charset="0"/>
+              </a:rPr>
+              <a:t>(&amp;</a:t>
+            </a:r>
+            <a:r>
+              <a:rPr lang="de-DE" sz="1400" dirty="0" err="1" smtClean="0">
+                <a:latin typeface="Courier New" pitchFamily="49" charset="0"/>
+                <a:cs typeface="Courier New" pitchFamily="49" charset="0"/>
+              </a:rPr>
+              <a:t>onTimeout</a:t>
+            </a:r>
+            <a:r>
+              <a:rPr lang="de-DE" sz="1400" dirty="0" smtClean="0">
+                <a:latin typeface="Courier New" pitchFamily="49" charset="0"/>
+                <a:cs typeface="Courier New" pitchFamily="49" charset="0"/>
+              </a:rPr>
+              <a:t>);</a:t>
+            </a:r>
+          </a:p>
+          <a:p>
+            <a:pPr marL="0" indent="0">
+              <a:buNone/>
+            </a:pPr>
+            <a:r>
+              <a:rPr lang="de-DE" sz="1400" dirty="0" smtClean="0">
+                <a:latin typeface="Courier New" pitchFamily="49" charset="0"/>
+                <a:cs typeface="Courier New" pitchFamily="49" charset="0"/>
+              </a:rPr>
+              <a:t>    </a:t>
+            </a:r>
+            <a:r>
+              <a:rPr lang="de-DE" sz="1400" dirty="0" err="1" smtClean="0">
+                <a:latin typeface="Courier New" pitchFamily="49" charset="0"/>
+                <a:cs typeface="Courier New" pitchFamily="49" charset="0"/>
+              </a:rPr>
+              <a:t>timer.timeout</a:t>
+            </a:r>
+            <a:r>
+              <a:rPr lang="de-DE" sz="1400" dirty="0" smtClean="0">
+                <a:latin typeface="Courier New" pitchFamily="49" charset="0"/>
+                <a:cs typeface="Courier New" pitchFamily="49" charset="0"/>
+              </a:rPr>
+              <a:t>() </a:t>
+            </a:r>
+            <a:r>
+              <a:rPr lang="de-DE" sz="1400" dirty="0" smtClean="0">
+                <a:latin typeface="Courier New" pitchFamily="49" charset="0"/>
+                <a:cs typeface="Courier New" pitchFamily="49" charset="0"/>
+              </a:rPr>
+              <a:t>+= Pt::</a:t>
+            </a:r>
+            <a:r>
+              <a:rPr lang="de-DE" sz="1400" dirty="0" err="1" smtClean="0">
+                <a:latin typeface="Courier New" pitchFamily="49" charset="0"/>
+                <a:cs typeface="Courier New" pitchFamily="49" charset="0"/>
+              </a:rPr>
+              <a:t>slot</a:t>
+            </a:r>
+            <a:r>
+              <a:rPr lang="de-DE" sz="1400" dirty="0" smtClean="0">
+                <a:latin typeface="Courier New" pitchFamily="49" charset="0"/>
+                <a:cs typeface="Courier New" pitchFamily="49" charset="0"/>
+              </a:rPr>
+              <a:t>(</a:t>
+            </a:r>
+            <a:r>
+              <a:rPr lang="de-DE" sz="1400" dirty="0" err="1" smtClean="0">
+                <a:latin typeface="Courier New" pitchFamily="49" charset="0"/>
+                <a:cs typeface="Courier New" pitchFamily="49" charset="0"/>
+              </a:rPr>
+              <a:t>loop</a:t>
+            </a:r>
+            <a:r>
+              <a:rPr lang="de-DE" sz="1400" dirty="0" smtClean="0">
+                <a:latin typeface="Courier New" pitchFamily="49" charset="0"/>
+                <a:cs typeface="Courier New" pitchFamily="49" charset="0"/>
+              </a:rPr>
+              <a:t>, &amp;</a:t>
+            </a:r>
+            <a:r>
+              <a:rPr lang="de-DE" sz="1400" dirty="0" err="1" smtClean="0">
+                <a:latin typeface="Courier New" pitchFamily="49" charset="0"/>
+                <a:cs typeface="Courier New" pitchFamily="49" charset="0"/>
+              </a:rPr>
+              <a:t>MainLoop</a:t>
+            </a:r>
+            <a:r>
+              <a:rPr lang="de-DE" sz="1400" dirty="0" smtClean="0">
+                <a:latin typeface="Courier New" pitchFamily="49" charset="0"/>
+                <a:cs typeface="Courier New" pitchFamily="49" charset="0"/>
+              </a:rPr>
+              <a:t>::</a:t>
+            </a:r>
+            <a:r>
+              <a:rPr lang="de-DE" sz="1400" dirty="0" err="1" smtClean="0">
+                <a:latin typeface="Courier New" pitchFamily="49" charset="0"/>
+                <a:cs typeface="Courier New" pitchFamily="49" charset="0"/>
+              </a:rPr>
+              <a:t>exit</a:t>
+            </a:r>
+            <a:r>
+              <a:rPr lang="de-DE" sz="1400" dirty="0" smtClean="0">
+                <a:latin typeface="Courier New" pitchFamily="49" charset="0"/>
+                <a:cs typeface="Courier New" pitchFamily="49" charset="0"/>
+              </a:rPr>
+              <a:t>);</a:t>
+            </a:r>
+          </a:p>
+          <a:p>
+            <a:pPr marL="0" indent="0">
+              <a:buNone/>
+            </a:pPr>
+            <a:r>
+              <a:rPr lang="de-DE" sz="1400" dirty="0">
+                <a:latin typeface="Courier New" pitchFamily="49" charset="0"/>
+                <a:cs typeface="Courier New" pitchFamily="49" charset="0"/>
+              </a:rPr>
+              <a:t> </a:t>
+            </a:r>
+            <a:r>
+              <a:rPr lang="de-DE" sz="1400" dirty="0" smtClean="0">
+                <a:latin typeface="Courier New" pitchFamily="49" charset="0"/>
+                <a:cs typeface="Courier New" pitchFamily="49" charset="0"/>
+              </a:rPr>
+              <a:t>   </a:t>
+            </a:r>
+            <a:r>
+              <a:rPr lang="de-DE" sz="1400" dirty="0" err="1" smtClean="0">
+                <a:latin typeface="Courier New" pitchFamily="49" charset="0"/>
+                <a:cs typeface="Courier New" pitchFamily="49" charset="0"/>
+              </a:rPr>
               <a:t>timer.start</a:t>
             </a:r>
             <a:r>
@@ -26209,144 +26519,19 @@
                 <a:latin typeface="Courier New" pitchFamily="49" charset="0"/>
                 <a:cs typeface="Courier New" pitchFamily="49" charset="0"/>
               </a:rPr>
-              <a:t>(5000);</a:t>
-            </a:r>
-          </a:p>
-          <a:p>
-            <a:pPr marL="0" indent="0">
-              <a:buNone/>
-            </a:pPr>
-            <a:r>
-              <a:rPr lang="de-DE" sz="1400" dirty="0" smtClean="0">
-                <a:latin typeface="Courier New" pitchFamily="49" charset="0"/>
-                <a:cs typeface="Courier New" pitchFamily="49" charset="0"/>
-              </a:rPr>
-              <a:t>    </a:t>
-            </a:r>
-            <a:r>
-              <a:rPr lang="de-DE" sz="1400" dirty="0" err="1" smtClean="0">
-                <a:latin typeface="Courier New" pitchFamily="49" charset="0"/>
-                <a:cs typeface="Courier New" pitchFamily="49" charset="0"/>
-              </a:rPr>
-              <a:t>timer.timeout</a:t>
-            </a:r>
-            <a:r>
-              <a:rPr lang="de-DE" sz="1400" dirty="0" smtClean="0">
-                <a:latin typeface="Courier New" pitchFamily="49" charset="0"/>
-                <a:cs typeface="Courier New" pitchFamily="49" charset="0"/>
-              </a:rPr>
-              <a:t> += Pt::</a:t>
-            </a:r>
-            <a:r>
-              <a:rPr lang="de-DE" sz="1400" dirty="0" err="1" smtClean="0">
-                <a:latin typeface="Courier New" pitchFamily="49" charset="0"/>
-                <a:cs typeface="Courier New" pitchFamily="49" charset="0"/>
-              </a:rPr>
-              <a:t>slot</a:t>
-            </a:r>
-            <a:r>
-              <a:rPr lang="de-DE" sz="1400" dirty="0" smtClean="0">
-                <a:latin typeface="Courier New" pitchFamily="49" charset="0"/>
-                <a:cs typeface="Courier New" pitchFamily="49" charset="0"/>
-              </a:rPr>
-              <a:t>(&amp;</a:t>
-            </a:r>
-            <a:r>
-              <a:rPr lang="de-DE" sz="1400" dirty="0" err="1" smtClean="0">
-                <a:latin typeface="Courier New" pitchFamily="49" charset="0"/>
-                <a:cs typeface="Courier New" pitchFamily="49" charset="0"/>
-              </a:rPr>
-              <a:t>onTimeout</a:t>
-            </a:r>
-            <a:r>
-              <a:rPr lang="de-DE" sz="1400" dirty="0" smtClean="0">
+              <a:t>(5000</a:t>
+            </a:r>
+            <a:r>
+              <a:rPr lang="de-DE" sz="1400" dirty="0">
                 <a:latin typeface="Courier New" pitchFamily="49" charset="0"/>
                 <a:cs typeface="Courier New" pitchFamily="49" charset="0"/>
               </a:rPr>
               <a:t>);</a:t>
             </a:r>
-          </a:p>
-          <a:p>
-            <a:pPr marL="0" indent="0">
-              <a:buNone/>
-            </a:pPr>
-            <a:r>
-              <a:rPr lang="de-DE" sz="1400" dirty="0" smtClean="0">
-                <a:latin typeface="Courier New" pitchFamily="49" charset="0"/>
-                <a:cs typeface="Courier New" pitchFamily="49" charset="0"/>
-              </a:rPr>
-              <a:t>    </a:t>
-            </a:r>
-            <a:r>
-              <a:rPr lang="de-DE" sz="1400" dirty="0" err="1" smtClean="0">
-                <a:latin typeface="Courier New" pitchFamily="49" charset="0"/>
-                <a:cs typeface="Courier New" pitchFamily="49" charset="0"/>
-              </a:rPr>
-              <a:t>timer.timeout</a:t>
-            </a:r>
-            <a:r>
-              <a:rPr lang="de-DE" sz="1400" dirty="0" smtClean="0">
-                <a:latin typeface="Courier New" pitchFamily="49" charset="0"/>
-                <a:cs typeface="Courier New" pitchFamily="49" charset="0"/>
-              </a:rPr>
-              <a:t> += Pt::</a:t>
-            </a:r>
-            <a:r>
-              <a:rPr lang="de-DE" sz="1400" dirty="0" err="1" smtClean="0">
-                <a:latin typeface="Courier New" pitchFamily="49" charset="0"/>
-                <a:cs typeface="Courier New" pitchFamily="49" charset="0"/>
-              </a:rPr>
-              <a:t>slot</a:t>
-            </a:r>
-            <a:r>
-              <a:rPr lang="de-DE" sz="1400" dirty="0" smtClean="0">
-                <a:latin typeface="Courier New" pitchFamily="49" charset="0"/>
-                <a:cs typeface="Courier New" pitchFamily="49" charset="0"/>
-              </a:rPr>
-              <a:t>(</a:t>
-            </a:r>
-            <a:r>
-              <a:rPr lang="de-DE" sz="1400" dirty="0" err="1" smtClean="0">
-                <a:latin typeface="Courier New" pitchFamily="49" charset="0"/>
-                <a:cs typeface="Courier New" pitchFamily="49" charset="0"/>
-              </a:rPr>
-              <a:t>loop</a:t>
-            </a:r>
-            <a:r>
-              <a:rPr lang="de-DE" sz="1400" dirty="0" smtClean="0">
-                <a:latin typeface="Courier New" pitchFamily="49" charset="0"/>
-                <a:cs typeface="Courier New" pitchFamily="49" charset="0"/>
-              </a:rPr>
-              <a:t>, &amp;</a:t>
-            </a:r>
-            <a:r>
-              <a:rPr lang="de-DE" sz="1400" dirty="0" err="1" smtClean="0">
-                <a:latin typeface="Courier New" pitchFamily="49" charset="0"/>
-                <a:cs typeface="Courier New" pitchFamily="49" charset="0"/>
-              </a:rPr>
-              <a:t>MainLoop</a:t>
-            </a:r>
-            <a:r>
-              <a:rPr lang="de-DE" sz="1400" dirty="0" smtClean="0">
-                <a:latin typeface="Courier New" pitchFamily="49" charset="0"/>
-                <a:cs typeface="Courier New" pitchFamily="49" charset="0"/>
-              </a:rPr>
-              <a:t>::</a:t>
-            </a:r>
-            <a:r>
-              <a:rPr lang="de-DE" sz="1400" dirty="0" err="1" smtClean="0">
-                <a:latin typeface="Courier New" pitchFamily="49" charset="0"/>
-                <a:cs typeface="Courier New" pitchFamily="49" charset="0"/>
-              </a:rPr>
-              <a:t>exit</a:t>
-            </a:r>
-            <a:r>
-              <a:rPr lang="de-DE" sz="1400" dirty="0" smtClean="0">
-                <a:latin typeface="Courier New" pitchFamily="49" charset="0"/>
-                <a:cs typeface="Courier New" pitchFamily="49" charset="0"/>
-              </a:rPr>
-              <a:t>);</a:t>
-            </a:r>
+            <a:endParaRPr lang="de-DE" sz="1400" dirty="0" smtClean="0">
+              <a:latin typeface="Courier New" pitchFamily="49" charset="0"/>
+              <a:cs typeface="Courier New" pitchFamily="49" charset="0"/>
+            </a:endParaRPr>
           </a:p>
           <a:p>
             <a:pPr marL="0" indent="0">
@@ -26356,46 +26541,6 @@
               <a:latin typeface="Courier New" pitchFamily="49" charset="0"/>
               <a:cs typeface="Courier New" pitchFamily="49" charset="0"/>
             </a:endParaRPr>
-          </a:p>
-          <a:p>
-            <a:pPr marL="0" indent="0">
-              <a:buNone/>
-            </a:pPr>
-            <a:r>
-              <a:rPr lang="de-DE" sz="1400" dirty="0" smtClean="0">
-                <a:latin typeface="Courier New" pitchFamily="49" charset="0"/>
-                <a:cs typeface="Courier New" pitchFamily="49" charset="0"/>
-              </a:rPr>
-              <a:t>    </a:t>
-            </a:r>
-            <a:r>
-              <a:rPr lang="de-DE" sz="1400" dirty="0" err="1" smtClean="0">
-                <a:latin typeface="Courier New" pitchFamily="49" charset="0"/>
-                <a:cs typeface="Courier New" pitchFamily="49" charset="0"/>
-              </a:rPr>
-              <a:t>loop.add</a:t>
-            </a:r>
-            <a:r>
-              <a:rPr lang="de-DE" sz="1400" dirty="0" smtClean="0">
-                <a:latin typeface="Courier New" pitchFamily="49" charset="0"/>
-                <a:cs typeface="Courier New" pitchFamily="49" charset="0"/>
-              </a:rPr>
-              <a:t>(</a:t>
-            </a:r>
-            <a:r>
-              <a:rPr lang="de-DE" sz="1400" dirty="0" err="1" smtClean="0">
-                <a:latin typeface="Courier New" pitchFamily="49" charset="0"/>
-                <a:cs typeface="Courier New" pitchFamily="49" charset="0"/>
-              </a:rPr>
-              <a:t>timer</a:t>
-            </a:r>
-            <a:r>
-              <a:rPr lang="de-DE" sz="1400" dirty="0" smtClean="0">
-                <a:latin typeface="Courier New" pitchFamily="49" charset="0"/>
-                <a:cs typeface="Courier New" pitchFamily="49" charset="0"/>
-              </a:rPr>
-              <a:t>);</a:t>
-            </a:r>
           </a:p>
           <a:p>
             <a:pPr marL="0" indent="0">
@@ -28756,7 +28901,7 @@
               <a:rPr lang="de-DE" sz="1300" dirty="0" err="1" smtClean="0">
                 <a:cs typeface="Courier New" pitchFamily="49" charset="0"/>
               </a:rPr>
-              <a:t>cancelable</a:t>
+              <a:t>cancellable</a:t>
             </a:r>
             <a:endParaRPr lang="de-DE" sz="1300" dirty="0" smtClean="0">
               <a:cs typeface="Courier New" pitchFamily="49" charset="0"/>
@@ -29875,13 +30020,43 @@
                 <a:latin typeface="Courier New" pitchFamily="49" charset="0"/>
                 <a:cs typeface="Courier New" pitchFamily="49" charset="0"/>
               </a:rPr>
-              <a:t>::System::Pipe pipe(Pt::System::Pipe::Async);</a:t>
+              <a:t>::System::Pipe </a:t>
+            </a:r>
+            <a:r>
+              <a:rPr lang="nb-NO" sz="1700" dirty="0" smtClean="0">
+                <a:latin typeface="Courier New" pitchFamily="49" charset="0"/>
+                <a:cs typeface="Courier New" pitchFamily="49" charset="0"/>
+              </a:rPr>
+              <a:t>pipe;</a:t>
             </a:r>
           </a:p>
           <a:p>
             <a:pPr marL="0" indent="0">
               <a:buNone/>
             </a:pPr>
+            <a:endParaRPr lang="nb-NO" sz="1700" dirty="0">
+              <a:latin typeface="Courier New" pitchFamily="49" charset="0"/>
+              <a:cs typeface="Courier New" pitchFamily="49" charset="0"/>
+            </a:endParaRPr>
+          </a:p>
+          <a:p>
+            <a:pPr marL="0" indent="0">
+              <a:buNone/>
+            </a:pPr>
+            <a:r>
+              <a:rPr lang="nb-NO" sz="1700" dirty="0">
+                <a:latin typeface="Courier New" pitchFamily="49" charset="0"/>
+                <a:cs typeface="Courier New" pitchFamily="49" charset="0"/>
+              </a:rPr>
+              <a:t> </a:t>
+            </a:r>
+            <a:r>
+              <a:rPr lang="nb-NO" sz="1700" dirty="0" smtClean="0">
+                <a:latin typeface="Courier New" pitchFamily="49" charset="0"/>
+                <a:cs typeface="Courier New" pitchFamily="49" charset="0"/>
+              </a:rPr>
+              <a:t>   pipe.in().setActive(loop);</a:t>
+            </a:r>
             <a:endParaRPr lang="de-DE" sz="1700" dirty="0" smtClean="0">
               <a:latin typeface="Courier New" pitchFamily="49" charset="0"/>
               <a:cs typeface="Courier New" pitchFamily="49" charset="0"/>
@@ -29958,140 +30133,58 @@
               <a:t>().</a:t>
             </a:r>
             <a:r>
-              <a:rPr lang="en-US" sz="1700" dirty="0" err="1">
+              <a:rPr lang="en-US" sz="1700" dirty="0" err="1" smtClean="0">
                 <a:latin typeface="Courier New" pitchFamily="49" charset="0"/>
                 <a:cs typeface="Courier New" pitchFamily="49" charset="0"/>
               </a:rPr>
               <a:t>outputReady</a:t>
             </a:r>
             <a:r>
+              <a:rPr lang="en-US" sz="1700" dirty="0" smtClean="0">
+                <a:latin typeface="Courier New" pitchFamily="49" charset="0"/>
+                <a:cs typeface="Courier New" pitchFamily="49" charset="0"/>
+              </a:rPr>
+              <a:t>() </a:t>
+            </a:r>
+            <a:r>
               <a:rPr lang="en-US" sz="1700" dirty="0">
                 <a:latin typeface="Courier New" pitchFamily="49" charset="0"/>
                 <a:cs typeface="Courier New" pitchFamily="49" charset="0"/>
               </a:rPr>
-              <a:t> += </a:t>
-            </a:r>
-            <a:r>
-              <a:rPr lang="en-US" sz="1700" dirty="0" err="1">
-                <a:latin typeface="Courier New" pitchFamily="49" charset="0"/>
-                <a:cs typeface="Courier New" pitchFamily="49" charset="0"/>
-              </a:rPr>
-              <a:t>Pt</a:t>
+              <a:t>+= Pt::slot</a:t>
+            </a:r>
+            <a:r>
+              <a:rPr lang="en-US" sz="1700" dirty="0" smtClean="0">
+                <a:latin typeface="Courier New" pitchFamily="49" charset="0"/>
+                <a:cs typeface="Courier New" pitchFamily="49" charset="0"/>
+              </a:rPr>
+              <a:t>(&amp;</a:t>
+            </a:r>
+            <a:r>
+              <a:rPr lang="en-US" sz="1700" dirty="0" err="1" smtClean="0">
+                <a:latin typeface="Courier New" pitchFamily="49" charset="0"/>
+                <a:cs typeface="Courier New" pitchFamily="49" charset="0"/>
+              </a:rPr>
+              <a:t>onWrite</a:t>
             </a:r>
             <a:r>
               <a:rPr lang="en-US" sz="1700" dirty="0">
                 <a:latin typeface="Courier New" pitchFamily="49" charset="0"/>
                 <a:cs typeface="Courier New" pitchFamily="49" charset="0"/>
               </a:rPr>
-              <a:t>::slot</a:t>
-            </a:r>
+              <a:t>);</a:t>
+            </a:r>
+          </a:p>
+          <a:p>
+            <a:pPr marL="0" indent="0">
+              <a:buNone/>
+            </a:pPr>
             <a:r>
               <a:rPr lang="en-US" sz="1700" dirty="0" smtClean="0">
                 <a:latin typeface="Courier New" pitchFamily="49" charset="0"/>
                 <a:cs typeface="Courier New" pitchFamily="49" charset="0"/>
               </a:rPr>
-              <a:t>(&amp;</a:t>
-            </a:r>
-            <a:r>
-              <a:rPr lang="en-US" sz="1700" dirty="0" err="1" smtClean="0">
-                <a:latin typeface="Courier New" pitchFamily="49" charset="0"/>
-                <a:cs typeface="Courier New" pitchFamily="49" charset="0"/>
-              </a:rPr>
-              <a:t>onWrite</a:t>
-            </a:r>
-            <a:r>
-              <a:rPr lang="en-US" sz="1700" dirty="0">
-                <a:latin typeface="Courier New" pitchFamily="49" charset="0"/>
-                <a:cs typeface="Courier New" pitchFamily="49" charset="0"/>
-              </a:rPr>
-              <a:t>);</a:t>
-            </a:r>
-          </a:p>
-          <a:p>
-            <a:pPr marL="0" indent="0">
-              <a:buNone/>
-            </a:pPr>
-            <a:r>
-              <a:rPr lang="en-US" sz="1700" dirty="0" smtClean="0">
-                <a:latin typeface="Courier New" pitchFamily="49" charset="0"/>
-                <a:cs typeface="Courier New" pitchFamily="49" charset="0"/>
-              </a:rPr>
               <a:t>	</a:t>
-            </a:r>
-          </a:p>
-          <a:p>
-            <a:pPr marL="0" indent="0">
-              <a:buNone/>
-            </a:pPr>
-            <a:r>
-              <a:rPr lang="en-US" sz="1700" dirty="0" smtClean="0">
-                <a:latin typeface="Courier New" pitchFamily="49" charset="0"/>
-                <a:cs typeface="Courier New" pitchFamily="49" charset="0"/>
-              </a:rPr>
-              <a:t>    </a:t>
-            </a:r>
-            <a:r>
-              <a:rPr lang="en-US" sz="1700" dirty="0" err="1" smtClean="0">
-                <a:latin typeface="Courier New" pitchFamily="49" charset="0"/>
-                <a:cs typeface="Courier New" pitchFamily="49" charset="0"/>
-              </a:rPr>
-              <a:t>pipe.out</a:t>
-            </a:r>
-            <a:r>
-              <a:rPr lang="en-US" sz="1700" dirty="0">
-                <a:latin typeface="Courier New" pitchFamily="49" charset="0"/>
-                <a:cs typeface="Courier New" pitchFamily="49" charset="0"/>
-              </a:rPr>
-              <a:t>().</a:t>
-            </a:r>
-            <a:r>
-              <a:rPr lang="en-US" sz="1700" dirty="0" err="1">
-                <a:latin typeface="Courier New" pitchFamily="49" charset="0"/>
-                <a:cs typeface="Courier New" pitchFamily="49" charset="0"/>
-              </a:rPr>
-              <a:t>beginRead</a:t>
-            </a:r>
-            <a:r>
-              <a:rPr lang="en-US" sz="1700" dirty="0">
-                <a:latin typeface="Courier New" pitchFamily="49" charset="0"/>
-                <a:cs typeface="Courier New" pitchFamily="49" charset="0"/>
-              </a:rPr>
-              <a:t>( </a:t>
-            </a:r>
-            <a:r>
-              <a:rPr lang="en-US" sz="1700" dirty="0" smtClean="0">
-                <a:latin typeface="Courier New" pitchFamily="49" charset="0"/>
-                <a:cs typeface="Courier New" pitchFamily="49" charset="0"/>
-              </a:rPr>
-              <a:t>buffer</a:t>
-            </a:r>
-            <a:r>
-              <a:rPr lang="en-US" sz="1700" dirty="0">
-                <a:latin typeface="Courier New" pitchFamily="49" charset="0"/>
-                <a:cs typeface="Courier New" pitchFamily="49" charset="0"/>
-              </a:rPr>
-              <a:t>, </a:t>
-            </a:r>
-            <a:r>
-              <a:rPr lang="en-US" sz="1700" b="1" dirty="0" err="1" smtClean="0">
-                <a:latin typeface="Courier New" pitchFamily="49" charset="0"/>
-                <a:cs typeface="Courier New" pitchFamily="49" charset="0"/>
-              </a:rPr>
-              <a:t>sizeof</a:t>
-            </a:r>
-            <a:r>
-              <a:rPr lang="en-US" sz="1700" dirty="0" smtClean="0">
-                <a:latin typeface="Courier New" pitchFamily="49" charset="0"/>
-                <a:cs typeface="Courier New" pitchFamily="49" charset="0"/>
-              </a:rPr>
-              <a:t>(buffer</a:t>
-            </a:r>
-            <a:r>
-              <a:rPr lang="en-US" sz="1700" dirty="0">
-                <a:latin typeface="Courier New" pitchFamily="49" charset="0"/>
-                <a:cs typeface="Courier New" pitchFamily="49" charset="0"/>
-              </a:rPr>
-              <a:t>) ); </a:t>
             </a:r>
             <a:endParaRPr lang="en-US" sz="1700" dirty="0" smtClean="0">
               <a:latin typeface="Courier New" pitchFamily="49" charset="0"/>
@@ -30103,6 +30196,71 @@
               <a:buNone/>
             </a:pPr>
             <a:r>
+              <a:rPr lang="de-DE" sz="1700" dirty="0">
+                <a:latin typeface="Courier New" pitchFamily="49" charset="0"/>
+                <a:cs typeface="Courier New" pitchFamily="49" charset="0"/>
+              </a:rPr>
+              <a:t> </a:t>
+            </a:r>
+            <a:r>
+              <a:rPr lang="de-DE" sz="1700" dirty="0" smtClean="0">
+                <a:latin typeface="Courier New" pitchFamily="49" charset="0"/>
+                <a:cs typeface="Courier New" pitchFamily="49" charset="0"/>
+              </a:rPr>
+              <a:t>   </a:t>
+            </a:r>
+            <a:r>
+              <a:rPr lang="de-DE" sz="1700" dirty="0" err="1" smtClean="0">
+                <a:latin typeface="Courier New" pitchFamily="49" charset="0"/>
+                <a:cs typeface="Courier New" pitchFamily="49" charset="0"/>
+              </a:rPr>
+              <a:t>pipe.out</a:t>
+            </a:r>
+            <a:r>
+              <a:rPr lang="de-DE" sz="1700" dirty="0" smtClean="0">
+                <a:latin typeface="Courier New" pitchFamily="49" charset="0"/>
+                <a:cs typeface="Courier New" pitchFamily="49" charset="0"/>
+              </a:rPr>
+              <a:t>().</a:t>
+            </a:r>
+            <a:r>
+              <a:rPr lang="de-DE" sz="1700" dirty="0" err="1" smtClean="0">
+                <a:latin typeface="Courier New" pitchFamily="49" charset="0"/>
+                <a:cs typeface="Courier New" pitchFamily="49" charset="0"/>
+              </a:rPr>
+              <a:t>setActive</a:t>
+            </a:r>
+            <a:r>
+              <a:rPr lang="de-DE" sz="1700" dirty="0" smtClean="0">
+                <a:latin typeface="Courier New" pitchFamily="49" charset="0"/>
+                <a:cs typeface="Courier New" pitchFamily="49" charset="0"/>
+              </a:rPr>
+              <a:t>(</a:t>
+            </a:r>
+            <a:r>
+              <a:rPr lang="de-DE" sz="1700" dirty="0" err="1" smtClean="0">
+                <a:latin typeface="Courier New" pitchFamily="49" charset="0"/>
+                <a:cs typeface="Courier New" pitchFamily="49" charset="0"/>
+              </a:rPr>
+              <a:t>loop</a:t>
+            </a:r>
+            <a:r>
+              <a:rPr lang="de-DE" sz="1700" dirty="0" smtClean="0">
+                <a:latin typeface="Courier New" pitchFamily="49" charset="0"/>
+                <a:cs typeface="Courier New" pitchFamily="49" charset="0"/>
+              </a:rPr>
+              <a:t>);</a:t>
+            </a:r>
+            <a:endParaRPr lang="en-US" sz="1700" dirty="0" smtClean="0">
+              <a:latin typeface="Courier New" pitchFamily="49" charset="0"/>
+              <a:cs typeface="Courier New" pitchFamily="49" charset="0"/>
+            </a:endParaRPr>
+          </a:p>
+          <a:p>
+            <a:pPr marL="0" indent="0">
+              <a:buNone/>
+            </a:pPr>
+            <a:r>
               <a:rPr lang="en-US" sz="1700" dirty="0" smtClean="0">
                 <a:latin typeface="Courier New" pitchFamily="49" charset="0"/>
                 <a:cs typeface="Courier New" pitchFamily="49" charset="0"/>
@@ -30128,28 +30286,100 @@
                 <a:latin typeface="Courier New" pitchFamily="49" charset="0"/>
                 <a:cs typeface="Courier New" pitchFamily="49" charset="0"/>
               </a:rPr>
+              <a:t>beginRead</a:t>
+            </a:r>
+            <a:r>
+              <a:rPr lang="en-US" sz="1700" dirty="0">
+                <a:latin typeface="Courier New" pitchFamily="49" charset="0"/>
+                <a:cs typeface="Courier New" pitchFamily="49" charset="0"/>
+              </a:rPr>
+              <a:t>( </a:t>
+            </a:r>
+            <a:r>
+              <a:rPr lang="en-US" sz="1700" dirty="0" smtClean="0">
+                <a:latin typeface="Courier New" pitchFamily="49" charset="0"/>
+                <a:cs typeface="Courier New" pitchFamily="49" charset="0"/>
+              </a:rPr>
+              <a:t>buffer</a:t>
+            </a:r>
+            <a:r>
+              <a:rPr lang="en-US" sz="1700" dirty="0">
+                <a:latin typeface="Courier New" pitchFamily="49" charset="0"/>
+                <a:cs typeface="Courier New" pitchFamily="49" charset="0"/>
+              </a:rPr>
+              <a:t>, </a:t>
+            </a:r>
+            <a:r>
+              <a:rPr lang="en-US" sz="1700" b="1" dirty="0" err="1" smtClean="0">
+                <a:latin typeface="Courier New" pitchFamily="49" charset="0"/>
+                <a:cs typeface="Courier New" pitchFamily="49" charset="0"/>
+              </a:rPr>
+              <a:t>sizeof</a:t>
+            </a:r>
+            <a:r>
+              <a:rPr lang="en-US" sz="1700" dirty="0" smtClean="0">
+                <a:latin typeface="Courier New" pitchFamily="49" charset="0"/>
+                <a:cs typeface="Courier New" pitchFamily="49" charset="0"/>
+              </a:rPr>
+              <a:t>(buffer</a:t>
+            </a:r>
+            <a:r>
+              <a:rPr lang="en-US" sz="1700" dirty="0">
+                <a:latin typeface="Courier New" pitchFamily="49" charset="0"/>
+                <a:cs typeface="Courier New" pitchFamily="49" charset="0"/>
+              </a:rPr>
+              <a:t>) ); </a:t>
+            </a:r>
+            <a:endParaRPr lang="en-US" sz="1700" dirty="0" smtClean="0">
+              <a:latin typeface="Courier New" pitchFamily="49" charset="0"/>
+              <a:cs typeface="Courier New" pitchFamily="49" charset="0"/>
+            </a:endParaRPr>
+          </a:p>
+          <a:p>
+            <a:pPr marL="0" indent="0">
+              <a:buNone/>
+            </a:pPr>
+            <a:r>
+              <a:rPr lang="en-US" sz="1700" dirty="0" smtClean="0">
+                <a:latin typeface="Courier New" pitchFamily="49" charset="0"/>
+                <a:cs typeface="Courier New" pitchFamily="49" charset="0"/>
+              </a:rPr>
+              <a:t>    </a:t>
+            </a:r>
+            <a:r>
+              <a:rPr lang="en-US" sz="1700" dirty="0" err="1" smtClean="0">
+                <a:latin typeface="Courier New" pitchFamily="49" charset="0"/>
+                <a:cs typeface="Courier New" pitchFamily="49" charset="0"/>
+              </a:rPr>
+              <a:t>pipe.out</a:t>
+            </a:r>
+            <a:r>
+              <a:rPr lang="en-US" sz="1700" dirty="0">
+                <a:latin typeface="Courier New" pitchFamily="49" charset="0"/>
+                <a:cs typeface="Courier New" pitchFamily="49" charset="0"/>
+              </a:rPr>
+              <a:t>().</a:t>
+            </a:r>
+            <a:r>
+              <a:rPr lang="en-US" sz="1700" dirty="0" err="1" smtClean="0">
+                <a:latin typeface="Courier New" pitchFamily="49" charset="0"/>
+                <a:cs typeface="Courier New" pitchFamily="49" charset="0"/>
+              </a:rPr>
               <a:t>inputReady</a:t>
             </a:r>
             <a:r>
+              <a:rPr lang="en-US" sz="1700" dirty="0" smtClean="0">
+                <a:latin typeface="Courier New" pitchFamily="49" charset="0"/>
+                <a:cs typeface="Courier New" pitchFamily="49" charset="0"/>
+              </a:rPr>
+              <a:t>() </a:t>
+            </a:r>
+            <a:r>
               <a:rPr lang="en-US" sz="1700" dirty="0">
                 <a:latin typeface="Courier New" pitchFamily="49" charset="0"/>
                 <a:cs typeface="Courier New" pitchFamily="49" charset="0"/>
               </a:rPr>
-              <a:t> += </a:t>
-            </a:r>
-            <a:r>
-              <a:rPr lang="en-US" sz="1700" dirty="0" err="1">
-                <a:latin typeface="Courier New" pitchFamily="49" charset="0"/>
-                <a:cs typeface="Courier New" pitchFamily="49" charset="0"/>
-              </a:rPr>
-              <a:t>Pt</a:t>
-            </a:r>
-            <a:r>
-              <a:rPr lang="en-US" sz="1700" dirty="0">
-                <a:latin typeface="Courier New" pitchFamily="49" charset="0"/>
-                <a:cs typeface="Courier New" pitchFamily="49" charset="0"/>
-              </a:rPr>
-              <a:t>::</a:t>
+              <a:t>+= Pt::</a:t>
             </a:r>
             <a:r>
               <a:rPr lang="en-US" sz="1700" dirty="0" smtClean="0">
@@ -30181,72 +30411,6 @@
               <a:latin typeface="Courier New" pitchFamily="49" charset="0"/>
               <a:cs typeface="Courier New" pitchFamily="49" charset="0"/>
             </a:endParaRPr>
-          </a:p>
-          <a:p>
-            <a:pPr marL="0" indent="0">
-              <a:buNone/>
-            </a:pPr>
-            <a:r>
-              <a:rPr lang="de-DE" sz="1700" dirty="0" smtClean="0">
-                <a:latin typeface="Courier New" pitchFamily="49" charset="0"/>
-                <a:cs typeface="Courier New" pitchFamily="49" charset="0"/>
-              </a:rPr>
-              <a:t>    </a:t>
-            </a:r>
-            <a:r>
-              <a:rPr lang="de-DE" sz="1700" dirty="0" err="1" smtClean="0">
-                <a:latin typeface="Courier New" pitchFamily="49" charset="0"/>
-                <a:cs typeface="Courier New" pitchFamily="49" charset="0"/>
-              </a:rPr>
-              <a:t>loop.add</a:t>
-            </a:r>
-            <a:r>
-              <a:rPr lang="de-DE" sz="1700" dirty="0" smtClean="0">
-                <a:latin typeface="Courier New" pitchFamily="49" charset="0"/>
-                <a:cs typeface="Courier New" pitchFamily="49" charset="0"/>
-              </a:rPr>
-              <a:t>(</a:t>
-            </a:r>
-            <a:r>
-              <a:rPr lang="de-DE" sz="1700" dirty="0" err="1" smtClean="0">
-                <a:latin typeface="Courier New" pitchFamily="49" charset="0"/>
-                <a:cs typeface="Courier New" pitchFamily="49" charset="0"/>
-              </a:rPr>
-              <a:t>pipe.out</a:t>
-            </a:r>
-            <a:r>
-              <a:rPr lang="de-DE" sz="1700" dirty="0" smtClean="0">
-                <a:latin typeface="Courier New" pitchFamily="49" charset="0"/>
-                <a:cs typeface="Courier New" pitchFamily="49" charset="0"/>
-              </a:rPr>
-              <a:t>());</a:t>
-            </a:r>
-          </a:p>
-          <a:p>
-            <a:pPr marL="0" indent="0">
-              <a:buNone/>
-            </a:pPr>
-            <a:r>
-              <a:rPr lang="de-DE" sz="1700" dirty="0" smtClean="0">
-                <a:latin typeface="Courier New" pitchFamily="49" charset="0"/>
-                <a:cs typeface="Courier New" pitchFamily="49" charset="0"/>
-              </a:rPr>
-              <a:t>    </a:t>
-            </a:r>
-            <a:r>
-              <a:rPr lang="de-DE" sz="1700" dirty="0" err="1" smtClean="0">
-                <a:latin typeface="Courier New" pitchFamily="49" charset="0"/>
-                <a:cs typeface="Courier New" pitchFamily="49" charset="0"/>
-              </a:rPr>
-              <a:t>loop.add</a:t>
-            </a:r>
-            <a:r>
-              <a:rPr lang="de-DE" sz="1700" dirty="0" smtClean="0">
-                <a:latin typeface="Courier New" pitchFamily="49" charset="0"/>
-                <a:cs typeface="Courier New" pitchFamily="49" charset="0"/>
-              </a:rPr>
-              <a:t>(pipe.in())</a:t>
-            </a:r>
           </a:p>
           <a:p>
             <a:pPr marL="0" indent="0">
@@ -31885,25 +32049,32 @@
               <a:t>(</a:t>
             </a:r>
             <a:r>
+              <a:rPr lang="en-US" sz="1300" dirty="0" smtClean="0">
+                <a:latin typeface="Courier New" pitchFamily="49" charset="0"/>
+                <a:cs typeface="Courier New" pitchFamily="49" charset="0"/>
+              </a:rPr>
+              <a:t>Pt::System</a:t>
+            </a:r>
+            <a:r>
+              <a:rPr lang="en-US" sz="1300" dirty="0" smtClean="0">
+                <a:latin typeface="Courier New" pitchFamily="49" charset="0"/>
+                <a:cs typeface="Courier New" pitchFamily="49" charset="0"/>
+              </a:rPr>
+              <a:t>::</a:t>
+            </a:r>
+            <a:r>
               <a:rPr lang="en-US" sz="1300" dirty="0" err="1" smtClean="0">
                 <a:latin typeface="Courier New" pitchFamily="49" charset="0"/>
                 <a:cs typeface="Courier New" pitchFamily="49" charset="0"/>
               </a:rPr>
-              <a:t>Pt</a:t>
-            </a:r>
-            <a:r>
-              <a:rPr lang="en-US" sz="1300" dirty="0" smtClean="0">
-                <a:latin typeface="Courier New" pitchFamily="49" charset="0"/>
-                <a:cs typeface="Courier New" pitchFamily="49" charset="0"/>
-              </a:rPr>
-              <a:t>::System::</a:t>
+              <a:t>IO</a:t>
             </a:r>
             <a:r>
               <a:rPr lang="en-US" sz="1300" dirty="0" err="1" smtClean="0">
                 <a:latin typeface="Courier New" pitchFamily="49" charset="0"/>
                 <a:cs typeface="Courier New" pitchFamily="49" charset="0"/>
               </a:rPr>
-              <a:t>StreamBuffer</a:t>
+              <a:t>Buffer</a:t>
             </a:r>
             <a:r>
               <a:rPr lang="en-US" sz="1300" dirty="0" smtClean="0">
@@ -32433,15 +32604,86 @@
                 <a:latin typeface="Courier New" pitchFamily="49" charset="0"/>
                 <a:cs typeface="Courier New" pitchFamily="49" charset="0"/>
               </a:rPr>
-              <a:t>::System::Pipe pipe(Pt::System::Pipe::Async</a:t>
+              <a:t>::System::Pipe </a:t>
             </a:r>
             <a:r>
               <a:rPr lang="nb-NO" sz="1300" dirty="0" smtClean="0">
                 <a:latin typeface="Courier New" pitchFamily="49" charset="0"/>
                 <a:cs typeface="Courier New" pitchFamily="49" charset="0"/>
               </a:rPr>
+              <a:t>pipe;</a:t>
+            </a:r>
+            <a:endParaRPr lang="nb-NO" sz="1300" dirty="0" smtClean="0">
+              <a:latin typeface="Courier New" pitchFamily="49" charset="0"/>
+              <a:cs typeface="Courier New" pitchFamily="49" charset="0"/>
+            </a:endParaRPr>
+          </a:p>
+          <a:p>
+            <a:pPr marL="0" indent="0">
+              <a:buNone/>
+            </a:pPr>
+            <a:r>
+              <a:rPr lang="en-US" sz="1300" dirty="0" smtClean="0">
+                <a:latin typeface="Courier New" pitchFamily="49" charset="0"/>
+                <a:cs typeface="Courier New" pitchFamily="49" charset="0"/>
+              </a:rPr>
+              <a:t>	</a:t>
+            </a:r>
+            <a:endParaRPr lang="en-US" sz="1300" dirty="0" smtClean="0">
+              <a:latin typeface="Courier New" pitchFamily="49" charset="0"/>
+              <a:cs typeface="Courier New" pitchFamily="49" charset="0"/>
+            </a:endParaRPr>
+          </a:p>
+          <a:p>
+            <a:pPr marL="0" indent="0">
+              <a:buNone/>
+            </a:pPr>
+            <a:r>
+              <a:rPr lang="de-DE" sz="1300" dirty="0">
+                <a:latin typeface="Courier New" pitchFamily="49" charset="0"/>
+                <a:cs typeface="Courier New" pitchFamily="49" charset="0"/>
+              </a:rPr>
+              <a:t> </a:t>
+            </a:r>
+            <a:r>
+              <a:rPr lang="de-DE" sz="1300" dirty="0" smtClean="0">
+                <a:latin typeface="Courier New" pitchFamily="49" charset="0"/>
+                <a:cs typeface="Courier New" pitchFamily="49" charset="0"/>
+              </a:rPr>
+              <a:t>   pipe.in().</a:t>
+            </a:r>
+            <a:r>
+              <a:rPr lang="de-DE" sz="1300" dirty="0" err="1" smtClean="0">
+                <a:latin typeface="Courier New" pitchFamily="49" charset="0"/>
+                <a:cs typeface="Courier New" pitchFamily="49" charset="0"/>
+              </a:rPr>
+              <a:t>setActive</a:t>
+            </a:r>
+            <a:r>
+              <a:rPr lang="de-DE" sz="1300" dirty="0" smtClean="0">
+                <a:latin typeface="Courier New" pitchFamily="49" charset="0"/>
+                <a:cs typeface="Courier New" pitchFamily="49" charset="0"/>
+              </a:rPr>
+              <a:t>(</a:t>
+            </a:r>
+            <a:r>
+              <a:rPr lang="de-DE" sz="1300" dirty="0" err="1" smtClean="0">
+                <a:latin typeface="Courier New" pitchFamily="49" charset="0"/>
+                <a:cs typeface="Courier New" pitchFamily="49" charset="0"/>
+              </a:rPr>
+              <a:t>loop</a:t>
+            </a:r>
+            <a:r>
+              <a:rPr lang="de-DE" sz="1300" dirty="0" smtClean="0">
+                <a:latin typeface="Courier New" pitchFamily="49" charset="0"/>
+                <a:cs typeface="Courier New" pitchFamily="49" charset="0"/>
+              </a:rPr>
               <a:t>);</a:t>
             </a:r>
+            <a:endParaRPr lang="en-US" sz="1300" dirty="0" smtClean="0">
+              <a:latin typeface="Courier New" pitchFamily="49" charset="0"/>
+              <a:cs typeface="Courier New" pitchFamily="49" charset="0"/>
+            </a:endParaRPr>
           </a:p>
           <a:p>
             <a:pPr marL="0" indent="0">
@@ -32452,7 +32694,56 @@
                 <a:latin typeface="Courier New" pitchFamily="49" charset="0"/>
                 <a:cs typeface="Courier New" pitchFamily="49" charset="0"/>
               </a:rPr>
-              <a:t>	</a:t>
+              <a:t>    Pt</a:t>
+            </a:r>
+            <a:r>
+              <a:rPr lang="en-US" sz="1300" dirty="0">
+                <a:latin typeface="Courier New" pitchFamily="49" charset="0"/>
+                <a:cs typeface="Courier New" pitchFamily="49" charset="0"/>
+              </a:rPr>
+              <a:t>::System</a:t>
+            </a:r>
+            <a:r>
+              <a:rPr lang="en-US" sz="1300" dirty="0" smtClean="0">
+                <a:latin typeface="Courier New" pitchFamily="49" charset="0"/>
+                <a:cs typeface="Courier New" pitchFamily="49" charset="0"/>
+              </a:rPr>
+              <a:t>::</a:t>
+            </a:r>
+            <a:r>
+              <a:rPr lang="en-US" sz="1300" dirty="0" err="1" smtClean="0">
+                <a:latin typeface="Courier New" pitchFamily="49" charset="0"/>
+                <a:cs typeface="Courier New" pitchFamily="49" charset="0"/>
+              </a:rPr>
+              <a:t>IO</a:t>
+            </a:r>
+            <a:r>
+              <a:rPr lang="en-US" sz="1300" dirty="0" err="1" smtClean="0">
+                <a:latin typeface="Courier New" pitchFamily="49" charset="0"/>
+                <a:cs typeface="Courier New" pitchFamily="49" charset="0"/>
+              </a:rPr>
+              <a:t>Buffer</a:t>
+            </a:r>
+            <a:r>
+              <a:rPr lang="en-US" sz="1300" dirty="0" smtClean="0">
+                <a:latin typeface="Courier New" pitchFamily="49" charset="0"/>
+                <a:cs typeface="Courier New" pitchFamily="49" charset="0"/>
+              </a:rPr>
+              <a:t> </a:t>
+            </a:r>
+            <a:r>
+              <a:rPr lang="en-US" sz="1300" dirty="0" err="1" smtClean="0">
+                <a:latin typeface="Courier New" pitchFamily="49" charset="0"/>
+                <a:cs typeface="Courier New" pitchFamily="49" charset="0"/>
+              </a:rPr>
+              <a:t>sb</a:t>
+            </a:r>
+            <a:r>
+              <a:rPr lang="en-US" sz="1300" dirty="0" smtClean="0">
+                <a:latin typeface="Courier New" pitchFamily="49" charset="0"/>
+                <a:cs typeface="Courier New" pitchFamily="49" charset="0"/>
+              </a:rPr>
+              <a:t>(pipe.in());</a:t>
             </a:r>
           </a:p>
           <a:p>
@@ -32460,74 +32751,13 @@
               <a:buNone/>
             </a:pPr>
             <a:r>
-              <a:rPr lang="en-US" sz="1300" dirty="0" smtClean="0">
+              <a:rPr lang="de-DE" sz="1300" dirty="0" smtClean="0">
                 <a:latin typeface="Courier New" pitchFamily="49" charset="0"/>
                 <a:cs typeface="Courier New" pitchFamily="49" charset="0"/>
               </a:rPr>
               <a:t>    </a:t>
             </a:r>
             <a:r>
-              <a:rPr lang="en-US" sz="1300" dirty="0" err="1" smtClean="0">
-                <a:latin typeface="Courier New" pitchFamily="49" charset="0"/>
-                <a:cs typeface="Courier New" pitchFamily="49" charset="0"/>
-              </a:rPr>
-              <a:t>Pt</a:t>
-            </a:r>
-            <a:r>
-              <a:rPr lang="en-US" sz="1300" dirty="0">
-                <a:latin typeface="Courier New" pitchFamily="49" charset="0"/>
-                <a:cs typeface="Courier New" pitchFamily="49" charset="0"/>
-              </a:rPr>
-              <a:t>::System</a:t>
-            </a:r>
-            <a:r>
-              <a:rPr lang="en-US" sz="1300" dirty="0" smtClean="0">
-                <a:latin typeface="Courier New" pitchFamily="49" charset="0"/>
-                <a:cs typeface="Courier New" pitchFamily="49" charset="0"/>
-              </a:rPr>
-              <a:t>::</a:t>
-            </a:r>
-            <a:r>
-              <a:rPr lang="en-US" sz="1300" dirty="0" err="1" smtClean="0">
-                <a:latin typeface="Courier New" pitchFamily="49" charset="0"/>
-                <a:cs typeface="Courier New" pitchFamily="49" charset="0"/>
-              </a:rPr>
-              <a:t>StreamBuffer</a:t>
-            </a:r>
-            <a:r>
-              <a:rPr lang="en-US" sz="1300" dirty="0" smtClean="0">
-                <a:latin typeface="Courier New" pitchFamily="49" charset="0"/>
-                <a:cs typeface="Courier New" pitchFamily="49" charset="0"/>
-              </a:rPr>
-              <a:t> </a:t>
-            </a:r>
-            <a:r>
-              <a:rPr lang="en-US" sz="1300" dirty="0" err="1" smtClean="0">
-                <a:latin typeface="Courier New" pitchFamily="49" charset="0"/>
-                <a:cs typeface="Courier New" pitchFamily="49" charset="0"/>
-              </a:rPr>
-              <a:t>sb</a:t>
-            </a:r>
-            <a:r>
-              <a:rPr lang="en-US" sz="1300" dirty="0" smtClean="0">
-                <a:latin typeface="Courier New" pitchFamily="49" charset="0"/>
-                <a:cs typeface="Courier New" pitchFamily="49" charset="0"/>
-              </a:rPr>
-              <a:t>(pipe.in());</a:t>
-            </a:r>
-          </a:p>
-          <a:p>
-            <a:pPr marL="0" indent="0">
-              <a:buNone/>
-            </a:pPr>
-            <a:r>
-              <a:rPr lang="de-DE" sz="1300" dirty="0" smtClean="0">
-                <a:latin typeface="Courier New" pitchFamily="49" charset="0"/>
-                <a:cs typeface="Courier New" pitchFamily="49" charset="0"/>
-              </a:rPr>
-              <a:t>    </a:t>
-            </a:r>
-            <a:r>
               <a:rPr lang="de-DE" sz="1300" dirty="0" err="1" smtClean="0">
                 <a:latin typeface="Courier New" pitchFamily="49" charset="0"/>
                 <a:cs typeface="Courier New" pitchFamily="49" charset="0"/>
@@ -32539,7 +32769,14 @@
                 <a:latin typeface="Courier New" pitchFamily="49" charset="0"/>
                 <a:cs typeface="Courier New" pitchFamily="49" charset="0"/>
               </a:rPr>
-              <a:t> += Pt::</a:t>
+              <a:t>() </a:t>
+            </a:r>
+            <a:r>
+              <a:rPr lang="de-DE" sz="1300" dirty="0" smtClean="0">
+                <a:latin typeface="Courier New" pitchFamily="49" charset="0"/>
+                <a:cs typeface="Courier New" pitchFamily="49" charset="0"/>
+              </a:rPr>
+              <a:t>+= Pt::</a:t>
             </a:r>
             <a:r>
               <a:rPr lang="de-DE" sz="1300" dirty="0" err="1" smtClean="0">
@@ -32810,32 +33047,6 @@
               <a:latin typeface="Courier New" pitchFamily="49" charset="0"/>
               <a:cs typeface="Courier New" pitchFamily="49" charset="0"/>
             </a:endParaRPr>
-          </a:p>
-          <a:p>
-            <a:pPr marL="0" indent="0">
-              <a:buNone/>
-            </a:pPr>
-            <a:r>
-              <a:rPr lang="de-DE" sz="1300" dirty="0" smtClean="0">
-                <a:latin typeface="Courier New" pitchFamily="49" charset="0"/>
-                <a:cs typeface="Courier New" pitchFamily="49" charset="0"/>
-              </a:rPr>
-              <a:t>    </a:t>
-            </a:r>
-            <a:r>
-              <a:rPr lang="de-DE" sz="1300" dirty="0" err="1" smtClean="0">
-                <a:latin typeface="Courier New" pitchFamily="49" charset="0"/>
-                <a:cs typeface="Courier New" pitchFamily="49" charset="0"/>
-              </a:rPr>
-              <a:t>loop.add</a:t>
-            </a:r>
-            <a:r>
-              <a:rPr lang="de-DE" sz="1300" dirty="0" smtClean="0">
-                <a:latin typeface="Courier New" pitchFamily="49" charset="0"/>
-                <a:cs typeface="Courier New" pitchFamily="49" charset="0"/>
-              </a:rPr>
-              <a:t>(pipe.in());</a:t>
-            </a:r>
           </a:p>
           <a:p>
             <a:pPr marL="0" indent="0">

</xml_diff>